<commit_message>
Add four talk-track slides (Q3 results, Q4 focus, top of mind, lessons learned)
Co-Authored-By: Claude Sonnet 5.5 <noreply@anthropic.com>
Claude-Session: https://claude.ai/code/session_013DXsjPawU7xQxqcoPwwbM8
</commit_message>
<xml_diff>
--- a/Market Update/CCIG_Market_Update_Slides_CCIG-Brand.pptx
+++ b/Market Update/CCIG_Market_Update_Slides_CCIG-Brand.pptx
@@ -11,6 +11,10 @@
   <p:sldIdLst>
     <p:sldId id="333" r:id="rId9"/>
     <p:sldId id="336" r:id="rId21"/>
+    <p:sldId id="340" r:id="rId25"/>
+    <p:sldId id="339" r:id="rId24"/>
+    <p:sldId id="338" r:id="rId23"/>
+    <p:sldId id="337" r:id="rId22"/>
   </p:sldIdLst>
   <p:sldSz cx="12192000" cy="6858000"/>
   <p:notesSz cx="6858000" cy="9144000"/>
@@ -800,6 +804,286 @@
           <a:p>
             <a:r>
               <a:t>Employee benefits: pharmacy is now the dominant cost driver, but strategy and confidence have not caught up. Pharmacy exceeds 30% of total medical spend for some employers. 3 in 4 employers cite cost (specialty drugs, affordability, gene therapies) as their top pharmacy challenge. About 6 in 10 feel only neutral or unprepared. 43% are not sure when their pharmacy strategy was last reviewed. High-net-worth: capacity is improving, but carriers prioritize risk quality, loss prevention, and accurate property and exposure data over price. Catastrophe exposure, rebuilding cost inflation, and liability severity are core underwriting factors. Portfolio-level thinking separates strong placements from weak ones.</a:t>
+            </a:r>
+          </a:p>
+        </p:txBody>
+      </p:sp>
+      <p:sp>
+        <p:nvSpPr>
+          <p:cNvPr id="4" name="Slide Number Placeholder 3"/>
+          <p:cNvSpPr>
+            <a:spLocks noGrp="1"/>
+          </p:cNvSpPr>
+          <p:nvPr>
+            <p:ph type="sldNum" idx="5" sz="quarter"/>
+          </p:nvPr>
+        </p:nvSpPr>
+        <p:spPr/>
+      </p:sp>
+    </p:spTree>
+  </p:cSld>
+  <p:clrMapOvr>
+    <a:masterClrMapping/>
+  </p:clrMapOvr>
+</p:notes>
+</file>
+
+<file path=ppt/notesSlides/notesSlide3.xml><?xml version="1.0" encoding="utf-8"?>
+<p:notes xmlns:a="http://schemas.openxmlformats.org/drawingml/2006/main" xmlns:p="http://schemas.openxmlformats.org/presentationml/2006/main" xmlns:r="http://schemas.openxmlformats.org/officeDocument/2006/relationships">
+  <p:cSld>
+    <p:spTree>
+      <p:nvGrpSpPr>
+        <p:cNvPr id="1" name=""/>
+        <p:cNvGrpSpPr/>
+        <p:nvPr/>
+      </p:nvGrpSpPr>
+      <p:grpSpPr>
+        <a:xfrm>
+          <a:off x="0" y="0"/>
+          <a:ext cx="0" cy="0"/>
+          <a:chOff x="0" y="0"/>
+          <a:chExt cx="0" cy="0"/>
+        </a:xfrm>
+      </p:grpSpPr>
+      <p:sp>
+        <p:nvSpPr>
+          <p:cNvPr id="2" name="Slide Image Placeholder 1"/>
+          <p:cNvSpPr>
+            <a:spLocks noGrp="1"/>
+          </p:cNvSpPr>
+          <p:nvPr>
+            <p:ph type="sldImg" idx="2"/>
+          </p:nvPr>
+        </p:nvSpPr>
+        <p:spPr/>
+      </p:sp>
+      <p:sp>
+        <p:nvSpPr>
+          <p:cNvPr id="3" name="Notes Placeholder 2"/>
+          <p:cNvSpPr>
+            <a:spLocks noGrp="1"/>
+          </p:cNvSpPr>
+          <p:nvPr>
+            <p:ph type="body" idx="3" sz="quarter"/>
+          </p:nvPr>
+        </p:nvSpPr>
+        <p:spPr/>
+        <p:txBody>
+          <a:bodyPr/>
+          <a:lstStyle/>
+          <a:p>
+            <a:r>
+              <a:t>Our new business growth puts us in the top 10% of brokers in the country. That is an unusual level of success, and it reflects the talent, effort, and relationships across CCIG. That growth creates opportunity to invest in our people, advance careers, and build new capabilities. It also challenges us: our capacity, processes, and leadership have to keep developing to support it. We have promoted 24 people in the last 18 months, and nine of our 11 new employees were referred by someone inside CCIG. You are putting your credibility behind this company when you recommend that someone join us.</a:t>
+            </a:r>
+          </a:p>
+        </p:txBody>
+      </p:sp>
+      <p:sp>
+        <p:nvSpPr>
+          <p:cNvPr id="4" name="Slide Number Placeholder 3"/>
+          <p:cNvSpPr>
+            <a:spLocks noGrp="1"/>
+          </p:cNvSpPr>
+          <p:nvPr>
+            <p:ph type="sldNum" idx="5" sz="quarter"/>
+          </p:nvPr>
+        </p:nvSpPr>
+        <p:spPr/>
+      </p:sp>
+    </p:spTree>
+  </p:cSld>
+  <p:clrMapOvr>
+    <a:masterClrMapping/>
+  </p:clrMapOvr>
+</p:notes>
+</file>
+
+<file path=ppt/notesSlides/notesSlide4.xml><?xml version="1.0" encoding="utf-8"?>
+<p:notes xmlns:a="http://schemas.openxmlformats.org/drawingml/2006/main" xmlns:p="http://schemas.openxmlformats.org/presentationml/2006/main" xmlns:r="http://schemas.openxmlformats.org/officeDocument/2006/relationships">
+  <p:cSld>
+    <p:spTree>
+      <p:nvGrpSpPr>
+        <p:cNvPr id="1" name=""/>
+        <p:cNvGrpSpPr/>
+        <p:nvPr/>
+      </p:nvGrpSpPr>
+      <p:grpSpPr>
+        <a:xfrm>
+          <a:off x="0" y="0"/>
+          <a:ext cx="0" cy="0"/>
+          <a:chOff x="0" y="0"/>
+          <a:chExt cx="0" cy="0"/>
+        </a:xfrm>
+      </p:grpSpPr>
+      <p:sp>
+        <p:nvSpPr>
+          <p:cNvPr id="2" name="Slide Image Placeholder 1"/>
+          <p:cNvSpPr>
+            <a:spLocks noGrp="1"/>
+          </p:cNvSpPr>
+          <p:nvPr>
+            <p:ph type="sldImg" idx="2"/>
+          </p:nvPr>
+        </p:nvSpPr>
+        <p:spPr/>
+      </p:sp>
+      <p:sp>
+        <p:nvSpPr>
+          <p:cNvPr id="3" name="Notes Placeholder 2"/>
+          <p:cNvSpPr>
+            <a:spLocks noGrp="1"/>
+          </p:cNvSpPr>
+          <p:nvPr>
+            <p:ph type="body" idx="3" sz="quarter"/>
+          </p:nvPr>
+        </p:nvSpPr>
+        <p:spPr/>
+        <p:txBody>
+          <a:bodyPr/>
+          <a:lstStyle/>
+          <a:p>
+            <a:r>
+              <a:t>What should every coworker be focused on during Q4? Know what matters most in your role, own your commitments, and speak up about what is getting in the way. Our accountability chart clarifies what each person owns, who they can turn to, and how their work connects to the rest of the company. Use your L10 meetings to bring forward capacity concerns, difficult handoffs, recurring problems, and accounts that need attention; the value comes from solving the issue and making sure someone owns the next step. Use quarterly conversations to talk openly about performance, development, and the support you need. Retention also needs our focus: every coworker can contribute through responsiveness, follow-through, and raising concerns early.</a:t>
+            </a:r>
+          </a:p>
+        </p:txBody>
+      </p:sp>
+      <p:sp>
+        <p:nvSpPr>
+          <p:cNvPr id="4" name="Slide Number Placeholder 3"/>
+          <p:cNvSpPr>
+            <a:spLocks noGrp="1"/>
+          </p:cNvSpPr>
+          <p:nvPr>
+            <p:ph type="sldNum" idx="5" sz="quarter"/>
+          </p:nvPr>
+        </p:nvSpPr>
+        <p:spPr/>
+      </p:sp>
+    </p:spTree>
+  </p:cSld>
+  <p:clrMapOvr>
+    <a:masterClrMapping/>
+  </p:clrMapOvr>
+</p:notes>
+</file>
+
+<file path=ppt/notesSlides/notesSlide5.xml><?xml version="1.0" encoding="utf-8"?>
+<p:notes xmlns:a="http://schemas.openxmlformats.org/drawingml/2006/main" xmlns:p="http://schemas.openxmlformats.org/presentationml/2006/main" xmlns:r="http://schemas.openxmlformats.org/officeDocument/2006/relationships">
+  <p:cSld>
+    <p:spTree>
+      <p:nvGrpSpPr>
+        <p:cNvPr id="1" name=""/>
+        <p:cNvGrpSpPr/>
+        <p:nvPr/>
+      </p:nvGrpSpPr>
+      <p:grpSpPr>
+        <a:xfrm>
+          <a:off x="0" y="0"/>
+          <a:ext cx="0" cy="0"/>
+          <a:chOff x="0" y="0"/>
+          <a:chExt cx="0" cy="0"/>
+        </a:xfrm>
+      </p:grpSpPr>
+      <p:sp>
+        <p:nvSpPr>
+          <p:cNvPr id="2" name="Slide Image Placeholder 1"/>
+          <p:cNvSpPr>
+            <a:spLocks noGrp="1"/>
+          </p:cNvSpPr>
+          <p:nvPr>
+            <p:ph type="sldImg" idx="2"/>
+          </p:nvPr>
+        </p:nvSpPr>
+        <p:spPr/>
+      </p:sp>
+      <p:sp>
+        <p:nvSpPr>
+          <p:cNvPr id="3" name="Notes Placeholder 2"/>
+          <p:cNvSpPr>
+            <a:spLocks noGrp="1"/>
+          </p:cNvSpPr>
+          <p:nvPr>
+            <p:ph type="body" idx="3" sz="quarter"/>
+          </p:nvPr>
+        </p:nvSpPr>
+        <p:spPr/>
+        <p:txBody>
+          <a:bodyPr/>
+          <a:lstStyle/>
+          <a:p>
+            <a:r>
+              <a:t>What is top of mind right now? Managing a level of growth that very few brokers are experiencing. More clients bring more responsibility, more complexity, and more demand on our teams. We need to get ahead of capacity constraints, hire great people, build consistent processes, and use technology to help people spend more time on work that needs their expertise. Delegate and elevate is part of that. EOS helps us connect these priorities: Scorecards show where attention is needed, L10s help us understand and solve the underlying issues, and Rocks move the most important improvements forward. Retention remains a challenge, and we need to bring the same focus and accountability to keeping clients that we bring to winning them.</a:t>
+            </a:r>
+          </a:p>
+        </p:txBody>
+      </p:sp>
+      <p:sp>
+        <p:nvSpPr>
+          <p:cNvPr id="4" name="Slide Number Placeholder 3"/>
+          <p:cNvSpPr>
+            <a:spLocks noGrp="1"/>
+          </p:cNvSpPr>
+          <p:nvPr>
+            <p:ph type="sldNum" idx="5" sz="quarter"/>
+          </p:nvPr>
+        </p:nvSpPr>
+        <p:spPr/>
+      </p:sp>
+    </p:spTree>
+  </p:cSld>
+  <p:clrMapOvr>
+    <a:masterClrMapping/>
+  </p:clrMapOvr>
+</p:notes>
+</file>
+
+<file path=ppt/notesSlides/notesSlide6.xml><?xml version="1.0" encoding="utf-8"?>
+<p:notes xmlns:a="http://schemas.openxmlformats.org/drawingml/2006/main" xmlns:p="http://schemas.openxmlformats.org/presentationml/2006/main" xmlns:r="http://schemas.openxmlformats.org/officeDocument/2006/relationships">
+  <p:cSld>
+    <p:spTree>
+      <p:nvGrpSpPr>
+        <p:cNvPr id="1" name=""/>
+        <p:cNvGrpSpPr/>
+        <p:nvPr/>
+      </p:nvGrpSpPr>
+      <p:grpSpPr>
+        <a:xfrm>
+          <a:off x="0" y="0"/>
+          <a:ext cx="0" cy="0"/>
+          <a:chOff x="0" y="0"/>
+          <a:chExt cx="0" cy="0"/>
+        </a:xfrm>
+      </p:grpSpPr>
+      <p:sp>
+        <p:nvSpPr>
+          <p:cNvPr id="2" name="Slide Image Placeholder 1"/>
+          <p:cNvSpPr>
+            <a:spLocks noGrp="1"/>
+          </p:cNvSpPr>
+          <p:nvPr>
+            <p:ph type="sldImg" idx="2"/>
+          </p:nvPr>
+        </p:nvSpPr>
+        <p:spPr/>
+      </p:sp>
+      <p:sp>
+        <p:nvSpPr>
+          <p:cNvPr id="3" name="Notes Placeholder 2"/>
+          <p:cNvSpPr>
+            <a:spLocks noGrp="1"/>
+          </p:cNvSpPr>
+          <p:nvPr>
+            <p:ph type="body" idx="3" sz="quarter"/>
+          </p:nvPr>
+        </p:nvSpPr>
+        <p:spPr/>
+        <p:txBody>
+          <a:bodyPr/>
+          <a:lstStyle/>
+          <a:p>
+            <a:r>
+              <a:t>What was harder than expected? Building the capacity and structure to keep pace with exceptional growth while continuing to serve our existing clients well. Hiring is one step; getting someone trained, supported, and confident takes more work. Creating a process is one step; getting it consistently used takes more work. Finding a promising technology is one step; making it useful in someone's day takes more work. That work is especially challenging when teams already have full schedules. Retention is another area where we need to keep improving: understand why clients leave, identify patterns, and turn what we learn into changes that stick.</a:t>
             </a:r>
           </a:p>
         </p:txBody>
@@ -5299,6 +5583,4606 @@
                 <a:latin typeface="Source Sans Pro"/>
               </a:rPr>
               <a:t>What separates strong placements from weak ones.</a:t>
+            </a:r>
+          </a:p>
+        </p:txBody>
+      </p:sp>
+    </p:spTree>
+    <p:extLst>
+      <p:ext uri="{BB962C8B-B14F-4D97-AF65-F5344CB8AC3E}">
+        <p14:creationId xmlns:p14="http://schemas.microsoft.com/office/powerpoint/2010/main" val="3739547963"/>
+      </p:ext>
+    </p:extLst>
+  </p:cSld>
+  <p:clrMapOvr>
+    <a:masterClrMapping/>
+  </p:clrMapOvr>
+  <mc:AlternateContent xmlns:mc="http://schemas.openxmlformats.org/markup-compatibility/2006" xmlns:p159="http://schemas.microsoft.com/office/powerpoint/2015/09/main">
+    <mc:Choice Requires="p159">
+      <p:transition xmlns:p14="http://schemas.microsoft.com/office/powerpoint/2010/main" spd="slow" p14:dur="2000">
+        <p159:morph option="byObject"/>
+      </p:transition>
+    </mc:Choice>
+    <mc:Fallback xmlns="">
+      <p:transition spd="slow">
+        <p:fade/>
+      </p:transition>
+    </mc:Fallback>
+  </mc:AlternateContent>
+</p:sld>
+</file>
+
+<file path=ppt/slides/slide3.xml><?xml version="1.0" encoding="utf-8"?>
+<p:sld xmlns:a="http://schemas.openxmlformats.org/drawingml/2006/main" xmlns:r="http://schemas.openxmlformats.org/officeDocument/2006/relationships" xmlns:p="http://schemas.openxmlformats.org/presentationml/2006/main">
+  <p:cSld>
+    <p:spTree>
+      <p:nvGrpSpPr>
+        <p:cNvPr id="1" name="">
+          <a:extLst>
+            <a:ext uri="{FF2B5EF4-FFF2-40B4-BE49-F238E27FC236}">
+              <a16:creationId xmlns:a16="http://schemas.microsoft.com/office/drawing/2014/main" id="{3CC0E2FD-837D-9753-CF85-B96BB0ED339A}"/>
+            </a:ext>
+          </a:extLst>
+        </p:cNvPr>
+        <p:cNvGrpSpPr/>
+        <p:nvPr/>
+      </p:nvGrpSpPr>
+      <p:grpSpPr>
+        <a:xfrm>
+          <a:off x="0" y="0"/>
+          <a:ext cx="0" cy="0"/>
+          <a:chOff x="0" y="0"/>
+          <a:chExt cx="0" cy="0"/>
+        </a:xfrm>
+      </p:grpSpPr>
+      <p:sp>
+        <p:nvSpPr>
+          <p:cNvPr id="4" name="TextBox 3">
+            <a:extLst>
+              <a:ext uri="{FF2B5EF4-FFF2-40B4-BE49-F238E27FC236}">
+                <a16:creationId xmlns:a16="http://schemas.microsoft.com/office/drawing/2014/main" id="{D52C6772-D662-5D65-1798-38644B18B7E5}"/>
+              </a:ext>
+            </a:extLst>
+          </p:cNvPr>
+          <p:cNvSpPr txBox="1"/>
+          <p:nvPr/>
+        </p:nvSpPr>
+        <p:spPr>
+          <a:xfrm>
+            <a:off x="875347" y="368336"/>
+            <a:ext cx="10447973" cy="584775"/>
+          </a:xfrm>
+          <a:prstGeom prst="rect">
+            <a:avLst/>
+          </a:prstGeom>
+          <a:noFill/>
+        </p:spPr>
+        <p:txBody>
+          <a:bodyPr wrap="square" rtlCol="0">
+            <a:spAutoFit/>
+          </a:bodyPr>
+          <a:lstStyle/>
+          <a:p>
+            <a:pPr marL="0" marR="0" lvl="0" indent="0" algn="l" defTabSz="914400" rtl="0" eaLnBrk="1" fontAlgn="auto" latinLnBrk="0" hangingPunct="1">
+              <a:lnSpc>
+                <a:spcPct val="100000"/>
+              </a:lnSpc>
+              <a:spcBef>
+                <a:spcPts val="0"/>
+              </a:spcBef>
+              <a:spcAft>
+                <a:spcPts val="0"/>
+              </a:spcAft>
+              <a:buClrTx/>
+              <a:buSzTx/>
+              <a:buFontTx/>
+              <a:buNone/>
+              <a:tabLst/>
+              <a:defRPr/>
+            </a:pPr>
+            <a:r>
+              <a:rPr kumimoji="0" lang="en-US" sz="3200" b="1" i="1" u="none" strike="noStrike" kern="1200" cap="none" spc="0" normalizeH="0" baseline="0" noProof="0" dirty="0">
+                <a:ln>
+                  <a:noFill/>
+                </a:ln>
+                <a:solidFill>
+                  <a:srgbClr val="EDECED"/>
+                </a:solidFill>
+                <a:effectLst/>
+                <a:uLnTx/>
+                <a:uFillTx/>
+                <a:latin typeface="Playfair Display" panose="00000500000000000000" pitchFamily="2" charset="0"/>
+                <a:ea typeface="+mn-ea"/>
+                <a:cs typeface="+mn-cs"/>
+              </a:rPr>
+              <a:t>Top 10% in new business growth</a:t>
+            </a:r>
+          </a:p>
+        </p:txBody>
+      </p:sp>
+      <p:cxnSp>
+        <p:nvCxnSpPr>
+          <p:cNvPr id="6" name="Straight Connector 5">
+            <a:extLst>
+              <a:ext uri="{FF2B5EF4-FFF2-40B4-BE49-F238E27FC236}">
+                <a16:creationId xmlns:a16="http://schemas.microsoft.com/office/drawing/2014/main" id="{5E9116D3-F450-4A0A-4B24-450372B6DA92}"/>
+              </a:ext>
+            </a:extLst>
+          </p:cNvPr>
+          <p:cNvCxnSpPr>
+            <a:cxnSpLocks/>
+          </p:cNvCxnSpPr>
+          <p:nvPr/>
+        </p:nvCxnSpPr>
+        <p:spPr>
+          <a:xfrm>
+            <a:off x="963168" y="1060704"/>
+            <a:ext cx="10360152" cy="0"/>
+          </a:xfrm>
+          <a:prstGeom prst="line">
+            <a:avLst/>
+          </a:prstGeom>
+          <a:ln>
+            <a:solidFill>
+              <a:schemeClr val="accent3"/>
+            </a:solidFill>
+          </a:ln>
+        </p:spPr>
+        <p:style>
+          <a:lnRef idx="2">
+            <a:schemeClr val="accent3"/>
+          </a:lnRef>
+          <a:fillRef idx="0">
+            <a:schemeClr val="accent3"/>
+          </a:fillRef>
+          <a:effectRef idx="1">
+            <a:schemeClr val="accent3"/>
+          </a:effectRef>
+          <a:fontRef idx="minor">
+            <a:schemeClr val="tx1"/>
+          </a:fontRef>
+        </p:style>
+      </p:cxnSp>
+      <p:sp>
+        <p:nvSpPr>
+          <p:cNvPr id="7" name="Eyebrow"/>
+          <p:cNvSpPr txBox="1"/>
+          <p:nvPr/>
+        </p:nvSpPr>
+        <p:spPr>
+          <a:xfrm>
+            <a:off x="960120" y="1188720"/>
+            <a:ext cx="10360152" cy="228600"/>
+          </a:xfrm>
+          <a:prstGeom prst="rect">
+            <a:avLst/>
+          </a:prstGeom>
+          <a:noFill/>
+        </p:spPr>
+        <p:txBody>
+          <a:bodyPr wrap="square" lIns="0" rIns="0" tIns="0" bIns="0" anchor="t">
+            <a:spAutoFit/>
+          </a:bodyPr>
+          <a:lstStyle/>
+          <a:p>
+            <a:r>
+              <a:rPr sz="1200" b="1" i="0" spc="200">
+                <a:solidFill>
+                  <a:srgbClr val="8FB24E"/>
+                </a:solidFill>
+                <a:latin typeface="Source Sans Pro"/>
+              </a:rPr>
+              <a:t>Q3 2026 RESULTS</a:t>
+            </a:r>
+          </a:p>
+        </p:txBody>
+      </p:sp>
+      <p:sp>
+        <p:nvSpPr>
+          <p:cNvPr id="8" name="Subtitle"/>
+          <p:cNvSpPr txBox="1"/>
+          <p:nvPr/>
+        </p:nvSpPr>
+        <p:spPr>
+          <a:xfrm>
+            <a:off x="960120" y="1444752"/>
+            <a:ext cx="10360152" cy="320040"/>
+          </a:xfrm>
+          <a:prstGeom prst="rect">
+            <a:avLst/>
+          </a:prstGeom>
+          <a:noFill/>
+        </p:spPr>
+        <p:txBody>
+          <a:bodyPr wrap="square" lIns="0" rIns="0" tIns="0" bIns="0" anchor="t">
+            <a:spAutoFit/>
+          </a:bodyPr>
+          <a:lstStyle/>
+          <a:p>
+            <a:r>
+              <a:rPr sz="1600" b="0" i="0">
+                <a:solidFill>
+                  <a:srgbClr val="FFFFFF"/>
+                </a:solidFill>
+                <a:latin typeface="Source Sans Pro"/>
+              </a:rPr>
+              <a:t>Growth in revenue, new team members, and promotions. Now we turn it into a great company.</a:t>
+            </a:r>
+          </a:p>
+        </p:txBody>
+      </p:sp>
+      <p:sp>
+        <p:nvSpPr>
+          <p:cNvPr id="9" name="Top 10% card"/>
+          <p:cNvSpPr/>
+          <p:nvPr/>
+        </p:nvSpPr>
+        <p:spPr>
+          <a:xfrm>
+            <a:off x="960120" y="1965960"/>
+            <a:ext cx="4572000" cy="3017520"/>
+          </a:xfrm>
+          <a:prstGeom prst="roundRect">
+            <a:avLst>
+              <a:gd name="adj" fmla="val 8000"/>
+            </a:avLst>
+          </a:prstGeom>
+          <a:solidFill>
+            <a:srgbClr val="8FB24E"/>
+          </a:solidFill>
+          <a:ln>
+            <a:noFill/>
+          </a:ln>
+          <a:effectLst/>
+        </p:spPr>
+        <p:style>
+          <a:lnRef idx="1">
+            <a:schemeClr val="accent1"/>
+          </a:lnRef>
+          <a:fillRef idx="3">
+            <a:schemeClr val="accent1"/>
+          </a:fillRef>
+          <a:effectRef idx="2">
+            <a:schemeClr val="accent1"/>
+          </a:effectRef>
+          <a:fontRef idx="minor">
+            <a:schemeClr val="lt1"/>
+          </a:fontRef>
+        </p:style>
+        <p:txBody>
+          <a:bodyPr rtlCol="0" anchor="ctr"/>
+          <a:lstStyle/>
+          <a:p>
+            <a:pPr algn="ctr"/>
+          </a:p>
+        </p:txBody>
+      </p:sp>
+      <p:sp>
+        <p:nvSpPr>
+          <p:cNvPr id="10" name="Growth icon circle"/>
+          <p:cNvSpPr/>
+          <p:nvPr/>
+        </p:nvSpPr>
+        <p:spPr>
+          <a:xfrm>
+            <a:off x="1280160" y="2286000"/>
+            <a:ext cx="640080" cy="640080"/>
+          </a:xfrm>
+          <a:prstGeom prst="ellipse">
+            <a:avLst/>
+          </a:prstGeom>
+          <a:solidFill>
+            <a:srgbClr val="8FB24E"/>
+          </a:solidFill>
+          <a:ln>
+            <a:noFill/>
+          </a:ln>
+          <a:effectLst/>
+        </p:spPr>
+        <p:style>
+          <a:lnRef idx="1">
+            <a:schemeClr val="accent1"/>
+          </a:lnRef>
+          <a:fillRef idx="3">
+            <a:schemeClr val="accent1"/>
+          </a:fillRef>
+          <a:effectRef idx="2">
+            <a:schemeClr val="accent1"/>
+          </a:effectRef>
+          <a:fontRef idx="minor">
+            <a:schemeClr val="lt1"/>
+          </a:fontRef>
+        </p:style>
+        <p:txBody>
+          <a:bodyPr rtlCol="0" anchor="ctr"/>
+          <a:lstStyle/>
+          <a:p>
+            <a:pPr algn="ctr"/>
+          </a:p>
+        </p:txBody>
+      </p:sp>
+      <p:pic>
+        <p:nvPicPr>
+          <p:cNvPr id="11" name="Growth icon" descr="Growth icon"/>
+          <p:cNvPicPr>
+            <a:picLocks noChangeAspect="1"/>
+          </p:cNvPicPr>
+          <p:nvPr/>
+        </p:nvPicPr>
+        <p:blipFill>
+          <a:blip r:embed="rId2"/>
+          <a:stretch>
+            <a:fillRect/>
+          </a:stretch>
+        </p:blipFill>
+        <p:spPr>
+          <a:xfrm>
+            <a:off x="1433779" y="2439619"/>
+            <a:ext cx="332841" cy="332841"/>
+          </a:xfrm>
+          <a:prstGeom prst="rect">
+            <a:avLst/>
+          </a:prstGeom>
+        </p:spPr>
+      </p:pic>
+      <p:sp>
+        <p:nvSpPr>
+          <p:cNvPr id="12" name="Top 10% stat"/>
+          <p:cNvSpPr txBox="1"/>
+          <p:nvPr/>
+        </p:nvSpPr>
+        <p:spPr>
+          <a:xfrm>
+            <a:off x="1280160" y="3108960"/>
+            <a:ext cx="4023360" cy="1005840"/>
+          </a:xfrm>
+          <a:prstGeom prst="rect">
+            <a:avLst/>
+          </a:prstGeom>
+          <a:noFill/>
+        </p:spPr>
+        <p:txBody>
+          <a:bodyPr wrap="square" lIns="0" rIns="0" tIns="0" bIns="0" anchor="ctr">
+            <a:spAutoFit/>
+          </a:bodyPr>
+          <a:lstStyle/>
+          <a:p>
+            <a:r>
+              <a:rPr sz="5400" b="1" i="0">
+                <a:solidFill>
+                  <a:srgbClr val="153243"/>
+                </a:solidFill>
+                <a:latin typeface="Playfair Display"/>
+              </a:rPr>
+              <a:t>Top 10%</a:t>
+            </a:r>
+          </a:p>
+        </p:txBody>
+      </p:sp>
+      <p:sp>
+        <p:nvSpPr>
+          <p:cNvPr id="13" name="Top 10% label"/>
+          <p:cNvSpPr txBox="1"/>
+          <p:nvPr/>
+        </p:nvSpPr>
+        <p:spPr>
+          <a:xfrm>
+            <a:off x="1280160" y="4160520"/>
+            <a:ext cx="4023360" cy="640080"/>
+          </a:xfrm>
+          <a:prstGeom prst="rect">
+            <a:avLst/>
+          </a:prstGeom>
+          <a:noFill/>
+        </p:spPr>
+        <p:txBody>
+          <a:bodyPr wrap="square" lIns="0" rIns="0" tIns="0" bIns="0" anchor="t">
+            <a:spAutoFit/>
+          </a:bodyPr>
+          <a:lstStyle/>
+          <a:p>
+            <a:r>
+              <a:rPr sz="1300" b="1" i="0" spc="150">
+                <a:solidFill>
+                  <a:srgbClr val="153243"/>
+                </a:solidFill>
+                <a:latin typeface="Source Sans Pro"/>
+              </a:rPr>
+              <a:t>OF BROKERS IN THE COUNTRY FOR NEW BUSINESS GROWTH</a:t>
+            </a:r>
+          </a:p>
+        </p:txBody>
+      </p:sp>
+      <p:sp>
+        <p:nvSpPr>
+          <p:cNvPr id="14" name="Stat card 1"/>
+          <p:cNvSpPr/>
+          <p:nvPr/>
+        </p:nvSpPr>
+        <p:spPr>
+          <a:xfrm>
+            <a:off x="5852160" y="1965960"/>
+            <a:ext cx="5468112" cy="1417320"/>
+          </a:xfrm>
+          <a:prstGeom prst="roundRect">
+            <a:avLst>
+              <a:gd name="adj" fmla="val 5000"/>
+            </a:avLst>
+          </a:prstGeom>
+          <a:solidFill>
+            <a:srgbClr val="EDECED"/>
+          </a:solidFill>
+          <a:ln>
+            <a:noFill/>
+          </a:ln>
+          <a:effectLst/>
+        </p:spPr>
+        <p:style>
+          <a:lnRef idx="1">
+            <a:schemeClr val="accent1"/>
+          </a:lnRef>
+          <a:fillRef idx="3">
+            <a:schemeClr val="accent1"/>
+          </a:fillRef>
+          <a:effectRef idx="2">
+            <a:schemeClr val="accent1"/>
+          </a:effectRef>
+          <a:fontRef idx="minor">
+            <a:schemeClr val="lt1"/>
+          </a:fontRef>
+        </p:style>
+        <p:txBody>
+          <a:bodyPr rtlCol="0" anchor="ctr"/>
+          <a:lstStyle/>
+          <a:p>
+            <a:pPr algn="ctr"/>
+          </a:p>
+        </p:txBody>
+      </p:sp>
+      <p:sp>
+        <p:nvSpPr>
+          <p:cNvPr id="15" name="Stat icon 1 circle"/>
+          <p:cNvSpPr/>
+          <p:nvPr/>
+        </p:nvSpPr>
+        <p:spPr>
+          <a:xfrm>
+            <a:off x="6149340" y="2382011"/>
+            <a:ext cx="594360" cy="594360"/>
+          </a:xfrm>
+          <a:prstGeom prst="ellipse">
+            <a:avLst/>
+          </a:prstGeom>
+          <a:solidFill>
+            <a:srgbClr val="8FB24E"/>
+          </a:solidFill>
+          <a:ln>
+            <a:noFill/>
+          </a:ln>
+          <a:effectLst/>
+        </p:spPr>
+        <p:style>
+          <a:lnRef idx="1">
+            <a:schemeClr val="accent1"/>
+          </a:lnRef>
+          <a:fillRef idx="3">
+            <a:schemeClr val="accent1"/>
+          </a:fillRef>
+          <a:effectRef idx="2">
+            <a:schemeClr val="accent1"/>
+          </a:effectRef>
+          <a:fontRef idx="minor">
+            <a:schemeClr val="lt1"/>
+          </a:fontRef>
+        </p:style>
+        <p:txBody>
+          <a:bodyPr rtlCol="0" anchor="ctr"/>
+          <a:lstStyle/>
+          <a:p>
+            <a:pPr algn="ctr"/>
+          </a:p>
+        </p:txBody>
+      </p:sp>
+      <p:pic>
+        <p:nvPicPr>
+          <p:cNvPr id="16" name="Stat icon 1" descr="Stat icon 1"/>
+          <p:cNvPicPr>
+            <a:picLocks noChangeAspect="1"/>
+          </p:cNvPicPr>
+          <p:nvPr/>
+        </p:nvPicPr>
+        <p:blipFill>
+          <a:blip r:embed="rId3"/>
+          <a:stretch>
+            <a:fillRect/>
+          </a:stretch>
+        </p:blipFill>
+        <p:spPr>
+          <a:xfrm>
+            <a:off x="6291986" y="2524658"/>
+            <a:ext cx="309067" cy="309067"/>
+          </a:xfrm>
+          <a:prstGeom prst="rect">
+            <a:avLst/>
+          </a:prstGeom>
+        </p:spPr>
+      </p:pic>
+      <p:sp>
+        <p:nvSpPr>
+          <p:cNvPr id="17" name="Stat 1"/>
+          <p:cNvSpPr txBox="1"/>
+          <p:nvPr/>
+        </p:nvSpPr>
+        <p:spPr>
+          <a:xfrm>
+            <a:off x="6949440" y="2130552"/>
+            <a:ext cx="4206240" cy="640080"/>
+          </a:xfrm>
+          <a:prstGeom prst="rect">
+            <a:avLst/>
+          </a:prstGeom>
+          <a:noFill/>
+        </p:spPr>
+        <p:txBody>
+          <a:bodyPr wrap="square" lIns="0" rIns="0" tIns="0" bIns="0" anchor="ctr">
+            <a:spAutoFit/>
+          </a:bodyPr>
+          <a:lstStyle/>
+          <a:p>
+            <a:r>
+              <a:rPr sz="3200" b="1" i="0">
+                <a:solidFill>
+                  <a:srgbClr val="153243"/>
+                </a:solidFill>
+                <a:latin typeface="Playfair Display"/>
+              </a:rPr>
+              <a:t>24</a:t>
+            </a:r>
+          </a:p>
+        </p:txBody>
+      </p:sp>
+      <p:sp>
+        <p:nvSpPr>
+          <p:cNvPr id="18" name="Stat label 1"/>
+          <p:cNvSpPr txBox="1"/>
+          <p:nvPr/>
+        </p:nvSpPr>
+        <p:spPr>
+          <a:xfrm>
+            <a:off x="6949440" y="2770632"/>
+            <a:ext cx="4206240" cy="457200"/>
+          </a:xfrm>
+          <a:prstGeom prst="rect">
+            <a:avLst/>
+          </a:prstGeom>
+          <a:noFill/>
+        </p:spPr>
+        <p:txBody>
+          <a:bodyPr wrap="square" lIns="0" rIns="0" tIns="0" bIns="0" anchor="t">
+            <a:spAutoFit/>
+          </a:bodyPr>
+          <a:lstStyle/>
+          <a:p>
+            <a:r>
+              <a:rPr sz="1400" b="0" i="0">
+                <a:solidFill>
+                  <a:srgbClr val="153243"/>
+                </a:solidFill>
+                <a:latin typeface="Source Sans Pro"/>
+              </a:rPr>
+              <a:t>people promoted in the last 18 months</a:t>
+            </a:r>
+          </a:p>
+        </p:txBody>
+      </p:sp>
+      <p:sp>
+        <p:nvSpPr>
+          <p:cNvPr id="19" name="Stat card 2"/>
+          <p:cNvSpPr/>
+          <p:nvPr/>
+        </p:nvSpPr>
+        <p:spPr>
+          <a:xfrm>
+            <a:off x="5852160" y="3566160"/>
+            <a:ext cx="5468112" cy="1417320"/>
+          </a:xfrm>
+          <a:prstGeom prst="roundRect">
+            <a:avLst>
+              <a:gd name="adj" fmla="val 5000"/>
+            </a:avLst>
+          </a:prstGeom>
+          <a:solidFill>
+            <a:srgbClr val="EDECED"/>
+          </a:solidFill>
+          <a:ln>
+            <a:noFill/>
+          </a:ln>
+          <a:effectLst/>
+        </p:spPr>
+        <p:style>
+          <a:lnRef idx="1">
+            <a:schemeClr val="accent1"/>
+          </a:lnRef>
+          <a:fillRef idx="3">
+            <a:schemeClr val="accent1"/>
+          </a:fillRef>
+          <a:effectRef idx="2">
+            <a:schemeClr val="accent1"/>
+          </a:effectRef>
+          <a:fontRef idx="minor">
+            <a:schemeClr val="lt1"/>
+          </a:fontRef>
+        </p:style>
+        <p:txBody>
+          <a:bodyPr rtlCol="0" anchor="ctr"/>
+          <a:lstStyle/>
+          <a:p>
+            <a:pPr algn="ctr"/>
+          </a:p>
+        </p:txBody>
+      </p:sp>
+      <p:sp>
+        <p:nvSpPr>
+          <p:cNvPr id="20" name="Stat icon 2 circle"/>
+          <p:cNvSpPr/>
+          <p:nvPr/>
+        </p:nvSpPr>
+        <p:spPr>
+          <a:xfrm>
+            <a:off x="6149340" y="3982211"/>
+            <a:ext cx="594360" cy="594360"/>
+          </a:xfrm>
+          <a:prstGeom prst="ellipse">
+            <a:avLst/>
+          </a:prstGeom>
+          <a:solidFill>
+            <a:srgbClr val="8FB24E"/>
+          </a:solidFill>
+          <a:ln>
+            <a:noFill/>
+          </a:ln>
+          <a:effectLst/>
+        </p:spPr>
+        <p:style>
+          <a:lnRef idx="1">
+            <a:schemeClr val="accent1"/>
+          </a:lnRef>
+          <a:fillRef idx="3">
+            <a:schemeClr val="accent1"/>
+          </a:fillRef>
+          <a:effectRef idx="2">
+            <a:schemeClr val="accent1"/>
+          </a:effectRef>
+          <a:fontRef idx="minor">
+            <a:schemeClr val="lt1"/>
+          </a:fontRef>
+        </p:style>
+        <p:txBody>
+          <a:bodyPr rtlCol="0" anchor="ctr"/>
+          <a:lstStyle/>
+          <a:p>
+            <a:pPr algn="ctr"/>
+          </a:p>
+        </p:txBody>
+      </p:sp>
+      <p:pic>
+        <p:nvPicPr>
+          <p:cNvPr id="21" name="Stat icon 2" descr="Stat icon 2"/>
+          <p:cNvPicPr>
+            <a:picLocks noChangeAspect="1"/>
+          </p:cNvPicPr>
+          <p:nvPr/>
+        </p:nvPicPr>
+        <p:blipFill>
+          <a:blip r:embed="rId4"/>
+          <a:stretch>
+            <a:fillRect/>
+          </a:stretch>
+        </p:blipFill>
+        <p:spPr>
+          <a:xfrm>
+            <a:off x="6291986" y="4124858"/>
+            <a:ext cx="309067" cy="309067"/>
+          </a:xfrm>
+          <a:prstGeom prst="rect">
+            <a:avLst/>
+          </a:prstGeom>
+        </p:spPr>
+      </p:pic>
+      <p:sp>
+        <p:nvSpPr>
+          <p:cNvPr id="22" name="Stat 2"/>
+          <p:cNvSpPr txBox="1"/>
+          <p:nvPr/>
+        </p:nvSpPr>
+        <p:spPr>
+          <a:xfrm>
+            <a:off x="6949440" y="3730752"/>
+            <a:ext cx="4206240" cy="640080"/>
+          </a:xfrm>
+          <a:prstGeom prst="rect">
+            <a:avLst/>
+          </a:prstGeom>
+          <a:noFill/>
+        </p:spPr>
+        <p:txBody>
+          <a:bodyPr wrap="square" lIns="0" rIns="0" tIns="0" bIns="0" anchor="ctr">
+            <a:spAutoFit/>
+          </a:bodyPr>
+          <a:lstStyle/>
+          <a:p>
+            <a:r>
+              <a:rPr sz="3200" b="1" i="0">
+                <a:solidFill>
+                  <a:srgbClr val="153243"/>
+                </a:solidFill>
+                <a:latin typeface="Playfair Display"/>
+              </a:rPr>
+              <a:t>9 of 11</a:t>
+            </a:r>
+          </a:p>
+        </p:txBody>
+      </p:sp>
+      <p:sp>
+        <p:nvSpPr>
+          <p:cNvPr id="23" name="Stat label 2"/>
+          <p:cNvSpPr txBox="1"/>
+          <p:nvPr/>
+        </p:nvSpPr>
+        <p:spPr>
+          <a:xfrm>
+            <a:off x="6949440" y="4370832"/>
+            <a:ext cx="4206240" cy="457200"/>
+          </a:xfrm>
+          <a:prstGeom prst="rect">
+            <a:avLst/>
+          </a:prstGeom>
+          <a:noFill/>
+        </p:spPr>
+        <p:txBody>
+          <a:bodyPr wrap="square" lIns="0" rIns="0" tIns="0" bIns="0" anchor="t">
+            <a:spAutoFit/>
+          </a:bodyPr>
+          <a:lstStyle/>
+          <a:p>
+            <a:r>
+              <a:rPr sz="1400" b="0" i="0">
+                <a:solidFill>
+                  <a:srgbClr val="153243"/>
+                </a:solidFill>
+                <a:latin typeface="Source Sans Pro"/>
+              </a:rPr>
+              <a:t>new employees were referred by someone inside CCIG</a:t>
+            </a:r>
+          </a:p>
+        </p:txBody>
+      </p:sp>
+      <p:sp>
+        <p:nvSpPr>
+          <p:cNvPr id="24" name="Bottom line card"/>
+          <p:cNvSpPr/>
+          <p:nvPr/>
+        </p:nvSpPr>
+        <p:spPr>
+          <a:xfrm>
+            <a:off x="960120" y="5212080"/>
+            <a:ext cx="10360152" cy="731520"/>
+          </a:xfrm>
+          <a:prstGeom prst="roundRect">
+            <a:avLst>
+              <a:gd name="adj" fmla="val 8000"/>
+            </a:avLst>
+          </a:prstGeom>
+          <a:solidFill>
+            <a:srgbClr val="366E8E"/>
+          </a:solidFill>
+          <a:ln>
+            <a:noFill/>
+          </a:ln>
+          <a:effectLst/>
+        </p:spPr>
+        <p:style>
+          <a:lnRef idx="1">
+            <a:schemeClr val="accent1"/>
+          </a:lnRef>
+          <a:fillRef idx="3">
+            <a:schemeClr val="accent1"/>
+          </a:fillRef>
+          <a:effectRef idx="2">
+            <a:schemeClr val="accent1"/>
+          </a:effectRef>
+          <a:fontRef idx="minor">
+            <a:schemeClr val="lt1"/>
+          </a:fontRef>
+        </p:style>
+        <p:txBody>
+          <a:bodyPr rtlCol="0" anchor="ctr"/>
+          <a:lstStyle/>
+          <a:p>
+            <a:pPr algn="ctr"/>
+          </a:p>
+        </p:txBody>
+      </p:sp>
+      <p:sp>
+        <p:nvSpPr>
+          <p:cNvPr id="25" name="Bottom line text"/>
+          <p:cNvSpPr txBox="1"/>
+          <p:nvPr/>
+        </p:nvSpPr>
+        <p:spPr>
+          <a:xfrm>
+            <a:off x="1188720" y="5212080"/>
+            <a:ext cx="9902952" cy="731520"/>
+          </a:xfrm>
+          <a:prstGeom prst="rect">
+            <a:avLst/>
+          </a:prstGeom>
+          <a:noFill/>
+        </p:spPr>
+        <p:txBody>
+          <a:bodyPr wrap="square" lIns="0" rIns="0" tIns="0" bIns="0" anchor="ctr">
+            <a:spAutoFit/>
+          </a:bodyPr>
+          <a:lstStyle/>
+          <a:p>
+            <a:r>
+              <a:rPr sz="1200" b="1" i="0" spc="150">
+                <a:solidFill>
+                  <a:srgbClr val="FFC666"/>
+                </a:solidFill>
+                <a:latin typeface="Source Sans Pro"/>
+              </a:rPr>
+              <a:t>THE BOTTOM LINE   </a:t>
+            </a:r>
+            <a:r>
+              <a:rPr sz="1400" b="0" i="0">
+                <a:solidFill>
+                  <a:srgbClr val="FFFFFF"/>
+                </a:solidFill>
+                <a:latin typeface="Source Sans Pro"/>
+              </a:rPr>
+              <a:t>Growth creates opportunity to invest in our people, and it challenges our capacity, processes, and leadership. EOS gives us the structure to keep up.</a:t>
+            </a:r>
+          </a:p>
+        </p:txBody>
+      </p:sp>
+    </p:spTree>
+    <p:extLst>
+      <p:ext uri="{BB962C8B-B14F-4D97-AF65-F5344CB8AC3E}">
+        <p14:creationId xmlns:p14="http://schemas.microsoft.com/office/powerpoint/2010/main" val="3739547963"/>
+      </p:ext>
+    </p:extLst>
+  </p:cSld>
+  <p:clrMapOvr>
+    <a:masterClrMapping/>
+  </p:clrMapOvr>
+  <mc:AlternateContent xmlns:mc="http://schemas.openxmlformats.org/markup-compatibility/2006" xmlns:p159="http://schemas.microsoft.com/office/powerpoint/2015/09/main">
+    <mc:Choice Requires="p159">
+      <p:transition xmlns:p14="http://schemas.microsoft.com/office/powerpoint/2010/main" spd="slow" p14:dur="2000">
+        <p159:morph option="byObject"/>
+      </p:transition>
+    </mc:Choice>
+    <mc:Fallback xmlns="">
+      <p:transition spd="slow">
+        <p:fade/>
+      </p:transition>
+    </mc:Fallback>
+  </mc:AlternateContent>
+</p:sld>
+</file>
+
+<file path=ppt/slides/slide4.xml><?xml version="1.0" encoding="utf-8"?>
+<p:sld xmlns:a="http://schemas.openxmlformats.org/drawingml/2006/main" xmlns:r="http://schemas.openxmlformats.org/officeDocument/2006/relationships" xmlns:p="http://schemas.openxmlformats.org/presentationml/2006/main">
+  <p:cSld>
+    <p:spTree>
+      <p:nvGrpSpPr>
+        <p:cNvPr id="1" name="">
+          <a:extLst>
+            <a:ext uri="{FF2B5EF4-FFF2-40B4-BE49-F238E27FC236}">
+              <a16:creationId xmlns:a16="http://schemas.microsoft.com/office/drawing/2014/main" id="{3CC0E2FD-837D-9753-CF85-B96BB0ED339A}"/>
+            </a:ext>
+          </a:extLst>
+        </p:cNvPr>
+        <p:cNvGrpSpPr/>
+        <p:nvPr/>
+      </p:nvGrpSpPr>
+      <p:grpSpPr>
+        <a:xfrm>
+          <a:off x="0" y="0"/>
+          <a:ext cx="0" cy="0"/>
+          <a:chOff x="0" y="0"/>
+          <a:chExt cx="0" cy="0"/>
+        </a:xfrm>
+      </p:grpSpPr>
+      <p:sp>
+        <p:nvSpPr>
+          <p:cNvPr id="4" name="TextBox 3">
+            <a:extLst>
+              <a:ext uri="{FF2B5EF4-FFF2-40B4-BE49-F238E27FC236}">
+                <a16:creationId xmlns:a16="http://schemas.microsoft.com/office/drawing/2014/main" id="{D52C6772-D662-5D65-1798-38644B18B7E5}"/>
+              </a:ext>
+            </a:extLst>
+          </p:cNvPr>
+          <p:cNvSpPr txBox="1"/>
+          <p:nvPr/>
+        </p:nvSpPr>
+        <p:spPr>
+          <a:xfrm>
+            <a:off x="875347" y="368336"/>
+            <a:ext cx="10447973" cy="584775"/>
+          </a:xfrm>
+          <a:prstGeom prst="rect">
+            <a:avLst/>
+          </a:prstGeom>
+          <a:noFill/>
+        </p:spPr>
+        <p:txBody>
+          <a:bodyPr wrap="square" rtlCol="0">
+            <a:spAutoFit/>
+          </a:bodyPr>
+          <a:lstStyle/>
+          <a:p>
+            <a:pPr marL="0" marR="0" lvl="0" indent="0" algn="l" defTabSz="914400" rtl="0" eaLnBrk="1" fontAlgn="auto" latinLnBrk="0" hangingPunct="1">
+              <a:lnSpc>
+                <a:spcPct val="100000"/>
+              </a:lnSpc>
+              <a:spcBef>
+                <a:spcPts val="0"/>
+              </a:spcBef>
+              <a:spcAft>
+                <a:spcPts val="0"/>
+              </a:spcAft>
+              <a:buClrTx/>
+              <a:buSzTx/>
+              <a:buFontTx/>
+              <a:buNone/>
+              <a:tabLst/>
+              <a:defRPr/>
+            </a:pPr>
+            <a:r>
+              <a:rPr kumimoji="0" lang="en-US" sz="3200" b="1" i="1" u="none" strike="noStrike" kern="1200" cap="none" spc="0" normalizeH="0" baseline="0" noProof="0" dirty="0">
+                <a:ln>
+                  <a:noFill/>
+                </a:ln>
+                <a:solidFill>
+                  <a:srgbClr val="EDECED"/>
+                </a:solidFill>
+                <a:effectLst/>
+                <a:uLnTx/>
+                <a:uFillTx/>
+                <a:latin typeface="Playfair Display" panose="00000500000000000000" pitchFamily="2" charset="0"/>
+                <a:ea typeface="+mn-ea"/>
+                <a:cs typeface="+mn-cs"/>
+              </a:rPr>
+              <a:t>What every coworker should focus on in Q4</a:t>
+            </a:r>
+          </a:p>
+        </p:txBody>
+      </p:sp>
+      <p:cxnSp>
+        <p:nvCxnSpPr>
+          <p:cNvPr id="6" name="Straight Connector 5">
+            <a:extLst>
+              <a:ext uri="{FF2B5EF4-FFF2-40B4-BE49-F238E27FC236}">
+                <a16:creationId xmlns:a16="http://schemas.microsoft.com/office/drawing/2014/main" id="{5E9116D3-F450-4A0A-4B24-450372B6DA92}"/>
+              </a:ext>
+            </a:extLst>
+          </p:cNvPr>
+          <p:cNvCxnSpPr>
+            <a:cxnSpLocks/>
+          </p:cNvCxnSpPr>
+          <p:nvPr/>
+        </p:nvCxnSpPr>
+        <p:spPr>
+          <a:xfrm>
+            <a:off x="963168" y="1060704"/>
+            <a:ext cx="10360152" cy="0"/>
+          </a:xfrm>
+          <a:prstGeom prst="line">
+            <a:avLst/>
+          </a:prstGeom>
+          <a:ln>
+            <a:solidFill>
+              <a:schemeClr val="accent3"/>
+            </a:solidFill>
+          </a:ln>
+        </p:spPr>
+        <p:style>
+          <a:lnRef idx="2">
+            <a:schemeClr val="accent3"/>
+          </a:lnRef>
+          <a:fillRef idx="0">
+            <a:schemeClr val="accent3"/>
+          </a:fillRef>
+          <a:effectRef idx="1">
+            <a:schemeClr val="accent3"/>
+          </a:effectRef>
+          <a:fontRef idx="minor">
+            <a:schemeClr val="tx1"/>
+          </a:fontRef>
+        </p:style>
+      </p:cxnSp>
+      <p:sp>
+        <p:nvSpPr>
+          <p:cNvPr id="7" name="Eyebrow"/>
+          <p:cNvSpPr txBox="1"/>
+          <p:nvPr/>
+        </p:nvSpPr>
+        <p:spPr>
+          <a:xfrm>
+            <a:off x="960120" y="1188720"/>
+            <a:ext cx="10360152" cy="228600"/>
+          </a:xfrm>
+          <a:prstGeom prst="rect">
+            <a:avLst/>
+          </a:prstGeom>
+          <a:noFill/>
+        </p:spPr>
+        <p:txBody>
+          <a:bodyPr wrap="square" lIns="0" rIns="0" tIns="0" bIns="0" anchor="t">
+            <a:spAutoFit/>
+          </a:bodyPr>
+          <a:lstStyle/>
+          <a:p>
+            <a:r>
+              <a:rPr sz="1200" b="1" i="0" spc="200">
+                <a:solidFill>
+                  <a:srgbClr val="8FB24E"/>
+                </a:solidFill>
+                <a:latin typeface="Source Sans Pro"/>
+              </a:rPr>
+              <a:t>Q4 PRIORITIES</a:t>
+            </a:r>
+          </a:p>
+        </p:txBody>
+      </p:sp>
+      <p:sp>
+        <p:nvSpPr>
+          <p:cNvPr id="8" name="Subtitle"/>
+          <p:cNvSpPr txBox="1"/>
+          <p:nvPr/>
+        </p:nvSpPr>
+        <p:spPr>
+          <a:xfrm>
+            <a:off x="960120" y="1444752"/>
+            <a:ext cx="10360152" cy="320040"/>
+          </a:xfrm>
+          <a:prstGeom prst="rect">
+            <a:avLst/>
+          </a:prstGeom>
+          <a:noFill/>
+        </p:spPr>
+        <p:txBody>
+          <a:bodyPr wrap="square" lIns="0" rIns="0" tIns="0" bIns="0" anchor="t">
+            <a:spAutoFit/>
+          </a:bodyPr>
+          <a:lstStyle/>
+          <a:p>
+            <a:r>
+              <a:rPr sz="1600" b="0" i="0">
+                <a:solidFill>
+                  <a:srgbClr val="FFFFFF"/>
+                </a:solidFill>
+                <a:latin typeface="Source Sans Pro"/>
+              </a:rPr>
+              <a:t>Know your role, own your commitments, and speak up about what is in the way.</a:t>
+            </a:r>
+          </a:p>
+        </p:txBody>
+      </p:sp>
+      <p:sp>
+        <p:nvSpPr>
+          <p:cNvPr id="9" name="Focus card 1"/>
+          <p:cNvSpPr/>
+          <p:nvPr/>
+        </p:nvSpPr>
+        <p:spPr>
+          <a:xfrm>
+            <a:off x="960120" y="1920240"/>
+            <a:ext cx="5029200" cy="1417320"/>
+          </a:xfrm>
+          <a:prstGeom prst="roundRect">
+            <a:avLst>
+              <a:gd name="adj" fmla="val 5000"/>
+            </a:avLst>
+          </a:prstGeom>
+          <a:solidFill>
+            <a:srgbClr val="EDECED"/>
+          </a:solidFill>
+          <a:ln>
+            <a:noFill/>
+          </a:ln>
+          <a:effectLst/>
+        </p:spPr>
+        <p:style>
+          <a:lnRef idx="1">
+            <a:schemeClr val="accent1"/>
+          </a:lnRef>
+          <a:fillRef idx="3">
+            <a:schemeClr val="accent1"/>
+          </a:fillRef>
+          <a:effectRef idx="2">
+            <a:schemeClr val="accent1"/>
+          </a:effectRef>
+          <a:fontRef idx="minor">
+            <a:schemeClr val="lt1"/>
+          </a:fontRef>
+        </p:style>
+        <p:txBody>
+          <a:bodyPr rtlCol="0" anchor="ctr"/>
+          <a:lstStyle/>
+          <a:p>
+            <a:pPr algn="ctr"/>
+          </a:p>
+        </p:txBody>
+      </p:sp>
+      <p:sp>
+        <p:nvSpPr>
+          <p:cNvPr id="10" name="Focus icon 1 circle"/>
+          <p:cNvSpPr/>
+          <p:nvPr/>
+        </p:nvSpPr>
+        <p:spPr>
+          <a:xfrm>
+            <a:off x="1188719" y="2313432"/>
+            <a:ext cx="640080" cy="640080"/>
+          </a:xfrm>
+          <a:prstGeom prst="ellipse">
+            <a:avLst/>
+          </a:prstGeom>
+          <a:solidFill>
+            <a:srgbClr val="8FB24E"/>
+          </a:solidFill>
+          <a:ln>
+            <a:noFill/>
+          </a:ln>
+          <a:effectLst/>
+        </p:spPr>
+        <p:style>
+          <a:lnRef idx="1">
+            <a:schemeClr val="accent1"/>
+          </a:lnRef>
+          <a:fillRef idx="3">
+            <a:schemeClr val="accent1"/>
+          </a:fillRef>
+          <a:effectRef idx="2">
+            <a:schemeClr val="accent1"/>
+          </a:effectRef>
+          <a:fontRef idx="minor">
+            <a:schemeClr val="lt1"/>
+          </a:fontRef>
+        </p:style>
+        <p:txBody>
+          <a:bodyPr rtlCol="0" anchor="ctr"/>
+          <a:lstStyle/>
+          <a:p>
+            <a:pPr algn="ctr"/>
+          </a:p>
+        </p:txBody>
+      </p:sp>
+      <p:pic>
+        <p:nvPicPr>
+          <p:cNvPr id="11" name="Focus icon 1" descr="Focus icon 1"/>
+          <p:cNvPicPr>
+            <a:picLocks noChangeAspect="1"/>
+          </p:cNvPicPr>
+          <p:nvPr/>
+        </p:nvPicPr>
+        <p:blipFill>
+          <a:blip r:embed="rId2"/>
+          <a:stretch>
+            <a:fillRect/>
+          </a:stretch>
+        </p:blipFill>
+        <p:spPr>
+          <a:xfrm>
+            <a:off x="1342339" y="2467051"/>
+            <a:ext cx="332841" cy="332841"/>
+          </a:xfrm>
+          <a:prstGeom prst="rect">
+            <a:avLst/>
+          </a:prstGeom>
+        </p:spPr>
+      </p:pic>
+      <p:sp>
+        <p:nvSpPr>
+          <p:cNvPr id="12" name="Focus text 1"/>
+          <p:cNvSpPr txBox="1"/>
+          <p:nvPr/>
+        </p:nvSpPr>
+        <p:spPr>
+          <a:xfrm>
+            <a:off x="2011680" y="2084832"/>
+            <a:ext cx="3794760" cy="1143000"/>
+          </a:xfrm>
+          <a:prstGeom prst="rect">
+            <a:avLst/>
+          </a:prstGeom>
+          <a:noFill/>
+        </p:spPr>
+        <p:txBody>
+          <a:bodyPr wrap="square" lIns="0" rIns="0" tIns="0" bIns="0" anchor="ctr">
+            <a:spAutoFit/>
+          </a:bodyPr>
+          <a:lstStyle/>
+          <a:p>
+            <a:r>
+              <a:rPr sz="1600" b="1" i="0">
+                <a:solidFill>
+                  <a:srgbClr val="153243"/>
+                </a:solidFill>
+                <a:latin typeface="Source Sans Pro"/>
+              </a:rPr>
+              <a:t>Accountability chart</a:t>
+            </a:r>
+          </a:p>
+          <a:p>
+            <a:r>
+              <a:rPr sz="1200" b="0" i="0">
+                <a:solidFill>
+                  <a:srgbClr val="153243"/>
+                </a:solidFill>
+                <a:latin typeface="Source Sans Pro"/>
+              </a:rPr>
+              <a:t>Clarifies what each person owns, who to turn to, and how your work connects to the rest of the company.</a:t>
+            </a:r>
+          </a:p>
+        </p:txBody>
+      </p:sp>
+      <p:sp>
+        <p:nvSpPr>
+          <p:cNvPr id="13" name="Focus card 2"/>
+          <p:cNvSpPr/>
+          <p:nvPr/>
+        </p:nvSpPr>
+        <p:spPr>
+          <a:xfrm>
+            <a:off x="6291072" y="1920240"/>
+            <a:ext cx="5029200" cy="1417320"/>
+          </a:xfrm>
+          <a:prstGeom prst="roundRect">
+            <a:avLst>
+              <a:gd name="adj" fmla="val 5000"/>
+            </a:avLst>
+          </a:prstGeom>
+          <a:solidFill>
+            <a:srgbClr val="EDECED"/>
+          </a:solidFill>
+          <a:ln>
+            <a:noFill/>
+          </a:ln>
+          <a:effectLst/>
+        </p:spPr>
+        <p:style>
+          <a:lnRef idx="1">
+            <a:schemeClr val="accent1"/>
+          </a:lnRef>
+          <a:fillRef idx="3">
+            <a:schemeClr val="accent1"/>
+          </a:fillRef>
+          <a:effectRef idx="2">
+            <a:schemeClr val="accent1"/>
+          </a:effectRef>
+          <a:fontRef idx="minor">
+            <a:schemeClr val="lt1"/>
+          </a:fontRef>
+        </p:style>
+        <p:txBody>
+          <a:bodyPr rtlCol="0" anchor="ctr"/>
+          <a:lstStyle/>
+          <a:p>
+            <a:pPr algn="ctr"/>
+          </a:p>
+        </p:txBody>
+      </p:sp>
+      <p:sp>
+        <p:nvSpPr>
+          <p:cNvPr id="14" name="Focus icon 2 circle"/>
+          <p:cNvSpPr/>
+          <p:nvPr/>
+        </p:nvSpPr>
+        <p:spPr>
+          <a:xfrm>
+            <a:off x="6519672" y="2313432"/>
+            <a:ext cx="640080" cy="640080"/>
+          </a:xfrm>
+          <a:prstGeom prst="ellipse">
+            <a:avLst/>
+          </a:prstGeom>
+          <a:solidFill>
+            <a:srgbClr val="8FB24E"/>
+          </a:solidFill>
+          <a:ln>
+            <a:noFill/>
+          </a:ln>
+          <a:effectLst/>
+        </p:spPr>
+        <p:style>
+          <a:lnRef idx="1">
+            <a:schemeClr val="accent1"/>
+          </a:lnRef>
+          <a:fillRef idx="3">
+            <a:schemeClr val="accent1"/>
+          </a:fillRef>
+          <a:effectRef idx="2">
+            <a:schemeClr val="accent1"/>
+          </a:effectRef>
+          <a:fontRef idx="minor">
+            <a:schemeClr val="lt1"/>
+          </a:fontRef>
+        </p:style>
+        <p:txBody>
+          <a:bodyPr rtlCol="0" anchor="ctr"/>
+          <a:lstStyle/>
+          <a:p>
+            <a:pPr algn="ctr"/>
+          </a:p>
+        </p:txBody>
+      </p:sp>
+      <p:pic>
+        <p:nvPicPr>
+          <p:cNvPr id="15" name="Focus icon 2" descr="Focus icon 2"/>
+          <p:cNvPicPr>
+            <a:picLocks noChangeAspect="1"/>
+          </p:cNvPicPr>
+          <p:nvPr/>
+        </p:nvPicPr>
+        <p:blipFill>
+          <a:blip r:embed="rId3"/>
+          <a:stretch>
+            <a:fillRect/>
+          </a:stretch>
+        </p:blipFill>
+        <p:spPr>
+          <a:xfrm>
+            <a:off x="6673291" y="2467051"/>
+            <a:ext cx="332841" cy="332841"/>
+          </a:xfrm>
+          <a:prstGeom prst="rect">
+            <a:avLst/>
+          </a:prstGeom>
+        </p:spPr>
+      </p:pic>
+      <p:sp>
+        <p:nvSpPr>
+          <p:cNvPr id="16" name="Focus text 2"/>
+          <p:cNvSpPr txBox="1"/>
+          <p:nvPr/>
+        </p:nvSpPr>
+        <p:spPr>
+          <a:xfrm>
+            <a:off x="7342631" y="2084832"/>
+            <a:ext cx="3794760" cy="1143000"/>
+          </a:xfrm>
+          <a:prstGeom prst="rect">
+            <a:avLst/>
+          </a:prstGeom>
+          <a:noFill/>
+        </p:spPr>
+        <p:txBody>
+          <a:bodyPr wrap="square" lIns="0" rIns="0" tIns="0" bIns="0" anchor="ctr">
+            <a:spAutoFit/>
+          </a:bodyPr>
+          <a:lstStyle/>
+          <a:p>
+            <a:r>
+              <a:rPr sz="1600" b="1" i="0">
+                <a:solidFill>
+                  <a:srgbClr val="153243"/>
+                </a:solidFill>
+                <a:latin typeface="Source Sans Pro"/>
+              </a:rPr>
+              <a:t>L10 meetings</a:t>
+            </a:r>
+          </a:p>
+          <a:p>
+            <a:r>
+              <a:rPr sz="1200" b="0" i="0">
+                <a:solidFill>
+                  <a:srgbClr val="153243"/>
+                </a:solidFill>
+                <a:latin typeface="Source Sans Pro"/>
+              </a:rPr>
+              <a:t>Raise capacity concerns, difficult handoffs, recurring problems, and accounts that need attention.</a:t>
+            </a:r>
+          </a:p>
+        </p:txBody>
+      </p:sp>
+      <p:sp>
+        <p:nvSpPr>
+          <p:cNvPr id="17" name="Focus card 3"/>
+          <p:cNvSpPr/>
+          <p:nvPr/>
+        </p:nvSpPr>
+        <p:spPr>
+          <a:xfrm>
+            <a:off x="960120" y="3474720"/>
+            <a:ext cx="5029200" cy="1417320"/>
+          </a:xfrm>
+          <a:prstGeom prst="roundRect">
+            <a:avLst>
+              <a:gd name="adj" fmla="val 5000"/>
+            </a:avLst>
+          </a:prstGeom>
+          <a:solidFill>
+            <a:srgbClr val="EDECED"/>
+          </a:solidFill>
+          <a:ln>
+            <a:noFill/>
+          </a:ln>
+          <a:effectLst/>
+        </p:spPr>
+        <p:style>
+          <a:lnRef idx="1">
+            <a:schemeClr val="accent1"/>
+          </a:lnRef>
+          <a:fillRef idx="3">
+            <a:schemeClr val="accent1"/>
+          </a:fillRef>
+          <a:effectRef idx="2">
+            <a:schemeClr val="accent1"/>
+          </a:effectRef>
+          <a:fontRef idx="minor">
+            <a:schemeClr val="lt1"/>
+          </a:fontRef>
+        </p:style>
+        <p:txBody>
+          <a:bodyPr rtlCol="0" anchor="ctr"/>
+          <a:lstStyle/>
+          <a:p>
+            <a:pPr algn="ctr"/>
+          </a:p>
+        </p:txBody>
+      </p:sp>
+      <p:sp>
+        <p:nvSpPr>
+          <p:cNvPr id="18" name="Focus icon 3 circle"/>
+          <p:cNvSpPr/>
+          <p:nvPr/>
+        </p:nvSpPr>
+        <p:spPr>
+          <a:xfrm>
+            <a:off x="1188719" y="3867912"/>
+            <a:ext cx="640080" cy="640080"/>
+          </a:xfrm>
+          <a:prstGeom prst="ellipse">
+            <a:avLst/>
+          </a:prstGeom>
+          <a:solidFill>
+            <a:srgbClr val="8FB24E"/>
+          </a:solidFill>
+          <a:ln>
+            <a:noFill/>
+          </a:ln>
+          <a:effectLst/>
+        </p:spPr>
+        <p:style>
+          <a:lnRef idx="1">
+            <a:schemeClr val="accent1"/>
+          </a:lnRef>
+          <a:fillRef idx="3">
+            <a:schemeClr val="accent1"/>
+          </a:fillRef>
+          <a:effectRef idx="2">
+            <a:schemeClr val="accent1"/>
+          </a:effectRef>
+          <a:fontRef idx="minor">
+            <a:schemeClr val="lt1"/>
+          </a:fontRef>
+        </p:style>
+        <p:txBody>
+          <a:bodyPr rtlCol="0" anchor="ctr"/>
+          <a:lstStyle/>
+          <a:p>
+            <a:pPr algn="ctr"/>
+          </a:p>
+        </p:txBody>
+      </p:sp>
+      <p:pic>
+        <p:nvPicPr>
+          <p:cNvPr id="19" name="Focus icon 3" descr="Focus icon 3"/>
+          <p:cNvPicPr>
+            <a:picLocks noChangeAspect="1"/>
+          </p:cNvPicPr>
+          <p:nvPr/>
+        </p:nvPicPr>
+        <p:blipFill>
+          <a:blip r:embed="rId4"/>
+          <a:stretch>
+            <a:fillRect/>
+          </a:stretch>
+        </p:blipFill>
+        <p:spPr>
+          <a:xfrm>
+            <a:off x="1342339" y="4021531"/>
+            <a:ext cx="332841" cy="332841"/>
+          </a:xfrm>
+          <a:prstGeom prst="rect">
+            <a:avLst/>
+          </a:prstGeom>
+        </p:spPr>
+      </p:pic>
+      <p:sp>
+        <p:nvSpPr>
+          <p:cNvPr id="20" name="Focus text 3"/>
+          <p:cNvSpPr txBox="1"/>
+          <p:nvPr/>
+        </p:nvSpPr>
+        <p:spPr>
+          <a:xfrm>
+            <a:off x="2011680" y="3639312"/>
+            <a:ext cx="3794760" cy="1143000"/>
+          </a:xfrm>
+          <a:prstGeom prst="rect">
+            <a:avLst/>
+          </a:prstGeom>
+          <a:noFill/>
+        </p:spPr>
+        <p:txBody>
+          <a:bodyPr wrap="square" lIns="0" rIns="0" tIns="0" bIns="0" anchor="ctr">
+            <a:spAutoFit/>
+          </a:bodyPr>
+          <a:lstStyle/>
+          <a:p>
+            <a:r>
+              <a:rPr sz="1600" b="1" i="0">
+                <a:solidFill>
+                  <a:srgbClr val="153243"/>
+                </a:solidFill>
+                <a:latin typeface="Source Sans Pro"/>
+              </a:rPr>
+              <a:t>Quarterly conversations</a:t>
+            </a:r>
+          </a:p>
+          <a:p>
+            <a:r>
+              <a:rPr sz="1200" b="0" i="0">
+                <a:solidFill>
+                  <a:srgbClr val="153243"/>
+                </a:solidFill>
+                <a:latin typeface="Source Sans Pro"/>
+              </a:rPr>
+              <a:t>Talk openly about performance, development, and the support you need.</a:t>
+            </a:r>
+          </a:p>
+        </p:txBody>
+      </p:sp>
+      <p:sp>
+        <p:nvSpPr>
+          <p:cNvPr id="21" name="Focus card 4"/>
+          <p:cNvSpPr/>
+          <p:nvPr/>
+        </p:nvSpPr>
+        <p:spPr>
+          <a:xfrm>
+            <a:off x="6291072" y="3474720"/>
+            <a:ext cx="5029200" cy="1417320"/>
+          </a:xfrm>
+          <a:prstGeom prst="roundRect">
+            <a:avLst>
+              <a:gd name="adj" fmla="val 5000"/>
+            </a:avLst>
+          </a:prstGeom>
+          <a:solidFill>
+            <a:srgbClr val="EDECED"/>
+          </a:solidFill>
+          <a:ln>
+            <a:noFill/>
+          </a:ln>
+          <a:effectLst/>
+        </p:spPr>
+        <p:style>
+          <a:lnRef idx="1">
+            <a:schemeClr val="accent1"/>
+          </a:lnRef>
+          <a:fillRef idx="3">
+            <a:schemeClr val="accent1"/>
+          </a:fillRef>
+          <a:effectRef idx="2">
+            <a:schemeClr val="accent1"/>
+          </a:effectRef>
+          <a:fontRef idx="minor">
+            <a:schemeClr val="lt1"/>
+          </a:fontRef>
+        </p:style>
+        <p:txBody>
+          <a:bodyPr rtlCol="0" anchor="ctr"/>
+          <a:lstStyle/>
+          <a:p>
+            <a:pPr algn="ctr"/>
+          </a:p>
+        </p:txBody>
+      </p:sp>
+      <p:sp>
+        <p:nvSpPr>
+          <p:cNvPr id="22" name="Focus icon 4 circle"/>
+          <p:cNvSpPr/>
+          <p:nvPr/>
+        </p:nvSpPr>
+        <p:spPr>
+          <a:xfrm>
+            <a:off x="6519672" y="3867912"/>
+            <a:ext cx="640080" cy="640080"/>
+          </a:xfrm>
+          <a:prstGeom prst="ellipse">
+            <a:avLst/>
+          </a:prstGeom>
+          <a:solidFill>
+            <a:srgbClr val="8FB24E"/>
+          </a:solidFill>
+          <a:ln>
+            <a:noFill/>
+          </a:ln>
+          <a:effectLst/>
+        </p:spPr>
+        <p:style>
+          <a:lnRef idx="1">
+            <a:schemeClr val="accent1"/>
+          </a:lnRef>
+          <a:fillRef idx="3">
+            <a:schemeClr val="accent1"/>
+          </a:fillRef>
+          <a:effectRef idx="2">
+            <a:schemeClr val="accent1"/>
+          </a:effectRef>
+          <a:fontRef idx="minor">
+            <a:schemeClr val="lt1"/>
+          </a:fontRef>
+        </p:style>
+        <p:txBody>
+          <a:bodyPr rtlCol="0" anchor="ctr"/>
+          <a:lstStyle/>
+          <a:p>
+            <a:pPr algn="ctr"/>
+          </a:p>
+        </p:txBody>
+      </p:sp>
+      <p:pic>
+        <p:nvPicPr>
+          <p:cNvPr id="23" name="Focus icon 4" descr="Focus icon 4"/>
+          <p:cNvPicPr>
+            <a:picLocks noChangeAspect="1"/>
+          </p:cNvPicPr>
+          <p:nvPr/>
+        </p:nvPicPr>
+        <p:blipFill>
+          <a:blip r:embed="rId5"/>
+          <a:stretch>
+            <a:fillRect/>
+          </a:stretch>
+        </p:blipFill>
+        <p:spPr>
+          <a:xfrm>
+            <a:off x="6673291" y="4021531"/>
+            <a:ext cx="332841" cy="332841"/>
+          </a:xfrm>
+          <a:prstGeom prst="rect">
+            <a:avLst/>
+          </a:prstGeom>
+        </p:spPr>
+      </p:pic>
+      <p:sp>
+        <p:nvSpPr>
+          <p:cNvPr id="24" name="Focus text 4"/>
+          <p:cNvSpPr txBox="1"/>
+          <p:nvPr/>
+        </p:nvSpPr>
+        <p:spPr>
+          <a:xfrm>
+            <a:off x="7342631" y="3639312"/>
+            <a:ext cx="3794760" cy="1143000"/>
+          </a:xfrm>
+          <a:prstGeom prst="rect">
+            <a:avLst/>
+          </a:prstGeom>
+          <a:noFill/>
+        </p:spPr>
+        <p:txBody>
+          <a:bodyPr wrap="square" lIns="0" rIns="0" tIns="0" bIns="0" anchor="ctr">
+            <a:spAutoFit/>
+          </a:bodyPr>
+          <a:lstStyle/>
+          <a:p>
+            <a:r>
+              <a:rPr sz="1600" b="1" i="0">
+                <a:solidFill>
+                  <a:srgbClr val="153243"/>
+                </a:solidFill>
+                <a:latin typeface="Source Sans Pro"/>
+              </a:rPr>
+              <a:t>Client retention</a:t>
+            </a:r>
+          </a:p>
+          <a:p>
+            <a:r>
+              <a:rPr sz="1200" b="0" i="0">
+                <a:solidFill>
+                  <a:srgbClr val="153243"/>
+                </a:solidFill>
+                <a:latin typeface="Source Sans Pro"/>
+              </a:rPr>
+              <a:t>Keep the clients who trust us through responsiveness, follow-through, and raising concerns early.</a:t>
+            </a:r>
+          </a:p>
+        </p:txBody>
+      </p:sp>
+      <p:sp>
+        <p:nvSpPr>
+          <p:cNvPr id="25" name="Bottom line card"/>
+          <p:cNvSpPr/>
+          <p:nvPr/>
+        </p:nvSpPr>
+        <p:spPr>
+          <a:xfrm>
+            <a:off x="960120" y="5120640"/>
+            <a:ext cx="10360152" cy="640080"/>
+          </a:xfrm>
+          <a:prstGeom prst="roundRect">
+            <a:avLst>
+              <a:gd name="adj" fmla="val 8000"/>
+            </a:avLst>
+          </a:prstGeom>
+          <a:solidFill>
+            <a:srgbClr val="366E8E"/>
+          </a:solidFill>
+          <a:ln>
+            <a:noFill/>
+          </a:ln>
+          <a:effectLst/>
+        </p:spPr>
+        <p:style>
+          <a:lnRef idx="1">
+            <a:schemeClr val="accent1"/>
+          </a:lnRef>
+          <a:fillRef idx="3">
+            <a:schemeClr val="accent1"/>
+          </a:fillRef>
+          <a:effectRef idx="2">
+            <a:schemeClr val="accent1"/>
+          </a:effectRef>
+          <a:fontRef idx="minor">
+            <a:schemeClr val="lt1"/>
+          </a:fontRef>
+        </p:style>
+        <p:txBody>
+          <a:bodyPr rtlCol="0" anchor="ctr"/>
+          <a:lstStyle/>
+          <a:p>
+            <a:pPr algn="ctr"/>
+          </a:p>
+        </p:txBody>
+      </p:sp>
+      <p:sp>
+        <p:nvSpPr>
+          <p:cNvPr id="26" name="Bottom line text"/>
+          <p:cNvSpPr txBox="1"/>
+          <p:nvPr/>
+        </p:nvSpPr>
+        <p:spPr>
+          <a:xfrm>
+            <a:off x="1188720" y="5120640"/>
+            <a:ext cx="9902952" cy="640080"/>
+          </a:xfrm>
+          <a:prstGeom prst="rect">
+            <a:avLst/>
+          </a:prstGeom>
+          <a:noFill/>
+        </p:spPr>
+        <p:txBody>
+          <a:bodyPr wrap="square" lIns="0" rIns="0" tIns="0" bIns="0" anchor="ctr">
+            <a:spAutoFit/>
+          </a:bodyPr>
+          <a:lstStyle/>
+          <a:p>
+            <a:r>
+              <a:rPr sz="1200" b="1" i="0" spc="150">
+                <a:solidFill>
+                  <a:srgbClr val="FFC666"/>
+                </a:solidFill>
+                <a:latin typeface="Source Sans Pro"/>
+              </a:rPr>
+              <a:t>THE BOTTOM LINE   </a:t>
+            </a:r>
+            <a:r>
+              <a:rPr sz="1400" b="0" i="0">
+                <a:solidFill>
+                  <a:srgbClr val="FFFFFF"/>
+                </a:solidFill>
+                <a:latin typeface="Source Sans Pro"/>
+              </a:rPr>
+              <a:t>The value comes from solving the issue and making sure someone owns the next step.</a:t>
+            </a:r>
+          </a:p>
+        </p:txBody>
+      </p:sp>
+    </p:spTree>
+    <p:extLst>
+      <p:ext uri="{BB962C8B-B14F-4D97-AF65-F5344CB8AC3E}">
+        <p14:creationId xmlns:p14="http://schemas.microsoft.com/office/powerpoint/2010/main" val="3739547963"/>
+      </p:ext>
+    </p:extLst>
+  </p:cSld>
+  <p:clrMapOvr>
+    <a:masterClrMapping/>
+  </p:clrMapOvr>
+  <mc:AlternateContent xmlns:mc="http://schemas.openxmlformats.org/markup-compatibility/2006" xmlns:p159="http://schemas.microsoft.com/office/powerpoint/2015/09/main">
+    <mc:Choice Requires="p159">
+      <p:transition xmlns:p14="http://schemas.microsoft.com/office/powerpoint/2010/main" spd="slow" p14:dur="2000">
+        <p159:morph option="byObject"/>
+      </p:transition>
+    </mc:Choice>
+    <mc:Fallback xmlns="">
+      <p:transition spd="slow">
+        <p:fade/>
+      </p:transition>
+    </mc:Fallback>
+  </mc:AlternateContent>
+</p:sld>
+</file>
+
+<file path=ppt/slides/slide5.xml><?xml version="1.0" encoding="utf-8"?>
+<p:sld xmlns:a="http://schemas.openxmlformats.org/drawingml/2006/main" xmlns:r="http://schemas.openxmlformats.org/officeDocument/2006/relationships" xmlns:p="http://schemas.openxmlformats.org/presentationml/2006/main">
+  <p:cSld>
+    <p:spTree>
+      <p:nvGrpSpPr>
+        <p:cNvPr id="1" name="">
+          <a:extLst>
+            <a:ext uri="{FF2B5EF4-FFF2-40B4-BE49-F238E27FC236}">
+              <a16:creationId xmlns:a16="http://schemas.microsoft.com/office/drawing/2014/main" id="{3CC0E2FD-837D-9753-CF85-B96BB0ED339A}"/>
+            </a:ext>
+          </a:extLst>
+        </p:cNvPr>
+        <p:cNvGrpSpPr/>
+        <p:nvPr/>
+      </p:nvGrpSpPr>
+      <p:grpSpPr>
+        <a:xfrm>
+          <a:off x="0" y="0"/>
+          <a:ext cx="0" cy="0"/>
+          <a:chOff x="0" y="0"/>
+          <a:chExt cx="0" cy="0"/>
+        </a:xfrm>
+      </p:grpSpPr>
+      <p:sp>
+        <p:nvSpPr>
+          <p:cNvPr id="4" name="TextBox 3">
+            <a:extLst>
+              <a:ext uri="{FF2B5EF4-FFF2-40B4-BE49-F238E27FC236}">
+                <a16:creationId xmlns:a16="http://schemas.microsoft.com/office/drawing/2014/main" id="{D52C6772-D662-5D65-1798-38644B18B7E5}"/>
+              </a:ext>
+            </a:extLst>
+          </p:cNvPr>
+          <p:cNvSpPr txBox="1"/>
+          <p:nvPr/>
+        </p:nvSpPr>
+        <p:spPr>
+          <a:xfrm>
+            <a:off x="875347" y="368336"/>
+            <a:ext cx="10447973" cy="584775"/>
+          </a:xfrm>
+          <a:prstGeom prst="rect">
+            <a:avLst/>
+          </a:prstGeom>
+          <a:noFill/>
+        </p:spPr>
+        <p:txBody>
+          <a:bodyPr wrap="square" rtlCol="0">
+            <a:spAutoFit/>
+          </a:bodyPr>
+          <a:lstStyle/>
+          <a:p>
+            <a:pPr marL="0" marR="0" lvl="0" indent="0" algn="l" defTabSz="914400" rtl="0" eaLnBrk="1" fontAlgn="auto" latinLnBrk="0" hangingPunct="1">
+              <a:lnSpc>
+                <a:spcPct val="100000"/>
+              </a:lnSpc>
+              <a:spcBef>
+                <a:spcPts val="0"/>
+              </a:spcBef>
+              <a:spcAft>
+                <a:spcPts val="0"/>
+              </a:spcAft>
+              <a:buClrTx/>
+              <a:buSzTx/>
+              <a:buFontTx/>
+              <a:buNone/>
+              <a:tabLst/>
+              <a:defRPr/>
+            </a:pPr>
+            <a:r>
+              <a:rPr kumimoji="0" lang="en-US" sz="3200" b="1" i="1" u="none" strike="noStrike" kern="1200" cap="none" spc="0" normalizeH="0" baseline="0" noProof="0" dirty="0">
+                <a:ln>
+                  <a:noFill/>
+                </a:ln>
+                <a:solidFill>
+                  <a:srgbClr val="EDECED"/>
+                </a:solidFill>
+                <a:effectLst/>
+                <a:uLnTx/>
+                <a:uFillTx/>
+                <a:latin typeface="Playfair Display" panose="00000500000000000000" pitchFamily="2" charset="0"/>
+                <a:ea typeface="+mn-ea"/>
+                <a:cs typeface="+mn-cs"/>
+              </a:rPr>
+              <a:t>Managing growth few brokers experience</a:t>
+            </a:r>
+          </a:p>
+        </p:txBody>
+      </p:sp>
+      <p:cxnSp>
+        <p:nvCxnSpPr>
+          <p:cNvPr id="6" name="Straight Connector 5">
+            <a:extLst>
+              <a:ext uri="{FF2B5EF4-FFF2-40B4-BE49-F238E27FC236}">
+                <a16:creationId xmlns:a16="http://schemas.microsoft.com/office/drawing/2014/main" id="{5E9116D3-F450-4A0A-4B24-450372B6DA92}"/>
+              </a:ext>
+            </a:extLst>
+          </p:cNvPr>
+          <p:cNvCxnSpPr>
+            <a:cxnSpLocks/>
+          </p:cNvCxnSpPr>
+          <p:nvPr/>
+        </p:nvCxnSpPr>
+        <p:spPr>
+          <a:xfrm>
+            <a:off x="963168" y="1060704"/>
+            <a:ext cx="10360152" cy="0"/>
+          </a:xfrm>
+          <a:prstGeom prst="line">
+            <a:avLst/>
+          </a:prstGeom>
+          <a:ln>
+            <a:solidFill>
+              <a:schemeClr val="accent3"/>
+            </a:solidFill>
+          </a:ln>
+        </p:spPr>
+        <p:style>
+          <a:lnRef idx="2">
+            <a:schemeClr val="accent3"/>
+          </a:lnRef>
+          <a:fillRef idx="0">
+            <a:schemeClr val="accent3"/>
+          </a:fillRef>
+          <a:effectRef idx="1">
+            <a:schemeClr val="accent3"/>
+          </a:effectRef>
+          <a:fontRef idx="minor">
+            <a:schemeClr val="tx1"/>
+          </a:fontRef>
+        </p:style>
+      </p:cxnSp>
+      <p:sp>
+        <p:nvSpPr>
+          <p:cNvPr id="7" name="Eyebrow"/>
+          <p:cNvSpPr txBox="1"/>
+          <p:nvPr/>
+        </p:nvSpPr>
+        <p:spPr>
+          <a:xfrm>
+            <a:off x="960120" y="1188720"/>
+            <a:ext cx="10360152" cy="228600"/>
+          </a:xfrm>
+          <a:prstGeom prst="rect">
+            <a:avLst/>
+          </a:prstGeom>
+          <a:noFill/>
+        </p:spPr>
+        <p:txBody>
+          <a:bodyPr wrap="square" lIns="0" rIns="0" tIns="0" bIns="0" anchor="t">
+            <a:spAutoFit/>
+          </a:bodyPr>
+          <a:lstStyle/>
+          <a:p>
+            <a:r>
+              <a:rPr sz="1200" b="1" i="0" spc="200">
+                <a:solidFill>
+                  <a:srgbClr val="8FB24E"/>
+                </a:solidFill>
+                <a:latin typeface="Source Sans Pro"/>
+              </a:rPr>
+              <a:t>TOP OF MIND</a:t>
+            </a:r>
+          </a:p>
+        </p:txBody>
+      </p:sp>
+      <p:sp>
+        <p:nvSpPr>
+          <p:cNvPr id="8" name="Subtitle"/>
+          <p:cNvSpPr txBox="1"/>
+          <p:nvPr/>
+        </p:nvSpPr>
+        <p:spPr>
+          <a:xfrm>
+            <a:off x="960120" y="1444752"/>
+            <a:ext cx="10360152" cy="320040"/>
+          </a:xfrm>
+          <a:prstGeom prst="rect">
+            <a:avLst/>
+          </a:prstGeom>
+          <a:noFill/>
+        </p:spPr>
+        <p:txBody>
+          <a:bodyPr wrap="square" lIns="0" rIns="0" tIns="0" bIns="0" anchor="t">
+            <a:spAutoFit/>
+          </a:bodyPr>
+          <a:lstStyle/>
+          <a:p>
+            <a:r>
+              <a:rPr sz="1600" b="0" i="0">
+                <a:solidFill>
+                  <a:srgbClr val="FFFFFF"/>
+                </a:solidFill>
+                <a:latin typeface="Source Sans Pro"/>
+              </a:rPr>
+              <a:t>More clients bring more responsibility, more complexity, and more demand on our teams.</a:t>
+            </a:r>
+          </a:p>
+        </p:txBody>
+      </p:sp>
+      <p:sp>
+        <p:nvSpPr>
+          <p:cNvPr id="9" name="Getting ahead of capacity panel"/>
+          <p:cNvSpPr/>
+          <p:nvPr/>
+        </p:nvSpPr>
+        <p:spPr>
+          <a:xfrm>
+            <a:off x="960120" y="1920240"/>
+            <a:ext cx="5029200" cy="3337560"/>
+          </a:xfrm>
+          <a:prstGeom prst="roundRect">
+            <a:avLst>
+              <a:gd name="adj" fmla="val 4000"/>
+            </a:avLst>
+          </a:prstGeom>
+          <a:solidFill>
+            <a:srgbClr val="EDECED"/>
+          </a:solidFill>
+          <a:ln>
+            <a:noFill/>
+          </a:ln>
+          <a:effectLst/>
+        </p:spPr>
+        <p:style>
+          <a:lnRef idx="1">
+            <a:schemeClr val="accent1"/>
+          </a:lnRef>
+          <a:fillRef idx="3">
+            <a:schemeClr val="accent1"/>
+          </a:fillRef>
+          <a:effectRef idx="2">
+            <a:schemeClr val="accent1"/>
+          </a:effectRef>
+          <a:fontRef idx="minor">
+            <a:schemeClr val="lt1"/>
+          </a:fontRef>
+        </p:style>
+        <p:txBody>
+          <a:bodyPr rtlCol="0" anchor="ctr"/>
+          <a:lstStyle/>
+          <a:p>
+            <a:pPr algn="ctr"/>
+          </a:p>
+        </p:txBody>
+      </p:sp>
+      <p:sp>
+        <p:nvSpPr>
+          <p:cNvPr id="10" name="Getting ahead of capacity header"/>
+          <p:cNvSpPr txBox="1"/>
+          <p:nvPr/>
+        </p:nvSpPr>
+        <p:spPr>
+          <a:xfrm>
+            <a:off x="1234440" y="2103120"/>
+            <a:ext cx="4480560" cy="292608"/>
+          </a:xfrm>
+          <a:prstGeom prst="rect">
+            <a:avLst/>
+          </a:prstGeom>
+          <a:noFill/>
+        </p:spPr>
+        <p:txBody>
+          <a:bodyPr wrap="square" lIns="0" rIns="0" tIns="0" bIns="0" anchor="t">
+            <a:spAutoFit/>
+          </a:bodyPr>
+          <a:lstStyle/>
+          <a:p>
+            <a:r>
+              <a:rPr sz="1800" b="1" i="0">
+                <a:solidFill>
+                  <a:srgbClr val="153243"/>
+                </a:solidFill>
+                <a:latin typeface="Source Sans Pro"/>
+              </a:rPr>
+              <a:t>Getting ahead of capacity</a:t>
+            </a:r>
+          </a:p>
+        </p:txBody>
+      </p:sp>
+      <p:sp>
+        <p:nvSpPr>
+          <p:cNvPr id="11" name="Getting ahead of capacity subhead"/>
+          <p:cNvSpPr txBox="1"/>
+          <p:nvPr/>
+        </p:nvSpPr>
+        <p:spPr>
+          <a:xfrm>
+            <a:off x="1234440" y="2395728"/>
+            <a:ext cx="4480560" cy="274320"/>
+          </a:xfrm>
+          <a:prstGeom prst="rect">
+            <a:avLst/>
+          </a:prstGeom>
+          <a:noFill/>
+        </p:spPr>
+        <p:txBody>
+          <a:bodyPr wrap="square" lIns="0" rIns="0" tIns="0" bIns="0" anchor="t">
+            <a:spAutoFit/>
+          </a:bodyPr>
+          <a:lstStyle/>
+          <a:p>
+            <a:r>
+              <a:rPr sz="1300" b="0" i="0">
+                <a:solidFill>
+                  <a:srgbClr val="366E8E"/>
+                </a:solidFill>
+                <a:latin typeface="Source Sans Pro"/>
+              </a:rPr>
+              <a:t>Support growth without losing service</a:t>
+            </a:r>
+          </a:p>
+        </p:txBody>
+      </p:sp>
+      <p:sp>
+        <p:nvSpPr>
+          <p:cNvPr id="12" name="Row icon 1 circle"/>
+          <p:cNvSpPr/>
+          <p:nvPr/>
+        </p:nvSpPr>
+        <p:spPr>
+          <a:xfrm>
+            <a:off x="1234440" y="2898648"/>
+            <a:ext cx="457200" cy="457200"/>
+          </a:xfrm>
+          <a:prstGeom prst="ellipse">
+            <a:avLst/>
+          </a:prstGeom>
+          <a:solidFill>
+            <a:srgbClr val="FFFFFF"/>
+          </a:solidFill>
+          <a:ln>
+            <a:noFill/>
+          </a:ln>
+          <a:effectLst/>
+        </p:spPr>
+        <p:style>
+          <a:lnRef idx="1">
+            <a:schemeClr val="accent1"/>
+          </a:lnRef>
+          <a:fillRef idx="3">
+            <a:schemeClr val="accent1"/>
+          </a:fillRef>
+          <a:effectRef idx="2">
+            <a:schemeClr val="accent1"/>
+          </a:effectRef>
+          <a:fontRef idx="minor">
+            <a:schemeClr val="lt1"/>
+          </a:fontRef>
+        </p:style>
+        <p:txBody>
+          <a:bodyPr rtlCol="0" anchor="ctr"/>
+          <a:lstStyle/>
+          <a:p>
+            <a:pPr algn="ctr"/>
+          </a:p>
+        </p:txBody>
+      </p:sp>
+      <p:pic>
+        <p:nvPicPr>
+          <p:cNvPr id="13" name="Row icon 1" descr="Row icon 1"/>
+          <p:cNvPicPr>
+            <a:picLocks noChangeAspect="1"/>
+          </p:cNvPicPr>
+          <p:nvPr/>
+        </p:nvPicPr>
+        <p:blipFill>
+          <a:blip r:embed="rId2"/>
+          <a:stretch>
+            <a:fillRect/>
+          </a:stretch>
+        </p:blipFill>
+        <p:spPr>
+          <a:xfrm>
+            <a:off x="1344168" y="3008376"/>
+            <a:ext cx="237744" cy="237744"/>
+          </a:xfrm>
+          <a:prstGeom prst="rect">
+            <a:avLst/>
+          </a:prstGeom>
+        </p:spPr>
+      </p:pic>
+      <p:sp>
+        <p:nvSpPr>
+          <p:cNvPr id="14" name="Row text 1"/>
+          <p:cNvSpPr txBox="1"/>
+          <p:nvPr/>
+        </p:nvSpPr>
+        <p:spPr>
+          <a:xfrm>
+            <a:off x="1874519" y="2880360"/>
+            <a:ext cx="4023360" cy="530352"/>
+          </a:xfrm>
+          <a:prstGeom prst="rect">
+            <a:avLst/>
+          </a:prstGeom>
+          <a:noFill/>
+        </p:spPr>
+        <p:txBody>
+          <a:bodyPr wrap="square" lIns="0" rIns="0" tIns="0" bIns="0" anchor="t">
+            <a:spAutoFit/>
+          </a:bodyPr>
+          <a:lstStyle/>
+          <a:p>
+            <a:r>
+              <a:rPr sz="1400" b="1" i="0">
+                <a:solidFill>
+                  <a:srgbClr val="153243"/>
+                </a:solidFill>
+                <a:latin typeface="Source Sans Pro"/>
+              </a:rPr>
+              <a:t>Hire great people</a:t>
+            </a:r>
+          </a:p>
+          <a:p>
+            <a:r>
+              <a:rPr sz="1200" b="0" i="0">
+                <a:solidFill>
+                  <a:srgbClr val="153243"/>
+                </a:solidFill>
+                <a:latin typeface="Source Sans Pro"/>
+              </a:rPr>
+              <a:t>Get ahead of capacity constraints</a:t>
+            </a:r>
+          </a:p>
+        </p:txBody>
+      </p:sp>
+      <p:sp>
+        <p:nvSpPr>
+          <p:cNvPr id="15" name="Row icon 2 circle"/>
+          <p:cNvSpPr/>
+          <p:nvPr/>
+        </p:nvSpPr>
+        <p:spPr>
+          <a:xfrm>
+            <a:off x="1234440" y="3483864"/>
+            <a:ext cx="457200" cy="457200"/>
+          </a:xfrm>
+          <a:prstGeom prst="ellipse">
+            <a:avLst/>
+          </a:prstGeom>
+          <a:solidFill>
+            <a:srgbClr val="FFFFFF"/>
+          </a:solidFill>
+          <a:ln>
+            <a:noFill/>
+          </a:ln>
+          <a:effectLst/>
+        </p:spPr>
+        <p:style>
+          <a:lnRef idx="1">
+            <a:schemeClr val="accent1"/>
+          </a:lnRef>
+          <a:fillRef idx="3">
+            <a:schemeClr val="accent1"/>
+          </a:fillRef>
+          <a:effectRef idx="2">
+            <a:schemeClr val="accent1"/>
+          </a:effectRef>
+          <a:fontRef idx="minor">
+            <a:schemeClr val="lt1"/>
+          </a:fontRef>
+        </p:style>
+        <p:txBody>
+          <a:bodyPr rtlCol="0" anchor="ctr"/>
+          <a:lstStyle/>
+          <a:p>
+            <a:pPr algn="ctr"/>
+          </a:p>
+        </p:txBody>
+      </p:sp>
+      <p:pic>
+        <p:nvPicPr>
+          <p:cNvPr id="16" name="Row icon 2" descr="Row icon 2"/>
+          <p:cNvPicPr>
+            <a:picLocks noChangeAspect="1"/>
+          </p:cNvPicPr>
+          <p:nvPr/>
+        </p:nvPicPr>
+        <p:blipFill>
+          <a:blip r:embed="rId3"/>
+          <a:stretch>
+            <a:fillRect/>
+          </a:stretch>
+        </p:blipFill>
+        <p:spPr>
+          <a:xfrm>
+            <a:off x="1344168" y="3593592"/>
+            <a:ext cx="237744" cy="237744"/>
+          </a:xfrm>
+          <a:prstGeom prst="rect">
+            <a:avLst/>
+          </a:prstGeom>
+        </p:spPr>
+      </p:pic>
+      <p:sp>
+        <p:nvSpPr>
+          <p:cNvPr id="17" name="Row text 2"/>
+          <p:cNvSpPr txBox="1"/>
+          <p:nvPr/>
+        </p:nvSpPr>
+        <p:spPr>
+          <a:xfrm>
+            <a:off x="1874519" y="3465576"/>
+            <a:ext cx="4023360" cy="530352"/>
+          </a:xfrm>
+          <a:prstGeom prst="rect">
+            <a:avLst/>
+          </a:prstGeom>
+          <a:noFill/>
+        </p:spPr>
+        <p:txBody>
+          <a:bodyPr wrap="square" lIns="0" rIns="0" tIns="0" bIns="0" anchor="t">
+            <a:spAutoFit/>
+          </a:bodyPr>
+          <a:lstStyle/>
+          <a:p>
+            <a:r>
+              <a:rPr sz="1400" b="1" i="0">
+                <a:solidFill>
+                  <a:srgbClr val="153243"/>
+                </a:solidFill>
+                <a:latin typeface="Source Sans Pro"/>
+              </a:rPr>
+              <a:t>Build consistent processes</a:t>
+            </a:r>
+          </a:p>
+          <a:p>
+            <a:r>
+              <a:rPr sz="1200" b="0" i="0">
+                <a:solidFill>
+                  <a:srgbClr val="153243"/>
+                </a:solidFill>
+                <a:latin typeface="Source Sans Pro"/>
+              </a:rPr>
+              <a:t>Make the way we work repeatable</a:t>
+            </a:r>
+          </a:p>
+        </p:txBody>
+      </p:sp>
+      <p:sp>
+        <p:nvSpPr>
+          <p:cNvPr id="18" name="Row icon 3 circle"/>
+          <p:cNvSpPr/>
+          <p:nvPr/>
+        </p:nvSpPr>
+        <p:spPr>
+          <a:xfrm>
+            <a:off x="1234440" y="4069079"/>
+            <a:ext cx="457200" cy="457200"/>
+          </a:xfrm>
+          <a:prstGeom prst="ellipse">
+            <a:avLst/>
+          </a:prstGeom>
+          <a:solidFill>
+            <a:srgbClr val="FFFFFF"/>
+          </a:solidFill>
+          <a:ln>
+            <a:noFill/>
+          </a:ln>
+          <a:effectLst/>
+        </p:spPr>
+        <p:style>
+          <a:lnRef idx="1">
+            <a:schemeClr val="accent1"/>
+          </a:lnRef>
+          <a:fillRef idx="3">
+            <a:schemeClr val="accent1"/>
+          </a:fillRef>
+          <a:effectRef idx="2">
+            <a:schemeClr val="accent1"/>
+          </a:effectRef>
+          <a:fontRef idx="minor">
+            <a:schemeClr val="lt1"/>
+          </a:fontRef>
+        </p:style>
+        <p:txBody>
+          <a:bodyPr rtlCol="0" anchor="ctr"/>
+          <a:lstStyle/>
+          <a:p>
+            <a:pPr algn="ctr"/>
+          </a:p>
+        </p:txBody>
+      </p:sp>
+      <p:pic>
+        <p:nvPicPr>
+          <p:cNvPr id="19" name="Row icon 3" descr="Row icon 3"/>
+          <p:cNvPicPr>
+            <a:picLocks noChangeAspect="1"/>
+          </p:cNvPicPr>
+          <p:nvPr/>
+        </p:nvPicPr>
+        <p:blipFill>
+          <a:blip r:embed="rId4"/>
+          <a:stretch>
+            <a:fillRect/>
+          </a:stretch>
+        </p:blipFill>
+        <p:spPr>
+          <a:xfrm>
+            <a:off x="1344168" y="4178807"/>
+            <a:ext cx="237744" cy="237744"/>
+          </a:xfrm>
+          <a:prstGeom prst="rect">
+            <a:avLst/>
+          </a:prstGeom>
+        </p:spPr>
+      </p:pic>
+      <p:sp>
+        <p:nvSpPr>
+          <p:cNvPr id="20" name="Row text 3"/>
+          <p:cNvSpPr txBox="1"/>
+          <p:nvPr/>
+        </p:nvSpPr>
+        <p:spPr>
+          <a:xfrm>
+            <a:off x="1874519" y="4050791"/>
+            <a:ext cx="4023360" cy="530352"/>
+          </a:xfrm>
+          <a:prstGeom prst="rect">
+            <a:avLst/>
+          </a:prstGeom>
+          <a:noFill/>
+        </p:spPr>
+        <p:txBody>
+          <a:bodyPr wrap="square" lIns="0" rIns="0" tIns="0" bIns="0" anchor="t">
+            <a:spAutoFit/>
+          </a:bodyPr>
+          <a:lstStyle/>
+          <a:p>
+            <a:r>
+              <a:rPr sz="1400" b="1" i="0">
+                <a:solidFill>
+                  <a:srgbClr val="153243"/>
+                </a:solidFill>
+                <a:latin typeface="Source Sans Pro"/>
+              </a:rPr>
+              <a:t>Use technology</a:t>
+            </a:r>
+          </a:p>
+          <a:p>
+            <a:r>
+              <a:rPr sz="1200" b="0" i="0">
+                <a:solidFill>
+                  <a:srgbClr val="153243"/>
+                </a:solidFill>
+                <a:latin typeface="Source Sans Pro"/>
+              </a:rPr>
+              <a:t>More time on work that needs your expertise</a:t>
+            </a:r>
+          </a:p>
+        </p:txBody>
+      </p:sp>
+      <p:sp>
+        <p:nvSpPr>
+          <p:cNvPr id="21" name="Row icon 4 circle"/>
+          <p:cNvSpPr/>
+          <p:nvPr/>
+        </p:nvSpPr>
+        <p:spPr>
+          <a:xfrm>
+            <a:off x="1234440" y="4654296"/>
+            <a:ext cx="457200" cy="457200"/>
+          </a:xfrm>
+          <a:prstGeom prst="ellipse">
+            <a:avLst/>
+          </a:prstGeom>
+          <a:solidFill>
+            <a:srgbClr val="FFFFFF"/>
+          </a:solidFill>
+          <a:ln>
+            <a:noFill/>
+          </a:ln>
+          <a:effectLst/>
+        </p:spPr>
+        <p:style>
+          <a:lnRef idx="1">
+            <a:schemeClr val="accent1"/>
+          </a:lnRef>
+          <a:fillRef idx="3">
+            <a:schemeClr val="accent1"/>
+          </a:fillRef>
+          <a:effectRef idx="2">
+            <a:schemeClr val="accent1"/>
+          </a:effectRef>
+          <a:fontRef idx="minor">
+            <a:schemeClr val="lt1"/>
+          </a:fontRef>
+        </p:style>
+        <p:txBody>
+          <a:bodyPr rtlCol="0" anchor="ctr"/>
+          <a:lstStyle/>
+          <a:p>
+            <a:pPr algn="ctr"/>
+          </a:p>
+        </p:txBody>
+      </p:sp>
+      <p:pic>
+        <p:nvPicPr>
+          <p:cNvPr id="22" name="Row icon 4" descr="Row icon 4"/>
+          <p:cNvPicPr>
+            <a:picLocks noChangeAspect="1"/>
+          </p:cNvPicPr>
+          <p:nvPr/>
+        </p:nvPicPr>
+        <p:blipFill>
+          <a:blip r:embed="rId5"/>
+          <a:stretch>
+            <a:fillRect/>
+          </a:stretch>
+        </p:blipFill>
+        <p:spPr>
+          <a:xfrm>
+            <a:off x="1344168" y="4764024"/>
+            <a:ext cx="237744" cy="237744"/>
+          </a:xfrm>
+          <a:prstGeom prst="rect">
+            <a:avLst/>
+          </a:prstGeom>
+        </p:spPr>
+      </p:pic>
+      <p:sp>
+        <p:nvSpPr>
+          <p:cNvPr id="23" name="Row text 4"/>
+          <p:cNvSpPr txBox="1"/>
+          <p:nvPr/>
+        </p:nvSpPr>
+        <p:spPr>
+          <a:xfrm>
+            <a:off x="1874519" y="4636008"/>
+            <a:ext cx="4023360" cy="530352"/>
+          </a:xfrm>
+          <a:prstGeom prst="rect">
+            <a:avLst/>
+          </a:prstGeom>
+          <a:noFill/>
+        </p:spPr>
+        <p:txBody>
+          <a:bodyPr wrap="square" lIns="0" rIns="0" tIns="0" bIns="0" anchor="t">
+            <a:spAutoFit/>
+          </a:bodyPr>
+          <a:lstStyle/>
+          <a:p>
+            <a:r>
+              <a:rPr sz="1400" b="1" i="0">
+                <a:solidFill>
+                  <a:srgbClr val="153243"/>
+                </a:solidFill>
+                <a:latin typeface="Source Sans Pro"/>
+              </a:rPr>
+              <a:t>Delegate and elevate</a:t>
+            </a:r>
+          </a:p>
+          <a:p>
+            <a:r>
+              <a:rPr sz="1200" b="0" i="0">
+                <a:solidFill>
+                  <a:srgbClr val="153243"/>
+                </a:solidFill>
+                <a:latin typeface="Source Sans Pro"/>
+              </a:rPr>
+              <a:t>What should each person own, and what can move?</a:t>
+            </a:r>
+          </a:p>
+        </p:txBody>
+      </p:sp>
+      <p:sp>
+        <p:nvSpPr>
+          <p:cNvPr id="24" name="How EOS connects it panel"/>
+          <p:cNvSpPr/>
+          <p:nvPr/>
+        </p:nvSpPr>
+        <p:spPr>
+          <a:xfrm>
+            <a:off x="6291072" y="1920240"/>
+            <a:ext cx="5029200" cy="3337560"/>
+          </a:xfrm>
+          <a:prstGeom prst="roundRect">
+            <a:avLst>
+              <a:gd name="adj" fmla="val 4000"/>
+            </a:avLst>
+          </a:prstGeom>
+          <a:solidFill>
+            <a:srgbClr val="EDECED"/>
+          </a:solidFill>
+          <a:ln>
+            <a:noFill/>
+          </a:ln>
+          <a:effectLst/>
+        </p:spPr>
+        <p:style>
+          <a:lnRef idx="1">
+            <a:schemeClr val="accent1"/>
+          </a:lnRef>
+          <a:fillRef idx="3">
+            <a:schemeClr val="accent1"/>
+          </a:fillRef>
+          <a:effectRef idx="2">
+            <a:schemeClr val="accent1"/>
+          </a:effectRef>
+          <a:fontRef idx="minor">
+            <a:schemeClr val="lt1"/>
+          </a:fontRef>
+        </p:style>
+        <p:txBody>
+          <a:bodyPr rtlCol="0" anchor="ctr"/>
+          <a:lstStyle/>
+          <a:p>
+            <a:pPr algn="ctr"/>
+          </a:p>
+        </p:txBody>
+      </p:sp>
+      <p:sp>
+        <p:nvSpPr>
+          <p:cNvPr id="25" name="How EOS connects it header"/>
+          <p:cNvSpPr txBox="1"/>
+          <p:nvPr/>
+        </p:nvSpPr>
+        <p:spPr>
+          <a:xfrm>
+            <a:off x="6565392" y="2103120"/>
+            <a:ext cx="4480560" cy="292608"/>
+          </a:xfrm>
+          <a:prstGeom prst="rect">
+            <a:avLst/>
+          </a:prstGeom>
+          <a:noFill/>
+        </p:spPr>
+        <p:txBody>
+          <a:bodyPr wrap="square" lIns="0" rIns="0" tIns="0" bIns="0" anchor="t">
+            <a:spAutoFit/>
+          </a:bodyPr>
+          <a:lstStyle/>
+          <a:p>
+            <a:r>
+              <a:rPr sz="1800" b="1" i="0">
+                <a:solidFill>
+                  <a:srgbClr val="153243"/>
+                </a:solidFill>
+                <a:latin typeface="Source Sans Pro"/>
+              </a:rPr>
+              <a:t>How EOS connects it</a:t>
+            </a:r>
+          </a:p>
+        </p:txBody>
+      </p:sp>
+      <p:sp>
+        <p:nvSpPr>
+          <p:cNvPr id="26" name="How EOS connects it subhead"/>
+          <p:cNvSpPr txBox="1"/>
+          <p:nvPr/>
+        </p:nvSpPr>
+        <p:spPr>
+          <a:xfrm>
+            <a:off x="6565392" y="2395728"/>
+            <a:ext cx="4480560" cy="274320"/>
+          </a:xfrm>
+          <a:prstGeom prst="rect">
+            <a:avLst/>
+          </a:prstGeom>
+          <a:noFill/>
+        </p:spPr>
+        <p:txBody>
+          <a:bodyPr wrap="square" lIns="0" rIns="0" tIns="0" bIns="0" anchor="t">
+            <a:spAutoFit/>
+          </a:bodyPr>
+          <a:lstStyle/>
+          <a:p>
+            <a:r>
+              <a:rPr sz="1300" b="0" i="0">
+                <a:solidFill>
+                  <a:srgbClr val="366E8E"/>
+                </a:solidFill>
+                <a:latin typeface="Source Sans Pro"/>
+              </a:rPr>
+              <a:t>Three tools, one rhythm</a:t>
+            </a:r>
+          </a:p>
+        </p:txBody>
+      </p:sp>
+      <p:sp>
+        <p:nvSpPr>
+          <p:cNvPr id="27" name="Row icon 1 circle"/>
+          <p:cNvSpPr/>
+          <p:nvPr/>
+        </p:nvSpPr>
+        <p:spPr>
+          <a:xfrm>
+            <a:off x="6565392" y="2898648"/>
+            <a:ext cx="457200" cy="457200"/>
+          </a:xfrm>
+          <a:prstGeom prst="ellipse">
+            <a:avLst/>
+          </a:prstGeom>
+          <a:solidFill>
+            <a:srgbClr val="FFFFFF"/>
+          </a:solidFill>
+          <a:ln>
+            <a:noFill/>
+          </a:ln>
+          <a:effectLst/>
+        </p:spPr>
+        <p:style>
+          <a:lnRef idx="1">
+            <a:schemeClr val="accent1"/>
+          </a:lnRef>
+          <a:fillRef idx="3">
+            <a:schemeClr val="accent1"/>
+          </a:fillRef>
+          <a:effectRef idx="2">
+            <a:schemeClr val="accent1"/>
+          </a:effectRef>
+          <a:fontRef idx="minor">
+            <a:schemeClr val="lt1"/>
+          </a:fontRef>
+        </p:style>
+        <p:txBody>
+          <a:bodyPr rtlCol="0" anchor="ctr"/>
+          <a:lstStyle/>
+          <a:p>
+            <a:pPr algn="ctr"/>
+          </a:p>
+        </p:txBody>
+      </p:sp>
+      <p:pic>
+        <p:nvPicPr>
+          <p:cNvPr id="28" name="Row icon 1" descr="Row icon 1"/>
+          <p:cNvPicPr>
+            <a:picLocks noChangeAspect="1"/>
+          </p:cNvPicPr>
+          <p:nvPr/>
+        </p:nvPicPr>
+        <p:blipFill>
+          <a:blip r:embed="rId6"/>
+          <a:stretch>
+            <a:fillRect/>
+          </a:stretch>
+        </p:blipFill>
+        <p:spPr>
+          <a:xfrm>
+            <a:off x="6675120" y="3008376"/>
+            <a:ext cx="237744" cy="237744"/>
+          </a:xfrm>
+          <a:prstGeom prst="rect">
+            <a:avLst/>
+          </a:prstGeom>
+        </p:spPr>
+      </p:pic>
+      <p:sp>
+        <p:nvSpPr>
+          <p:cNvPr id="29" name="Row text 1"/>
+          <p:cNvSpPr txBox="1"/>
+          <p:nvPr/>
+        </p:nvSpPr>
+        <p:spPr>
+          <a:xfrm>
+            <a:off x="7205472" y="2880360"/>
+            <a:ext cx="4023360" cy="530352"/>
+          </a:xfrm>
+          <a:prstGeom prst="rect">
+            <a:avLst/>
+          </a:prstGeom>
+          <a:noFill/>
+        </p:spPr>
+        <p:txBody>
+          <a:bodyPr wrap="square" lIns="0" rIns="0" tIns="0" bIns="0" anchor="t">
+            <a:spAutoFit/>
+          </a:bodyPr>
+          <a:lstStyle/>
+          <a:p>
+            <a:r>
+              <a:rPr sz="1400" b="1" i="0">
+                <a:solidFill>
+                  <a:srgbClr val="153243"/>
+                </a:solidFill>
+                <a:latin typeface="Source Sans Pro"/>
+              </a:rPr>
+              <a:t>Scorecards</a:t>
+            </a:r>
+          </a:p>
+          <a:p>
+            <a:r>
+              <a:rPr sz="1200" b="0" i="0">
+                <a:solidFill>
+                  <a:srgbClr val="153243"/>
+                </a:solidFill>
+                <a:latin typeface="Source Sans Pro"/>
+              </a:rPr>
+              <a:t>Show us where attention is needed</a:t>
+            </a:r>
+          </a:p>
+        </p:txBody>
+      </p:sp>
+      <p:sp>
+        <p:nvSpPr>
+          <p:cNvPr id="30" name="Row icon 2 circle"/>
+          <p:cNvSpPr/>
+          <p:nvPr/>
+        </p:nvSpPr>
+        <p:spPr>
+          <a:xfrm>
+            <a:off x="6565392" y="3630168"/>
+            <a:ext cx="457200" cy="457200"/>
+          </a:xfrm>
+          <a:prstGeom prst="ellipse">
+            <a:avLst/>
+          </a:prstGeom>
+          <a:solidFill>
+            <a:srgbClr val="FFFFFF"/>
+          </a:solidFill>
+          <a:ln>
+            <a:noFill/>
+          </a:ln>
+          <a:effectLst/>
+        </p:spPr>
+        <p:style>
+          <a:lnRef idx="1">
+            <a:schemeClr val="accent1"/>
+          </a:lnRef>
+          <a:fillRef idx="3">
+            <a:schemeClr val="accent1"/>
+          </a:fillRef>
+          <a:effectRef idx="2">
+            <a:schemeClr val="accent1"/>
+          </a:effectRef>
+          <a:fontRef idx="minor">
+            <a:schemeClr val="lt1"/>
+          </a:fontRef>
+        </p:style>
+        <p:txBody>
+          <a:bodyPr rtlCol="0" anchor="ctr"/>
+          <a:lstStyle/>
+          <a:p>
+            <a:pPr algn="ctr"/>
+          </a:p>
+        </p:txBody>
+      </p:sp>
+      <p:pic>
+        <p:nvPicPr>
+          <p:cNvPr id="31" name="Row icon 2" descr="Row icon 2"/>
+          <p:cNvPicPr>
+            <a:picLocks noChangeAspect="1"/>
+          </p:cNvPicPr>
+          <p:nvPr/>
+        </p:nvPicPr>
+        <p:blipFill>
+          <a:blip r:embed="rId7"/>
+          <a:stretch>
+            <a:fillRect/>
+          </a:stretch>
+        </p:blipFill>
+        <p:spPr>
+          <a:xfrm>
+            <a:off x="6675120" y="3739896"/>
+            <a:ext cx="237744" cy="237744"/>
+          </a:xfrm>
+          <a:prstGeom prst="rect">
+            <a:avLst/>
+          </a:prstGeom>
+        </p:spPr>
+      </p:pic>
+      <p:sp>
+        <p:nvSpPr>
+          <p:cNvPr id="32" name="Row text 2"/>
+          <p:cNvSpPr txBox="1"/>
+          <p:nvPr/>
+        </p:nvSpPr>
+        <p:spPr>
+          <a:xfrm>
+            <a:off x="7205472" y="3611880"/>
+            <a:ext cx="4023360" cy="530352"/>
+          </a:xfrm>
+          <a:prstGeom prst="rect">
+            <a:avLst/>
+          </a:prstGeom>
+          <a:noFill/>
+        </p:spPr>
+        <p:txBody>
+          <a:bodyPr wrap="square" lIns="0" rIns="0" tIns="0" bIns="0" anchor="t">
+            <a:spAutoFit/>
+          </a:bodyPr>
+          <a:lstStyle/>
+          <a:p>
+            <a:r>
+              <a:rPr sz="1400" b="1" i="0">
+                <a:solidFill>
+                  <a:srgbClr val="153243"/>
+                </a:solidFill>
+                <a:latin typeface="Source Sans Pro"/>
+              </a:rPr>
+              <a:t>L10s</a:t>
+            </a:r>
+          </a:p>
+          <a:p>
+            <a:r>
+              <a:rPr sz="1200" b="0" i="0">
+                <a:solidFill>
+                  <a:srgbClr val="153243"/>
+                </a:solidFill>
+                <a:latin typeface="Source Sans Pro"/>
+              </a:rPr>
+              <a:t>Help us understand and solve the underlying issues</a:t>
+            </a:r>
+          </a:p>
+        </p:txBody>
+      </p:sp>
+      <p:sp>
+        <p:nvSpPr>
+          <p:cNvPr id="33" name="Row icon 3 circle"/>
+          <p:cNvSpPr/>
+          <p:nvPr/>
+        </p:nvSpPr>
+        <p:spPr>
+          <a:xfrm>
+            <a:off x="6565392" y="4361688"/>
+            <a:ext cx="457200" cy="457200"/>
+          </a:xfrm>
+          <a:prstGeom prst="ellipse">
+            <a:avLst/>
+          </a:prstGeom>
+          <a:solidFill>
+            <a:srgbClr val="FFFFFF"/>
+          </a:solidFill>
+          <a:ln>
+            <a:noFill/>
+          </a:ln>
+          <a:effectLst/>
+        </p:spPr>
+        <p:style>
+          <a:lnRef idx="1">
+            <a:schemeClr val="accent1"/>
+          </a:lnRef>
+          <a:fillRef idx="3">
+            <a:schemeClr val="accent1"/>
+          </a:fillRef>
+          <a:effectRef idx="2">
+            <a:schemeClr val="accent1"/>
+          </a:effectRef>
+          <a:fontRef idx="minor">
+            <a:schemeClr val="lt1"/>
+          </a:fontRef>
+        </p:style>
+        <p:txBody>
+          <a:bodyPr rtlCol="0" anchor="ctr"/>
+          <a:lstStyle/>
+          <a:p>
+            <a:pPr algn="ctr"/>
+          </a:p>
+        </p:txBody>
+      </p:sp>
+      <p:pic>
+        <p:nvPicPr>
+          <p:cNvPr id="34" name="Row icon 3" descr="Row icon 3"/>
+          <p:cNvPicPr>
+            <a:picLocks noChangeAspect="1"/>
+          </p:cNvPicPr>
+          <p:nvPr/>
+        </p:nvPicPr>
+        <p:blipFill>
+          <a:blip r:embed="rId8"/>
+          <a:stretch>
+            <a:fillRect/>
+          </a:stretch>
+        </p:blipFill>
+        <p:spPr>
+          <a:xfrm>
+            <a:off x="6675120" y="4471416"/>
+            <a:ext cx="237744" cy="237744"/>
+          </a:xfrm>
+          <a:prstGeom prst="rect">
+            <a:avLst/>
+          </a:prstGeom>
+        </p:spPr>
+      </p:pic>
+      <p:sp>
+        <p:nvSpPr>
+          <p:cNvPr id="35" name="Row text 3"/>
+          <p:cNvSpPr txBox="1"/>
+          <p:nvPr/>
+        </p:nvSpPr>
+        <p:spPr>
+          <a:xfrm>
+            <a:off x="7205472" y="4343400"/>
+            <a:ext cx="4023360" cy="530352"/>
+          </a:xfrm>
+          <a:prstGeom prst="rect">
+            <a:avLst/>
+          </a:prstGeom>
+          <a:noFill/>
+        </p:spPr>
+        <p:txBody>
+          <a:bodyPr wrap="square" lIns="0" rIns="0" tIns="0" bIns="0" anchor="t">
+            <a:spAutoFit/>
+          </a:bodyPr>
+          <a:lstStyle/>
+          <a:p>
+            <a:r>
+              <a:rPr sz="1400" b="1" i="0">
+                <a:solidFill>
+                  <a:srgbClr val="153243"/>
+                </a:solidFill>
+                <a:latin typeface="Source Sans Pro"/>
+              </a:rPr>
+              <a:t>Rocks</a:t>
+            </a:r>
+          </a:p>
+          <a:p>
+            <a:r>
+              <a:rPr sz="1200" b="0" i="0">
+                <a:solidFill>
+                  <a:srgbClr val="153243"/>
+                </a:solidFill>
+                <a:latin typeface="Source Sans Pro"/>
+              </a:rPr>
+              <a:t>Move the most important improvements forward</a:t>
+            </a:r>
+          </a:p>
+        </p:txBody>
+      </p:sp>
+      <p:sp>
+        <p:nvSpPr>
+          <p:cNvPr id="36" name="Bottom line card"/>
+          <p:cNvSpPr/>
+          <p:nvPr/>
+        </p:nvSpPr>
+        <p:spPr>
+          <a:xfrm>
+            <a:off x="960120" y="5440680"/>
+            <a:ext cx="10360152" cy="548640"/>
+          </a:xfrm>
+          <a:prstGeom prst="roundRect">
+            <a:avLst>
+              <a:gd name="adj" fmla="val 8000"/>
+            </a:avLst>
+          </a:prstGeom>
+          <a:solidFill>
+            <a:srgbClr val="366E8E"/>
+          </a:solidFill>
+          <a:ln>
+            <a:noFill/>
+          </a:ln>
+          <a:effectLst/>
+        </p:spPr>
+        <p:style>
+          <a:lnRef idx="1">
+            <a:schemeClr val="accent1"/>
+          </a:lnRef>
+          <a:fillRef idx="3">
+            <a:schemeClr val="accent1"/>
+          </a:fillRef>
+          <a:effectRef idx="2">
+            <a:schemeClr val="accent1"/>
+          </a:effectRef>
+          <a:fontRef idx="minor">
+            <a:schemeClr val="lt1"/>
+          </a:fontRef>
+        </p:style>
+        <p:txBody>
+          <a:bodyPr rtlCol="0" anchor="ctr"/>
+          <a:lstStyle/>
+          <a:p>
+            <a:pPr algn="ctr"/>
+          </a:p>
+        </p:txBody>
+      </p:sp>
+      <p:sp>
+        <p:nvSpPr>
+          <p:cNvPr id="37" name="Bottom line text"/>
+          <p:cNvSpPr txBox="1"/>
+          <p:nvPr/>
+        </p:nvSpPr>
+        <p:spPr>
+          <a:xfrm>
+            <a:off x="1188720" y="5440680"/>
+            <a:ext cx="9902952" cy="548640"/>
+          </a:xfrm>
+          <a:prstGeom prst="rect">
+            <a:avLst/>
+          </a:prstGeom>
+          <a:noFill/>
+        </p:spPr>
+        <p:txBody>
+          <a:bodyPr wrap="square" lIns="0" rIns="0" tIns="0" bIns="0" anchor="ctr">
+            <a:spAutoFit/>
+          </a:bodyPr>
+          <a:lstStyle/>
+          <a:p>
+            <a:r>
+              <a:rPr sz="1200" b="1" i="0" spc="150">
+                <a:solidFill>
+                  <a:srgbClr val="FFC666"/>
+                </a:solidFill>
+                <a:latin typeface="Source Sans Pro"/>
+              </a:rPr>
+              <a:t>THE BOTTOM LINE   </a:t>
+            </a:r>
+            <a:r>
+              <a:rPr sz="1400" b="0" i="0">
+                <a:solidFill>
+                  <a:srgbClr val="FFFFFF"/>
+                </a:solidFill>
+                <a:latin typeface="Source Sans Pro"/>
+              </a:rPr>
+              <a:t>Retention remains a challenge. Bring the same focus to keeping clients as to winning them.</a:t>
+            </a:r>
+          </a:p>
+        </p:txBody>
+      </p:sp>
+    </p:spTree>
+    <p:extLst>
+      <p:ext uri="{BB962C8B-B14F-4D97-AF65-F5344CB8AC3E}">
+        <p14:creationId xmlns:p14="http://schemas.microsoft.com/office/powerpoint/2010/main" val="3739547963"/>
+      </p:ext>
+    </p:extLst>
+  </p:cSld>
+  <p:clrMapOvr>
+    <a:masterClrMapping/>
+  </p:clrMapOvr>
+  <mc:AlternateContent xmlns:mc="http://schemas.openxmlformats.org/markup-compatibility/2006" xmlns:p159="http://schemas.microsoft.com/office/powerpoint/2015/09/main">
+    <mc:Choice Requires="p159">
+      <p:transition xmlns:p14="http://schemas.microsoft.com/office/powerpoint/2010/main" spd="slow" p14:dur="2000">
+        <p159:morph option="byObject"/>
+      </p:transition>
+    </mc:Choice>
+    <mc:Fallback xmlns="">
+      <p:transition spd="slow">
+        <p:fade/>
+      </p:transition>
+    </mc:Fallback>
+  </mc:AlternateContent>
+</p:sld>
+</file>
+
+<file path=ppt/slides/slide6.xml><?xml version="1.0" encoding="utf-8"?>
+<p:sld xmlns:a="http://schemas.openxmlformats.org/drawingml/2006/main" xmlns:r="http://schemas.openxmlformats.org/officeDocument/2006/relationships" xmlns:p="http://schemas.openxmlformats.org/presentationml/2006/main">
+  <p:cSld>
+    <p:spTree>
+      <p:nvGrpSpPr>
+        <p:cNvPr id="1" name="">
+          <a:extLst>
+            <a:ext uri="{FF2B5EF4-FFF2-40B4-BE49-F238E27FC236}">
+              <a16:creationId xmlns:a16="http://schemas.microsoft.com/office/drawing/2014/main" id="{3CC0E2FD-837D-9753-CF85-B96BB0ED339A}"/>
+            </a:ext>
+          </a:extLst>
+        </p:cNvPr>
+        <p:cNvGrpSpPr/>
+        <p:nvPr/>
+      </p:nvGrpSpPr>
+      <p:grpSpPr>
+        <a:xfrm>
+          <a:off x="0" y="0"/>
+          <a:ext cx="0" cy="0"/>
+          <a:chOff x="0" y="0"/>
+          <a:chExt cx="0" cy="0"/>
+        </a:xfrm>
+      </p:grpSpPr>
+      <p:sp>
+        <p:nvSpPr>
+          <p:cNvPr id="4" name="TextBox 3">
+            <a:extLst>
+              <a:ext uri="{FF2B5EF4-FFF2-40B4-BE49-F238E27FC236}">
+                <a16:creationId xmlns:a16="http://schemas.microsoft.com/office/drawing/2014/main" id="{D52C6772-D662-5D65-1798-38644B18B7E5}"/>
+              </a:ext>
+            </a:extLst>
+          </p:cNvPr>
+          <p:cNvSpPr txBox="1"/>
+          <p:nvPr/>
+        </p:nvSpPr>
+        <p:spPr>
+          <a:xfrm>
+            <a:off x="875347" y="368336"/>
+            <a:ext cx="10447973" cy="584775"/>
+          </a:xfrm>
+          <a:prstGeom prst="rect">
+            <a:avLst/>
+          </a:prstGeom>
+          <a:noFill/>
+        </p:spPr>
+        <p:txBody>
+          <a:bodyPr wrap="square" rtlCol="0">
+            <a:spAutoFit/>
+          </a:bodyPr>
+          <a:lstStyle/>
+          <a:p>
+            <a:pPr marL="0" marR="0" lvl="0" indent="0" algn="l" defTabSz="914400" rtl="0" eaLnBrk="1" fontAlgn="auto" latinLnBrk="0" hangingPunct="1">
+              <a:lnSpc>
+                <a:spcPct val="100000"/>
+              </a:lnSpc>
+              <a:spcBef>
+                <a:spcPts val="0"/>
+              </a:spcBef>
+              <a:spcAft>
+                <a:spcPts val="0"/>
+              </a:spcAft>
+              <a:buClrTx/>
+              <a:buSzTx/>
+              <a:buFontTx/>
+              <a:buNone/>
+              <a:tabLst/>
+              <a:defRPr/>
+            </a:pPr>
+            <a:r>
+              <a:rPr kumimoji="0" lang="en-US" sz="3200" b="1" i="1" u="none" strike="noStrike" kern="1200" cap="none" spc="0" normalizeH="0" baseline="0" noProof="0" dirty="0">
+                <a:ln>
+                  <a:noFill/>
+                </a:ln>
+                <a:solidFill>
+                  <a:srgbClr val="EDECED"/>
+                </a:solidFill>
+                <a:effectLst/>
+                <a:uLnTx/>
+                <a:uFillTx/>
+                <a:latin typeface="Playfair Display" panose="00000500000000000000" pitchFamily="2" charset="0"/>
+                <a:ea typeface="+mn-ea"/>
+                <a:cs typeface="+mn-cs"/>
+              </a:rPr>
+              <a:t>What was harder than expected</a:t>
+            </a:r>
+          </a:p>
+        </p:txBody>
+      </p:sp>
+      <p:cxnSp>
+        <p:nvCxnSpPr>
+          <p:cNvPr id="6" name="Straight Connector 5">
+            <a:extLst>
+              <a:ext uri="{FF2B5EF4-FFF2-40B4-BE49-F238E27FC236}">
+                <a16:creationId xmlns:a16="http://schemas.microsoft.com/office/drawing/2014/main" id="{5E9116D3-F450-4A0A-4B24-450372B6DA92}"/>
+              </a:ext>
+            </a:extLst>
+          </p:cNvPr>
+          <p:cNvCxnSpPr>
+            <a:cxnSpLocks/>
+          </p:cNvCxnSpPr>
+          <p:nvPr/>
+        </p:nvCxnSpPr>
+        <p:spPr>
+          <a:xfrm>
+            <a:off x="963168" y="1060704"/>
+            <a:ext cx="10360152" cy="0"/>
+          </a:xfrm>
+          <a:prstGeom prst="line">
+            <a:avLst/>
+          </a:prstGeom>
+          <a:ln>
+            <a:solidFill>
+              <a:schemeClr val="accent3"/>
+            </a:solidFill>
+          </a:ln>
+        </p:spPr>
+        <p:style>
+          <a:lnRef idx="2">
+            <a:schemeClr val="accent3"/>
+          </a:lnRef>
+          <a:fillRef idx="0">
+            <a:schemeClr val="accent3"/>
+          </a:fillRef>
+          <a:effectRef idx="1">
+            <a:schemeClr val="accent3"/>
+          </a:effectRef>
+          <a:fontRef idx="minor">
+            <a:schemeClr val="tx1"/>
+          </a:fontRef>
+        </p:style>
+      </p:cxnSp>
+      <p:sp>
+        <p:nvSpPr>
+          <p:cNvPr id="7" name="Eyebrow"/>
+          <p:cNvSpPr txBox="1"/>
+          <p:nvPr/>
+        </p:nvSpPr>
+        <p:spPr>
+          <a:xfrm>
+            <a:off x="960120" y="1188720"/>
+            <a:ext cx="10360152" cy="228600"/>
+          </a:xfrm>
+          <a:prstGeom prst="rect">
+            <a:avLst/>
+          </a:prstGeom>
+          <a:noFill/>
+        </p:spPr>
+        <p:txBody>
+          <a:bodyPr wrap="square" lIns="0" rIns="0" tIns="0" bIns="0" anchor="t">
+            <a:spAutoFit/>
+          </a:bodyPr>
+          <a:lstStyle/>
+          <a:p>
+            <a:r>
+              <a:rPr sz="1200" b="1" i="0" spc="200">
+                <a:solidFill>
+                  <a:srgbClr val="8FB24E"/>
+                </a:solidFill>
+                <a:latin typeface="Source Sans Pro"/>
+              </a:rPr>
+              <a:t>LESSONS LEARNED</a:t>
+            </a:r>
+          </a:p>
+        </p:txBody>
+      </p:sp>
+      <p:sp>
+        <p:nvSpPr>
+          <p:cNvPr id="8" name="Subtitle"/>
+          <p:cNvSpPr txBox="1"/>
+          <p:nvPr/>
+        </p:nvSpPr>
+        <p:spPr>
+          <a:xfrm>
+            <a:off x="960120" y="1444752"/>
+            <a:ext cx="10360152" cy="320040"/>
+          </a:xfrm>
+          <a:prstGeom prst="rect">
+            <a:avLst/>
+          </a:prstGeom>
+          <a:noFill/>
+        </p:spPr>
+        <p:txBody>
+          <a:bodyPr wrap="square" lIns="0" rIns="0" tIns="0" bIns="0" anchor="t">
+            <a:spAutoFit/>
+          </a:bodyPr>
+          <a:lstStyle/>
+          <a:p>
+            <a:r>
+              <a:rPr sz="1600" b="0" i="0">
+                <a:solidFill>
+                  <a:srgbClr val="FFFFFF"/>
+                </a:solidFill>
+                <a:latin typeface="Source Sans Pro"/>
+              </a:rPr>
+              <a:t>Building the capacity and structure to keep pace while serving existing clients well.</a:t>
+            </a:r>
+          </a:p>
+        </p:txBody>
+      </p:sp>
+      <p:sp>
+        <p:nvSpPr>
+          <p:cNvPr id="9" name="Hiring card"/>
+          <p:cNvSpPr/>
+          <p:nvPr/>
+        </p:nvSpPr>
+        <p:spPr>
+          <a:xfrm>
+            <a:off x="960120" y="1920240"/>
+            <a:ext cx="3200400" cy="2468880"/>
+          </a:xfrm>
+          <a:prstGeom prst="roundRect">
+            <a:avLst>
+              <a:gd name="adj" fmla="val 5000"/>
+            </a:avLst>
+          </a:prstGeom>
+          <a:solidFill>
+            <a:srgbClr val="EDECED"/>
+          </a:solidFill>
+          <a:ln>
+            <a:noFill/>
+          </a:ln>
+          <a:effectLst/>
+        </p:spPr>
+        <p:style>
+          <a:lnRef idx="1">
+            <a:schemeClr val="accent1"/>
+          </a:lnRef>
+          <a:fillRef idx="3">
+            <a:schemeClr val="accent1"/>
+          </a:fillRef>
+          <a:effectRef idx="2">
+            <a:schemeClr val="accent1"/>
+          </a:effectRef>
+          <a:fontRef idx="minor">
+            <a:schemeClr val="lt1"/>
+          </a:fontRef>
+        </p:style>
+        <p:txBody>
+          <a:bodyPr rtlCol="0" anchor="ctr"/>
+          <a:lstStyle/>
+          <a:p>
+            <a:pPr algn="ctr"/>
+          </a:p>
+        </p:txBody>
+      </p:sp>
+      <p:sp>
+        <p:nvSpPr>
+          <p:cNvPr id="10" name="Hiring icon circle"/>
+          <p:cNvSpPr/>
+          <p:nvPr/>
+        </p:nvSpPr>
+        <p:spPr>
+          <a:xfrm>
+            <a:off x="1211580" y="2034540"/>
+            <a:ext cx="502920" cy="502920"/>
+          </a:xfrm>
+          <a:prstGeom prst="ellipse">
+            <a:avLst/>
+          </a:prstGeom>
+          <a:solidFill>
+            <a:srgbClr val="8FB24E"/>
+          </a:solidFill>
+          <a:ln>
+            <a:noFill/>
+          </a:ln>
+          <a:effectLst/>
+        </p:spPr>
+        <p:style>
+          <a:lnRef idx="1">
+            <a:schemeClr val="accent1"/>
+          </a:lnRef>
+          <a:fillRef idx="3">
+            <a:schemeClr val="accent1"/>
+          </a:fillRef>
+          <a:effectRef idx="2">
+            <a:schemeClr val="accent1"/>
+          </a:effectRef>
+          <a:fontRef idx="minor">
+            <a:schemeClr val="lt1"/>
+          </a:fontRef>
+        </p:style>
+        <p:txBody>
+          <a:bodyPr rtlCol="0" anchor="ctr"/>
+          <a:lstStyle/>
+          <a:p>
+            <a:pPr algn="ctr"/>
+          </a:p>
+        </p:txBody>
+      </p:sp>
+      <p:pic>
+        <p:nvPicPr>
+          <p:cNvPr id="11" name="Hiring icon" descr="Hiring icon"/>
+          <p:cNvPicPr>
+            <a:picLocks noChangeAspect="1"/>
+          </p:cNvPicPr>
+          <p:nvPr/>
+        </p:nvPicPr>
+        <p:blipFill>
+          <a:blip r:embed="rId2"/>
+          <a:stretch>
+            <a:fillRect/>
+          </a:stretch>
+        </p:blipFill>
+        <p:spPr>
+          <a:xfrm>
+            <a:off x="1332280" y="2155240"/>
+            <a:ext cx="261518" cy="261518"/>
+          </a:xfrm>
+          <a:prstGeom prst="rect">
+            <a:avLst/>
+          </a:prstGeom>
+        </p:spPr>
+      </p:pic>
+      <p:sp>
+        <p:nvSpPr>
+          <p:cNvPr id="12" name="Hiring header"/>
+          <p:cNvSpPr txBox="1"/>
+          <p:nvPr/>
+        </p:nvSpPr>
+        <p:spPr>
+          <a:xfrm>
+            <a:off x="1874519" y="2103120"/>
+            <a:ext cx="2103120" cy="365760"/>
+          </a:xfrm>
+          <a:prstGeom prst="rect">
+            <a:avLst/>
+          </a:prstGeom>
+          <a:noFill/>
+        </p:spPr>
+        <p:txBody>
+          <a:bodyPr wrap="square" lIns="0" rIns="0" tIns="0" bIns="0" anchor="ctr">
+            <a:spAutoFit/>
+          </a:bodyPr>
+          <a:lstStyle/>
+          <a:p>
+            <a:r>
+              <a:rPr sz="1800" b="1" i="0">
+                <a:solidFill>
+                  <a:srgbClr val="153243"/>
+                </a:solidFill>
+                <a:latin typeface="Source Sans Pro"/>
+              </a:rPr>
+              <a:t>Hiring</a:t>
+            </a:r>
+          </a:p>
+        </p:txBody>
+      </p:sp>
+      <p:sp>
+        <p:nvSpPr>
+          <p:cNvPr id="13" name="Hiring step"/>
+          <p:cNvSpPr/>
+          <p:nvPr/>
+        </p:nvSpPr>
+        <p:spPr>
+          <a:xfrm>
+            <a:off x="1143000" y="2743200"/>
+            <a:ext cx="2834640" cy="621792"/>
+          </a:xfrm>
+          <a:prstGeom prst="roundRect">
+            <a:avLst>
+              <a:gd name="adj" fmla="val 8000"/>
+            </a:avLst>
+          </a:prstGeom>
+          <a:solidFill>
+            <a:srgbClr val="FFFFFF"/>
+          </a:solidFill>
+          <a:ln>
+            <a:noFill/>
+          </a:ln>
+          <a:effectLst/>
+        </p:spPr>
+        <p:style>
+          <a:lnRef idx="1">
+            <a:schemeClr val="accent1"/>
+          </a:lnRef>
+          <a:fillRef idx="3">
+            <a:schemeClr val="accent1"/>
+          </a:fillRef>
+          <a:effectRef idx="2">
+            <a:schemeClr val="accent1"/>
+          </a:effectRef>
+          <a:fontRef idx="minor">
+            <a:schemeClr val="lt1"/>
+          </a:fontRef>
+        </p:style>
+        <p:txBody>
+          <a:bodyPr rtlCol="0" anchor="ctr"/>
+          <a:lstStyle/>
+          <a:p>
+            <a:pPr algn="ctr"/>
+          </a:p>
+        </p:txBody>
+      </p:sp>
+      <p:sp>
+        <p:nvSpPr>
+          <p:cNvPr id="14" name="Hiring step text"/>
+          <p:cNvSpPr txBox="1"/>
+          <p:nvPr/>
+        </p:nvSpPr>
+        <p:spPr>
+          <a:xfrm>
+            <a:off x="1280160" y="2743200"/>
+            <a:ext cx="2560320" cy="621792"/>
+          </a:xfrm>
+          <a:prstGeom prst="rect">
+            <a:avLst/>
+          </a:prstGeom>
+          <a:noFill/>
+        </p:spPr>
+        <p:txBody>
+          <a:bodyPr wrap="square" lIns="0" rIns="0" tIns="0" bIns="0" anchor="ctr">
+            <a:spAutoFit/>
+          </a:bodyPr>
+          <a:lstStyle/>
+          <a:p>
+            <a:r>
+              <a:rPr sz="1000" b="1" i="0" spc="100">
+                <a:solidFill>
+                  <a:srgbClr val="366E8E"/>
+                </a:solidFill>
+                <a:latin typeface="Source Sans Pro"/>
+              </a:rPr>
+              <a:t>ONE STEP  </a:t>
+            </a:r>
+          </a:p>
+          <a:p>
+            <a:r>
+              <a:rPr sz="1300" b="0" i="0">
+                <a:solidFill>
+                  <a:srgbClr val="153243"/>
+                </a:solidFill>
+                <a:latin typeface="Source Sans Pro"/>
+              </a:rPr>
+              <a:t>Hire someone</a:t>
+            </a:r>
+          </a:p>
+        </p:txBody>
+      </p:sp>
+      <p:sp>
+        <p:nvSpPr>
+          <p:cNvPr id="15" name="Hiring harder"/>
+          <p:cNvSpPr/>
+          <p:nvPr/>
+        </p:nvSpPr>
+        <p:spPr>
+          <a:xfrm>
+            <a:off x="1143000" y="3520440"/>
+            <a:ext cx="2834640" cy="685800"/>
+          </a:xfrm>
+          <a:prstGeom prst="roundRect">
+            <a:avLst>
+              <a:gd name="adj" fmla="val 8000"/>
+            </a:avLst>
+          </a:prstGeom>
+          <a:solidFill>
+            <a:srgbClr val="8FB24E"/>
+          </a:solidFill>
+          <a:ln>
+            <a:noFill/>
+          </a:ln>
+          <a:effectLst/>
+        </p:spPr>
+        <p:style>
+          <a:lnRef idx="1">
+            <a:schemeClr val="accent1"/>
+          </a:lnRef>
+          <a:fillRef idx="3">
+            <a:schemeClr val="accent1"/>
+          </a:fillRef>
+          <a:effectRef idx="2">
+            <a:schemeClr val="accent1"/>
+          </a:effectRef>
+          <a:fontRef idx="minor">
+            <a:schemeClr val="lt1"/>
+          </a:fontRef>
+        </p:style>
+        <p:txBody>
+          <a:bodyPr rtlCol="0" anchor="ctr"/>
+          <a:lstStyle/>
+          <a:p>
+            <a:pPr algn="ctr"/>
+          </a:p>
+        </p:txBody>
+      </p:sp>
+      <p:sp>
+        <p:nvSpPr>
+          <p:cNvPr id="16" name="Hiring harder text"/>
+          <p:cNvSpPr txBox="1"/>
+          <p:nvPr/>
+        </p:nvSpPr>
+        <p:spPr>
+          <a:xfrm>
+            <a:off x="1280160" y="3520440"/>
+            <a:ext cx="2560320" cy="685800"/>
+          </a:xfrm>
+          <a:prstGeom prst="rect">
+            <a:avLst/>
+          </a:prstGeom>
+          <a:noFill/>
+        </p:spPr>
+        <p:txBody>
+          <a:bodyPr wrap="square" lIns="0" rIns="0" tIns="0" bIns="0" anchor="ctr">
+            <a:spAutoFit/>
+          </a:bodyPr>
+          <a:lstStyle/>
+          <a:p>
+            <a:r>
+              <a:rPr sz="1000" b="1" i="0" spc="100">
+                <a:solidFill>
+                  <a:srgbClr val="153243"/>
+                </a:solidFill>
+                <a:latin typeface="Source Sans Pro"/>
+              </a:rPr>
+              <a:t>MORE WORK  </a:t>
+            </a:r>
+          </a:p>
+          <a:p>
+            <a:r>
+              <a:rPr sz="1300" b="1" i="0">
+                <a:solidFill>
+                  <a:srgbClr val="153243"/>
+                </a:solidFill>
+                <a:latin typeface="Source Sans Pro"/>
+              </a:rPr>
+              <a:t>Train and support them</a:t>
+            </a:r>
+          </a:p>
+        </p:txBody>
+      </p:sp>
+      <p:sp>
+        <p:nvSpPr>
+          <p:cNvPr id="17" name="Process card"/>
+          <p:cNvSpPr/>
+          <p:nvPr/>
+        </p:nvSpPr>
+        <p:spPr>
+          <a:xfrm>
+            <a:off x="4539996" y="1920240"/>
+            <a:ext cx="3200400" cy="2468880"/>
+          </a:xfrm>
+          <a:prstGeom prst="roundRect">
+            <a:avLst>
+              <a:gd name="adj" fmla="val 5000"/>
+            </a:avLst>
+          </a:prstGeom>
+          <a:solidFill>
+            <a:srgbClr val="EDECED"/>
+          </a:solidFill>
+          <a:ln>
+            <a:noFill/>
+          </a:ln>
+          <a:effectLst/>
+        </p:spPr>
+        <p:style>
+          <a:lnRef idx="1">
+            <a:schemeClr val="accent1"/>
+          </a:lnRef>
+          <a:fillRef idx="3">
+            <a:schemeClr val="accent1"/>
+          </a:fillRef>
+          <a:effectRef idx="2">
+            <a:schemeClr val="accent1"/>
+          </a:effectRef>
+          <a:fontRef idx="minor">
+            <a:schemeClr val="lt1"/>
+          </a:fontRef>
+        </p:style>
+        <p:txBody>
+          <a:bodyPr rtlCol="0" anchor="ctr"/>
+          <a:lstStyle/>
+          <a:p>
+            <a:pPr algn="ctr"/>
+          </a:p>
+        </p:txBody>
+      </p:sp>
+      <p:sp>
+        <p:nvSpPr>
+          <p:cNvPr id="18" name="Process icon circle"/>
+          <p:cNvSpPr/>
+          <p:nvPr/>
+        </p:nvSpPr>
+        <p:spPr>
+          <a:xfrm>
+            <a:off x="4791455" y="2034540"/>
+            <a:ext cx="502920" cy="502920"/>
+          </a:xfrm>
+          <a:prstGeom prst="ellipse">
+            <a:avLst/>
+          </a:prstGeom>
+          <a:solidFill>
+            <a:srgbClr val="8FB24E"/>
+          </a:solidFill>
+          <a:ln>
+            <a:noFill/>
+          </a:ln>
+          <a:effectLst/>
+        </p:spPr>
+        <p:style>
+          <a:lnRef idx="1">
+            <a:schemeClr val="accent1"/>
+          </a:lnRef>
+          <a:fillRef idx="3">
+            <a:schemeClr val="accent1"/>
+          </a:fillRef>
+          <a:effectRef idx="2">
+            <a:schemeClr val="accent1"/>
+          </a:effectRef>
+          <a:fontRef idx="minor">
+            <a:schemeClr val="lt1"/>
+          </a:fontRef>
+        </p:style>
+        <p:txBody>
+          <a:bodyPr rtlCol="0" anchor="ctr"/>
+          <a:lstStyle/>
+          <a:p>
+            <a:pPr algn="ctr"/>
+          </a:p>
+        </p:txBody>
+      </p:sp>
+      <p:pic>
+        <p:nvPicPr>
+          <p:cNvPr id="19" name="Process icon" descr="Process icon"/>
+          <p:cNvPicPr>
+            <a:picLocks noChangeAspect="1"/>
+          </p:cNvPicPr>
+          <p:nvPr/>
+        </p:nvPicPr>
+        <p:blipFill>
+          <a:blip r:embed="rId3"/>
+          <a:stretch>
+            <a:fillRect/>
+          </a:stretch>
+        </p:blipFill>
+        <p:spPr>
+          <a:xfrm>
+            <a:off x="4912156" y="2155240"/>
+            <a:ext cx="261518" cy="261518"/>
+          </a:xfrm>
+          <a:prstGeom prst="rect">
+            <a:avLst/>
+          </a:prstGeom>
+        </p:spPr>
+      </p:pic>
+      <p:sp>
+        <p:nvSpPr>
+          <p:cNvPr id="20" name="Process header"/>
+          <p:cNvSpPr txBox="1"/>
+          <p:nvPr/>
+        </p:nvSpPr>
+        <p:spPr>
+          <a:xfrm>
+            <a:off x="5454396" y="2103120"/>
+            <a:ext cx="2103120" cy="365760"/>
+          </a:xfrm>
+          <a:prstGeom prst="rect">
+            <a:avLst/>
+          </a:prstGeom>
+          <a:noFill/>
+        </p:spPr>
+        <p:txBody>
+          <a:bodyPr wrap="square" lIns="0" rIns="0" tIns="0" bIns="0" anchor="ctr">
+            <a:spAutoFit/>
+          </a:bodyPr>
+          <a:lstStyle/>
+          <a:p>
+            <a:r>
+              <a:rPr sz="1800" b="1" i="0">
+                <a:solidFill>
+                  <a:srgbClr val="153243"/>
+                </a:solidFill>
+                <a:latin typeface="Source Sans Pro"/>
+              </a:rPr>
+              <a:t>Process</a:t>
+            </a:r>
+          </a:p>
+        </p:txBody>
+      </p:sp>
+      <p:sp>
+        <p:nvSpPr>
+          <p:cNvPr id="21" name="Process step"/>
+          <p:cNvSpPr/>
+          <p:nvPr/>
+        </p:nvSpPr>
+        <p:spPr>
+          <a:xfrm>
+            <a:off x="4722876" y="2743200"/>
+            <a:ext cx="2834640" cy="621792"/>
+          </a:xfrm>
+          <a:prstGeom prst="roundRect">
+            <a:avLst>
+              <a:gd name="adj" fmla="val 8000"/>
+            </a:avLst>
+          </a:prstGeom>
+          <a:solidFill>
+            <a:srgbClr val="FFFFFF"/>
+          </a:solidFill>
+          <a:ln>
+            <a:noFill/>
+          </a:ln>
+          <a:effectLst/>
+        </p:spPr>
+        <p:style>
+          <a:lnRef idx="1">
+            <a:schemeClr val="accent1"/>
+          </a:lnRef>
+          <a:fillRef idx="3">
+            <a:schemeClr val="accent1"/>
+          </a:fillRef>
+          <a:effectRef idx="2">
+            <a:schemeClr val="accent1"/>
+          </a:effectRef>
+          <a:fontRef idx="minor">
+            <a:schemeClr val="lt1"/>
+          </a:fontRef>
+        </p:style>
+        <p:txBody>
+          <a:bodyPr rtlCol="0" anchor="ctr"/>
+          <a:lstStyle/>
+          <a:p>
+            <a:pPr algn="ctr"/>
+          </a:p>
+        </p:txBody>
+      </p:sp>
+      <p:sp>
+        <p:nvSpPr>
+          <p:cNvPr id="22" name="Process step text"/>
+          <p:cNvSpPr txBox="1"/>
+          <p:nvPr/>
+        </p:nvSpPr>
+        <p:spPr>
+          <a:xfrm>
+            <a:off x="4860036" y="2743200"/>
+            <a:ext cx="2560320" cy="621792"/>
+          </a:xfrm>
+          <a:prstGeom prst="rect">
+            <a:avLst/>
+          </a:prstGeom>
+          <a:noFill/>
+        </p:spPr>
+        <p:txBody>
+          <a:bodyPr wrap="square" lIns="0" rIns="0" tIns="0" bIns="0" anchor="ctr">
+            <a:spAutoFit/>
+          </a:bodyPr>
+          <a:lstStyle/>
+          <a:p>
+            <a:r>
+              <a:rPr sz="1000" b="1" i="0" spc="100">
+                <a:solidFill>
+                  <a:srgbClr val="366E8E"/>
+                </a:solidFill>
+                <a:latin typeface="Source Sans Pro"/>
+              </a:rPr>
+              <a:t>ONE STEP  </a:t>
+            </a:r>
+          </a:p>
+          <a:p>
+            <a:r>
+              <a:rPr sz="1300" b="0" i="0">
+                <a:solidFill>
+                  <a:srgbClr val="153243"/>
+                </a:solidFill>
+                <a:latin typeface="Source Sans Pro"/>
+              </a:rPr>
+              <a:t>Create a process</a:t>
+            </a:r>
+          </a:p>
+        </p:txBody>
+      </p:sp>
+      <p:sp>
+        <p:nvSpPr>
+          <p:cNvPr id="23" name="Process harder"/>
+          <p:cNvSpPr/>
+          <p:nvPr/>
+        </p:nvSpPr>
+        <p:spPr>
+          <a:xfrm>
+            <a:off x="4722876" y="3520440"/>
+            <a:ext cx="2834640" cy="685800"/>
+          </a:xfrm>
+          <a:prstGeom prst="roundRect">
+            <a:avLst>
+              <a:gd name="adj" fmla="val 8000"/>
+            </a:avLst>
+          </a:prstGeom>
+          <a:solidFill>
+            <a:srgbClr val="8FB24E"/>
+          </a:solidFill>
+          <a:ln>
+            <a:noFill/>
+          </a:ln>
+          <a:effectLst/>
+        </p:spPr>
+        <p:style>
+          <a:lnRef idx="1">
+            <a:schemeClr val="accent1"/>
+          </a:lnRef>
+          <a:fillRef idx="3">
+            <a:schemeClr val="accent1"/>
+          </a:fillRef>
+          <a:effectRef idx="2">
+            <a:schemeClr val="accent1"/>
+          </a:effectRef>
+          <a:fontRef idx="minor">
+            <a:schemeClr val="lt1"/>
+          </a:fontRef>
+        </p:style>
+        <p:txBody>
+          <a:bodyPr rtlCol="0" anchor="ctr"/>
+          <a:lstStyle/>
+          <a:p>
+            <a:pPr algn="ctr"/>
+          </a:p>
+        </p:txBody>
+      </p:sp>
+      <p:sp>
+        <p:nvSpPr>
+          <p:cNvPr id="24" name="Process harder text"/>
+          <p:cNvSpPr txBox="1"/>
+          <p:nvPr/>
+        </p:nvSpPr>
+        <p:spPr>
+          <a:xfrm>
+            <a:off x="4860036" y="3520440"/>
+            <a:ext cx="2560320" cy="685800"/>
+          </a:xfrm>
+          <a:prstGeom prst="rect">
+            <a:avLst/>
+          </a:prstGeom>
+          <a:noFill/>
+        </p:spPr>
+        <p:txBody>
+          <a:bodyPr wrap="square" lIns="0" rIns="0" tIns="0" bIns="0" anchor="ctr">
+            <a:spAutoFit/>
+          </a:bodyPr>
+          <a:lstStyle/>
+          <a:p>
+            <a:r>
+              <a:rPr sz="1000" b="1" i="0" spc="100">
+                <a:solidFill>
+                  <a:srgbClr val="153243"/>
+                </a:solidFill>
+                <a:latin typeface="Source Sans Pro"/>
+              </a:rPr>
+              <a:t>MORE WORK  </a:t>
+            </a:r>
+          </a:p>
+          <a:p>
+            <a:r>
+              <a:rPr sz="1300" b="1" i="0">
+                <a:solidFill>
+                  <a:srgbClr val="153243"/>
+                </a:solidFill>
+                <a:latin typeface="Source Sans Pro"/>
+              </a:rPr>
+              <a:t>Get it used consistently</a:t>
+            </a:r>
+          </a:p>
+        </p:txBody>
+      </p:sp>
+      <p:sp>
+        <p:nvSpPr>
+          <p:cNvPr id="25" name="Technology card"/>
+          <p:cNvSpPr/>
+          <p:nvPr/>
+        </p:nvSpPr>
+        <p:spPr>
+          <a:xfrm>
+            <a:off x="8119872" y="1920240"/>
+            <a:ext cx="3200400" cy="2468880"/>
+          </a:xfrm>
+          <a:prstGeom prst="roundRect">
+            <a:avLst>
+              <a:gd name="adj" fmla="val 5000"/>
+            </a:avLst>
+          </a:prstGeom>
+          <a:solidFill>
+            <a:srgbClr val="EDECED"/>
+          </a:solidFill>
+          <a:ln>
+            <a:noFill/>
+          </a:ln>
+          <a:effectLst/>
+        </p:spPr>
+        <p:style>
+          <a:lnRef idx="1">
+            <a:schemeClr val="accent1"/>
+          </a:lnRef>
+          <a:fillRef idx="3">
+            <a:schemeClr val="accent1"/>
+          </a:fillRef>
+          <a:effectRef idx="2">
+            <a:schemeClr val="accent1"/>
+          </a:effectRef>
+          <a:fontRef idx="minor">
+            <a:schemeClr val="lt1"/>
+          </a:fontRef>
+        </p:style>
+        <p:txBody>
+          <a:bodyPr rtlCol="0" anchor="ctr"/>
+          <a:lstStyle/>
+          <a:p>
+            <a:pPr algn="ctr"/>
+          </a:p>
+        </p:txBody>
+      </p:sp>
+      <p:sp>
+        <p:nvSpPr>
+          <p:cNvPr id="26" name="Technology icon circle"/>
+          <p:cNvSpPr/>
+          <p:nvPr/>
+        </p:nvSpPr>
+        <p:spPr>
+          <a:xfrm>
+            <a:off x="8371332" y="2034540"/>
+            <a:ext cx="502920" cy="502920"/>
+          </a:xfrm>
+          <a:prstGeom prst="ellipse">
+            <a:avLst/>
+          </a:prstGeom>
+          <a:solidFill>
+            <a:srgbClr val="8FB24E"/>
+          </a:solidFill>
+          <a:ln>
+            <a:noFill/>
+          </a:ln>
+          <a:effectLst/>
+        </p:spPr>
+        <p:style>
+          <a:lnRef idx="1">
+            <a:schemeClr val="accent1"/>
+          </a:lnRef>
+          <a:fillRef idx="3">
+            <a:schemeClr val="accent1"/>
+          </a:fillRef>
+          <a:effectRef idx="2">
+            <a:schemeClr val="accent1"/>
+          </a:effectRef>
+          <a:fontRef idx="minor">
+            <a:schemeClr val="lt1"/>
+          </a:fontRef>
+        </p:style>
+        <p:txBody>
+          <a:bodyPr rtlCol="0" anchor="ctr"/>
+          <a:lstStyle/>
+          <a:p>
+            <a:pPr algn="ctr"/>
+          </a:p>
+        </p:txBody>
+      </p:sp>
+      <p:pic>
+        <p:nvPicPr>
+          <p:cNvPr id="27" name="Technology icon" descr="Technology icon"/>
+          <p:cNvPicPr>
+            <a:picLocks noChangeAspect="1"/>
+          </p:cNvPicPr>
+          <p:nvPr/>
+        </p:nvPicPr>
+        <p:blipFill>
+          <a:blip r:embed="rId4"/>
+          <a:stretch>
+            <a:fillRect/>
+          </a:stretch>
+        </p:blipFill>
+        <p:spPr>
+          <a:xfrm>
+            <a:off x="8492032" y="2155240"/>
+            <a:ext cx="261518" cy="261518"/>
+          </a:xfrm>
+          <a:prstGeom prst="rect">
+            <a:avLst/>
+          </a:prstGeom>
+        </p:spPr>
+      </p:pic>
+      <p:sp>
+        <p:nvSpPr>
+          <p:cNvPr id="28" name="Technology header"/>
+          <p:cNvSpPr txBox="1"/>
+          <p:nvPr/>
+        </p:nvSpPr>
+        <p:spPr>
+          <a:xfrm>
+            <a:off x="9034272" y="2103120"/>
+            <a:ext cx="2103120" cy="365760"/>
+          </a:xfrm>
+          <a:prstGeom prst="rect">
+            <a:avLst/>
+          </a:prstGeom>
+          <a:noFill/>
+        </p:spPr>
+        <p:txBody>
+          <a:bodyPr wrap="square" lIns="0" rIns="0" tIns="0" bIns="0" anchor="ctr">
+            <a:spAutoFit/>
+          </a:bodyPr>
+          <a:lstStyle/>
+          <a:p>
+            <a:r>
+              <a:rPr sz="1800" b="1" i="0">
+                <a:solidFill>
+                  <a:srgbClr val="153243"/>
+                </a:solidFill>
+                <a:latin typeface="Source Sans Pro"/>
+              </a:rPr>
+              <a:t>Technology</a:t>
+            </a:r>
+          </a:p>
+        </p:txBody>
+      </p:sp>
+      <p:sp>
+        <p:nvSpPr>
+          <p:cNvPr id="29" name="Technology step"/>
+          <p:cNvSpPr/>
+          <p:nvPr/>
+        </p:nvSpPr>
+        <p:spPr>
+          <a:xfrm>
+            <a:off x="8302752" y="2743200"/>
+            <a:ext cx="2834640" cy="621792"/>
+          </a:xfrm>
+          <a:prstGeom prst="roundRect">
+            <a:avLst>
+              <a:gd name="adj" fmla="val 8000"/>
+            </a:avLst>
+          </a:prstGeom>
+          <a:solidFill>
+            <a:srgbClr val="FFFFFF"/>
+          </a:solidFill>
+          <a:ln>
+            <a:noFill/>
+          </a:ln>
+          <a:effectLst/>
+        </p:spPr>
+        <p:style>
+          <a:lnRef idx="1">
+            <a:schemeClr val="accent1"/>
+          </a:lnRef>
+          <a:fillRef idx="3">
+            <a:schemeClr val="accent1"/>
+          </a:fillRef>
+          <a:effectRef idx="2">
+            <a:schemeClr val="accent1"/>
+          </a:effectRef>
+          <a:fontRef idx="minor">
+            <a:schemeClr val="lt1"/>
+          </a:fontRef>
+        </p:style>
+        <p:txBody>
+          <a:bodyPr rtlCol="0" anchor="ctr"/>
+          <a:lstStyle/>
+          <a:p>
+            <a:pPr algn="ctr"/>
+          </a:p>
+        </p:txBody>
+      </p:sp>
+      <p:sp>
+        <p:nvSpPr>
+          <p:cNvPr id="30" name="Technology step text"/>
+          <p:cNvSpPr txBox="1"/>
+          <p:nvPr/>
+        </p:nvSpPr>
+        <p:spPr>
+          <a:xfrm>
+            <a:off x="8439912" y="2743200"/>
+            <a:ext cx="2560320" cy="621792"/>
+          </a:xfrm>
+          <a:prstGeom prst="rect">
+            <a:avLst/>
+          </a:prstGeom>
+          <a:noFill/>
+        </p:spPr>
+        <p:txBody>
+          <a:bodyPr wrap="square" lIns="0" rIns="0" tIns="0" bIns="0" anchor="ctr">
+            <a:spAutoFit/>
+          </a:bodyPr>
+          <a:lstStyle/>
+          <a:p>
+            <a:r>
+              <a:rPr sz="1000" b="1" i="0" spc="100">
+                <a:solidFill>
+                  <a:srgbClr val="366E8E"/>
+                </a:solidFill>
+                <a:latin typeface="Source Sans Pro"/>
+              </a:rPr>
+              <a:t>ONE STEP  </a:t>
+            </a:r>
+          </a:p>
+          <a:p>
+            <a:r>
+              <a:rPr sz="1300" b="0" i="0">
+                <a:solidFill>
+                  <a:srgbClr val="153243"/>
+                </a:solidFill>
+                <a:latin typeface="Source Sans Pro"/>
+              </a:rPr>
+              <a:t>Find a promising tool</a:t>
+            </a:r>
+          </a:p>
+        </p:txBody>
+      </p:sp>
+      <p:sp>
+        <p:nvSpPr>
+          <p:cNvPr id="31" name="Technology harder"/>
+          <p:cNvSpPr/>
+          <p:nvPr/>
+        </p:nvSpPr>
+        <p:spPr>
+          <a:xfrm>
+            <a:off x="8302752" y="3520440"/>
+            <a:ext cx="2834640" cy="685800"/>
+          </a:xfrm>
+          <a:prstGeom prst="roundRect">
+            <a:avLst>
+              <a:gd name="adj" fmla="val 8000"/>
+            </a:avLst>
+          </a:prstGeom>
+          <a:solidFill>
+            <a:srgbClr val="8FB24E"/>
+          </a:solidFill>
+          <a:ln>
+            <a:noFill/>
+          </a:ln>
+          <a:effectLst/>
+        </p:spPr>
+        <p:style>
+          <a:lnRef idx="1">
+            <a:schemeClr val="accent1"/>
+          </a:lnRef>
+          <a:fillRef idx="3">
+            <a:schemeClr val="accent1"/>
+          </a:fillRef>
+          <a:effectRef idx="2">
+            <a:schemeClr val="accent1"/>
+          </a:effectRef>
+          <a:fontRef idx="minor">
+            <a:schemeClr val="lt1"/>
+          </a:fontRef>
+        </p:style>
+        <p:txBody>
+          <a:bodyPr rtlCol="0" anchor="ctr"/>
+          <a:lstStyle/>
+          <a:p>
+            <a:pPr algn="ctr"/>
+          </a:p>
+        </p:txBody>
+      </p:sp>
+      <p:sp>
+        <p:nvSpPr>
+          <p:cNvPr id="32" name="Technology harder text"/>
+          <p:cNvSpPr txBox="1"/>
+          <p:nvPr/>
+        </p:nvSpPr>
+        <p:spPr>
+          <a:xfrm>
+            <a:off x="8439912" y="3520440"/>
+            <a:ext cx="2560320" cy="685800"/>
+          </a:xfrm>
+          <a:prstGeom prst="rect">
+            <a:avLst/>
+          </a:prstGeom>
+          <a:noFill/>
+        </p:spPr>
+        <p:txBody>
+          <a:bodyPr wrap="square" lIns="0" rIns="0" tIns="0" bIns="0" anchor="ctr">
+            <a:spAutoFit/>
+          </a:bodyPr>
+          <a:lstStyle/>
+          <a:p>
+            <a:r>
+              <a:rPr sz="1000" b="1" i="0" spc="100">
+                <a:solidFill>
+                  <a:srgbClr val="153243"/>
+                </a:solidFill>
+                <a:latin typeface="Source Sans Pro"/>
+              </a:rPr>
+              <a:t>MORE WORK  </a:t>
+            </a:r>
+          </a:p>
+          <a:p>
+            <a:r>
+              <a:rPr sz="1300" b="1" i="0">
+                <a:solidFill>
+                  <a:srgbClr val="153243"/>
+                </a:solidFill>
+                <a:latin typeface="Source Sans Pro"/>
+              </a:rPr>
+              <a:t>Make it useful day to day</a:t>
+            </a:r>
+          </a:p>
+        </p:txBody>
+      </p:sp>
+      <p:sp>
+        <p:nvSpPr>
+          <p:cNvPr id="33" name="Retention card"/>
+          <p:cNvSpPr/>
+          <p:nvPr/>
+        </p:nvSpPr>
+        <p:spPr>
+          <a:xfrm>
+            <a:off x="960120" y="4526280"/>
+            <a:ext cx="10360152" cy="777240"/>
+          </a:xfrm>
+          <a:prstGeom prst="roundRect">
+            <a:avLst>
+              <a:gd name="adj" fmla="val 5000"/>
+            </a:avLst>
+          </a:prstGeom>
+          <a:solidFill>
+            <a:srgbClr val="EDECED"/>
+          </a:solidFill>
+          <a:ln>
+            <a:noFill/>
+          </a:ln>
+          <a:effectLst/>
+        </p:spPr>
+        <p:style>
+          <a:lnRef idx="1">
+            <a:schemeClr val="accent1"/>
+          </a:lnRef>
+          <a:fillRef idx="3">
+            <a:schemeClr val="accent1"/>
+          </a:fillRef>
+          <a:effectRef idx="2">
+            <a:schemeClr val="accent1"/>
+          </a:effectRef>
+          <a:fontRef idx="minor">
+            <a:schemeClr val="lt1"/>
+          </a:fontRef>
+        </p:style>
+        <p:txBody>
+          <a:bodyPr rtlCol="0" anchor="ctr"/>
+          <a:lstStyle/>
+          <a:p>
+            <a:pPr algn="ctr"/>
+          </a:p>
+        </p:txBody>
+      </p:sp>
+      <p:sp>
+        <p:nvSpPr>
+          <p:cNvPr id="34" name="Retention icon circle"/>
+          <p:cNvSpPr/>
+          <p:nvPr/>
+        </p:nvSpPr>
+        <p:spPr>
+          <a:xfrm>
+            <a:off x="1280160" y="4640580"/>
+            <a:ext cx="548640" cy="548640"/>
+          </a:xfrm>
+          <a:prstGeom prst="ellipse">
+            <a:avLst/>
+          </a:prstGeom>
+          <a:solidFill>
+            <a:srgbClr val="8FB24E"/>
+          </a:solidFill>
+          <a:ln>
+            <a:noFill/>
+          </a:ln>
+          <a:effectLst/>
+        </p:spPr>
+        <p:style>
+          <a:lnRef idx="1">
+            <a:schemeClr val="accent1"/>
+          </a:lnRef>
+          <a:fillRef idx="3">
+            <a:schemeClr val="accent1"/>
+          </a:fillRef>
+          <a:effectRef idx="2">
+            <a:schemeClr val="accent1"/>
+          </a:effectRef>
+          <a:fontRef idx="minor">
+            <a:schemeClr val="lt1"/>
+          </a:fontRef>
+        </p:style>
+        <p:txBody>
+          <a:bodyPr rtlCol="0" anchor="ctr"/>
+          <a:lstStyle/>
+          <a:p>
+            <a:pPr algn="ctr"/>
+          </a:p>
+        </p:txBody>
+      </p:sp>
+      <p:pic>
+        <p:nvPicPr>
+          <p:cNvPr id="35" name="Retention icon" descr="Retention icon"/>
+          <p:cNvPicPr>
+            <a:picLocks noChangeAspect="1"/>
+          </p:cNvPicPr>
+          <p:nvPr/>
+        </p:nvPicPr>
+        <p:blipFill>
+          <a:blip r:embed="rId5"/>
+          <a:stretch>
+            <a:fillRect/>
+          </a:stretch>
+        </p:blipFill>
+        <p:spPr>
+          <a:xfrm>
+            <a:off x="1411833" y="4772253"/>
+            <a:ext cx="285292" cy="285292"/>
+          </a:xfrm>
+          <a:prstGeom prst="rect">
+            <a:avLst/>
+          </a:prstGeom>
+        </p:spPr>
+      </p:pic>
+      <p:sp>
+        <p:nvSpPr>
+          <p:cNvPr id="36" name="Retention text"/>
+          <p:cNvSpPr txBox="1"/>
+          <p:nvPr/>
+        </p:nvSpPr>
+        <p:spPr>
+          <a:xfrm>
+            <a:off x="2057400" y="4526280"/>
+            <a:ext cx="9144000" cy="777240"/>
+          </a:xfrm>
+          <a:prstGeom prst="rect">
+            <a:avLst/>
+          </a:prstGeom>
+          <a:noFill/>
+        </p:spPr>
+        <p:txBody>
+          <a:bodyPr wrap="square" lIns="0" rIns="0" tIns="0" bIns="0" anchor="ctr">
+            <a:spAutoFit/>
+          </a:bodyPr>
+          <a:lstStyle/>
+          <a:p>
+            <a:r>
+              <a:rPr sz="1400" b="1" i="0">
+                <a:solidFill>
+                  <a:srgbClr val="153243"/>
+                </a:solidFill>
+                <a:latin typeface="Source Sans Pro"/>
+              </a:rPr>
+              <a:t>Retention: </a:t>
+            </a:r>
+            <a:r>
+              <a:rPr sz="1400" b="0" i="0">
+                <a:solidFill>
+                  <a:srgbClr val="153243"/>
+                </a:solidFill>
+                <a:latin typeface="Source Sans Pro"/>
+              </a:rPr>
+              <a:t>understand why clients leave, identify patterns, and turn what we learn into changes that stick.</a:t>
+            </a:r>
+          </a:p>
+        </p:txBody>
+      </p:sp>
+      <p:sp>
+        <p:nvSpPr>
+          <p:cNvPr id="37" name="Bottom line card"/>
+          <p:cNvSpPr/>
+          <p:nvPr/>
+        </p:nvSpPr>
+        <p:spPr>
+          <a:xfrm>
+            <a:off x="960120" y="5440680"/>
+            <a:ext cx="10360152" cy="548640"/>
+          </a:xfrm>
+          <a:prstGeom prst="roundRect">
+            <a:avLst>
+              <a:gd name="adj" fmla="val 8000"/>
+            </a:avLst>
+          </a:prstGeom>
+          <a:solidFill>
+            <a:srgbClr val="366E8E"/>
+          </a:solidFill>
+          <a:ln>
+            <a:noFill/>
+          </a:ln>
+          <a:effectLst/>
+        </p:spPr>
+        <p:style>
+          <a:lnRef idx="1">
+            <a:schemeClr val="accent1"/>
+          </a:lnRef>
+          <a:fillRef idx="3">
+            <a:schemeClr val="accent1"/>
+          </a:fillRef>
+          <a:effectRef idx="2">
+            <a:schemeClr val="accent1"/>
+          </a:effectRef>
+          <a:fontRef idx="minor">
+            <a:schemeClr val="lt1"/>
+          </a:fontRef>
+        </p:style>
+        <p:txBody>
+          <a:bodyPr rtlCol="0" anchor="ctr"/>
+          <a:lstStyle/>
+          <a:p>
+            <a:pPr algn="ctr"/>
+          </a:p>
+        </p:txBody>
+      </p:sp>
+      <p:sp>
+        <p:nvSpPr>
+          <p:cNvPr id="38" name="Bottom line text"/>
+          <p:cNvSpPr txBox="1"/>
+          <p:nvPr/>
+        </p:nvSpPr>
+        <p:spPr>
+          <a:xfrm>
+            <a:off x="1188720" y="5440680"/>
+            <a:ext cx="9902952" cy="548640"/>
+          </a:xfrm>
+          <a:prstGeom prst="rect">
+            <a:avLst/>
+          </a:prstGeom>
+          <a:noFill/>
+        </p:spPr>
+        <p:txBody>
+          <a:bodyPr wrap="square" lIns="0" rIns="0" tIns="0" bIns="0" anchor="ctr">
+            <a:spAutoFit/>
+          </a:bodyPr>
+          <a:lstStyle/>
+          <a:p>
+            <a:r>
+              <a:rPr sz="1200" b="1" i="0" spc="150">
+                <a:solidFill>
+                  <a:srgbClr val="FFC666"/>
+                </a:solidFill>
+                <a:latin typeface="Source Sans Pro"/>
+              </a:rPr>
+              <a:t>THE BOTTOM LINE   </a:t>
+            </a:r>
+            <a:r>
+              <a:rPr sz="1400" b="0" i="0">
+                <a:solidFill>
+                  <a:srgbClr val="FFFFFF"/>
+                </a:solidFill>
+                <a:latin typeface="Source Sans Pro"/>
+              </a:rPr>
+              <a:t>That work is especially challenging when teams already have full schedules.</a:t>
             </a:r>
           </a:p>
         </p:txBody>

</xml_diff>

<commit_message>
Remove bottom-line bars from slides 3-6 and rebalance layouts
Co-Authored-By: Claude Sonnet 5.5 <noreply@anthropic.com>
Claude-Session: https://claude.ai/code/session_013DXsjPawU7xQxqcoPwwbM8
</commit_message>
<xml_diff>
--- a/Market Update/CCIG_Market_Update_Slides_CCIG-Brand.pptx
+++ b/Market Update/CCIG_Market_Update_Slides_CCIG-Brand.pptx
@@ -5820,7 +5820,7 @@
         <p:spPr>
           <a:xfrm>
             <a:off x="960120" y="1965960"/>
-            <a:ext cx="4572000" cy="3017520"/>
+            <a:ext cx="4572000" cy="3566160"/>
           </a:xfrm>
           <a:prstGeom prst="roundRect">
             <a:avLst>
@@ -5865,8 +5865,190 @@
         </p:nvSpPr>
         <p:spPr>
           <a:xfrm>
-            <a:off x="1280160" y="2286000"/>
+            <a:off x="1280160" y="2423160"/>
             <a:ext cx="640080" cy="640080"/>
+          </a:xfrm>
+          <a:prstGeom prst="ellipse">
+            <a:avLst/>
+          </a:prstGeom>
+          <a:solidFill>
+            <a:srgbClr val="FFFFFF"/>
+          </a:solidFill>
+          <a:ln>
+            <a:noFill/>
+          </a:ln>
+          <a:effectLst/>
+        </p:spPr>
+        <p:style>
+          <a:lnRef idx="1">
+            <a:schemeClr val="accent1"/>
+          </a:lnRef>
+          <a:fillRef idx="3">
+            <a:schemeClr val="accent1"/>
+          </a:fillRef>
+          <a:effectRef idx="2">
+            <a:schemeClr val="accent1"/>
+          </a:effectRef>
+          <a:fontRef idx="minor">
+            <a:schemeClr val="lt1"/>
+          </a:fontRef>
+        </p:style>
+        <p:txBody>
+          <a:bodyPr rtlCol="0" anchor="ctr"/>
+          <a:lstStyle/>
+          <a:p>
+            <a:pPr algn="ctr"/>
+          </a:p>
+        </p:txBody>
+      </p:sp>
+      <p:pic>
+        <p:nvPicPr>
+          <p:cNvPr id="11" name="Growth icon" descr="Growth icon"/>
+          <p:cNvPicPr>
+            <a:picLocks noChangeAspect="1"/>
+          </p:cNvPicPr>
+          <p:nvPr/>
+        </p:nvPicPr>
+        <p:blipFill>
+          <a:blip r:embed="rId2"/>
+          <a:stretch>
+            <a:fillRect/>
+          </a:stretch>
+        </p:blipFill>
+        <p:spPr>
+          <a:xfrm>
+            <a:off x="1433779" y="2576779"/>
+            <a:ext cx="332841" cy="332841"/>
+          </a:xfrm>
+          <a:prstGeom prst="rect">
+            <a:avLst/>
+          </a:prstGeom>
+        </p:spPr>
+      </p:pic>
+      <p:sp>
+        <p:nvSpPr>
+          <p:cNvPr id="12" name="Top 10% stat"/>
+          <p:cNvSpPr txBox="1"/>
+          <p:nvPr/>
+        </p:nvSpPr>
+        <p:spPr>
+          <a:xfrm>
+            <a:off x="1280160" y="3383280"/>
+            <a:ext cx="4023360" cy="1005840"/>
+          </a:xfrm>
+          <a:prstGeom prst="rect">
+            <a:avLst/>
+          </a:prstGeom>
+          <a:noFill/>
+        </p:spPr>
+        <p:txBody>
+          <a:bodyPr wrap="square" lIns="0" rIns="0" tIns="0" bIns="0" anchor="ctr">
+            <a:spAutoFit/>
+          </a:bodyPr>
+          <a:lstStyle/>
+          <a:p>
+            <a:r>
+              <a:rPr sz="5400" b="1" i="0">
+                <a:solidFill>
+                  <a:srgbClr val="153243"/>
+                </a:solidFill>
+                <a:latin typeface="Playfair Display"/>
+              </a:rPr>
+              <a:t>Top 10%</a:t>
+            </a:r>
+          </a:p>
+        </p:txBody>
+      </p:sp>
+      <p:sp>
+        <p:nvSpPr>
+          <p:cNvPr id="13" name="Top 10% label"/>
+          <p:cNvSpPr txBox="1"/>
+          <p:nvPr/>
+        </p:nvSpPr>
+        <p:spPr>
+          <a:xfrm>
+            <a:off x="1280160" y="4434840"/>
+            <a:ext cx="4023360" cy="640080"/>
+          </a:xfrm>
+          <a:prstGeom prst="rect">
+            <a:avLst/>
+          </a:prstGeom>
+          <a:noFill/>
+        </p:spPr>
+        <p:txBody>
+          <a:bodyPr wrap="square" lIns="0" rIns="0" tIns="0" bIns="0" anchor="t">
+            <a:spAutoFit/>
+          </a:bodyPr>
+          <a:lstStyle/>
+          <a:p>
+            <a:r>
+              <a:rPr sz="1300" b="1" i="0" spc="150">
+                <a:solidFill>
+                  <a:srgbClr val="153243"/>
+                </a:solidFill>
+                <a:latin typeface="Source Sans Pro"/>
+              </a:rPr>
+              <a:t>OF BROKERS IN THE COUNTRY FOR NEW BUSINESS GROWTH</a:t>
+            </a:r>
+          </a:p>
+        </p:txBody>
+      </p:sp>
+      <p:sp>
+        <p:nvSpPr>
+          <p:cNvPr id="14" name="Stat card 1"/>
+          <p:cNvSpPr/>
+          <p:nvPr/>
+        </p:nvSpPr>
+        <p:spPr>
+          <a:xfrm>
+            <a:off x="5852160" y="1965960"/>
+            <a:ext cx="5468112" cy="1645920"/>
+          </a:xfrm>
+          <a:prstGeom prst="roundRect">
+            <a:avLst>
+              <a:gd name="adj" fmla="val 5000"/>
+            </a:avLst>
+          </a:prstGeom>
+          <a:solidFill>
+            <a:srgbClr val="EDECED"/>
+          </a:solidFill>
+          <a:ln>
+            <a:noFill/>
+          </a:ln>
+          <a:effectLst/>
+        </p:spPr>
+        <p:style>
+          <a:lnRef idx="1">
+            <a:schemeClr val="accent1"/>
+          </a:lnRef>
+          <a:fillRef idx="3">
+            <a:schemeClr val="accent1"/>
+          </a:fillRef>
+          <a:effectRef idx="2">
+            <a:schemeClr val="accent1"/>
+          </a:effectRef>
+          <a:fontRef idx="minor">
+            <a:schemeClr val="lt1"/>
+          </a:fontRef>
+        </p:style>
+        <p:txBody>
+          <a:bodyPr rtlCol="0" anchor="ctr"/>
+          <a:lstStyle/>
+          <a:p>
+            <a:pPr algn="ctr"/>
+          </a:p>
+        </p:txBody>
+      </p:sp>
+      <p:sp>
+        <p:nvSpPr>
+          <p:cNvPr id="15" name="Stat icon 1 circle"/>
+          <p:cNvSpPr/>
+          <p:nvPr/>
+        </p:nvSpPr>
+        <p:spPr>
+          <a:xfrm>
+            <a:off x="6149340" y="2491739"/>
+            <a:ext cx="594360" cy="594360"/>
           </a:xfrm>
           <a:prstGeom prst="ellipse">
             <a:avLst/>
@@ -5903,22 +6085,22 @@
       </p:sp>
       <p:pic>
         <p:nvPicPr>
-          <p:cNvPr id="11" name="Growth icon" descr="Growth icon"/>
+          <p:cNvPr id="16" name="Stat icon 1" descr="Stat icon 1"/>
           <p:cNvPicPr>
             <a:picLocks noChangeAspect="1"/>
           </p:cNvPicPr>
           <p:nvPr/>
         </p:nvPicPr>
         <p:blipFill>
-          <a:blip r:embed="rId2"/>
+          <a:blip r:embed="rId3"/>
           <a:stretch>
             <a:fillRect/>
           </a:stretch>
         </p:blipFill>
         <p:spPr>
           <a:xfrm>
-            <a:off x="1433779" y="2439619"/>
-            <a:ext cx="332841" cy="332841"/>
+            <a:off x="6291986" y="2634386"/>
+            <a:ext cx="309067" cy="309067"/>
           </a:xfrm>
           <a:prstGeom prst="rect">
             <a:avLst/>
@@ -5927,14 +6109,14 @@
       </p:pic>
       <p:sp>
         <p:nvSpPr>
-          <p:cNvPr id="12" name="Top 10% stat"/>
+          <p:cNvPr id="17" name="Stat 1"/>
           <p:cNvSpPr txBox="1"/>
           <p:nvPr/>
         </p:nvSpPr>
         <p:spPr>
           <a:xfrm>
-            <a:off x="1280160" y="3108960"/>
-            <a:ext cx="4023360" cy="1005840"/>
+            <a:off x="6949440" y="2221991"/>
+            <a:ext cx="4206240" cy="640080"/>
           </a:xfrm>
           <a:prstGeom prst="rect">
             <a:avLst/>
@@ -5948,27 +6130,27 @@
           <a:lstStyle/>
           <a:p>
             <a:r>
-              <a:rPr sz="5400" b="1" i="0">
+              <a:rPr sz="3200" b="1" i="0">
                 <a:solidFill>
                   <a:srgbClr val="153243"/>
                 </a:solidFill>
                 <a:latin typeface="Playfair Display"/>
               </a:rPr>
-              <a:t>Top 10%</a:t>
-            </a:r>
-          </a:p>
-        </p:txBody>
-      </p:sp>
-      <p:sp>
-        <p:nvSpPr>
-          <p:cNvPr id="13" name="Top 10% label"/>
+              <a:t>24</a:t>
+            </a:r>
+          </a:p>
+        </p:txBody>
+      </p:sp>
+      <p:sp>
+        <p:nvSpPr>
+          <p:cNvPr id="18" name="Stat label 1"/>
           <p:cNvSpPr txBox="1"/>
           <p:nvPr/>
         </p:nvSpPr>
         <p:spPr>
           <a:xfrm>
-            <a:off x="1280160" y="4160520"/>
-            <a:ext cx="4023360" cy="640080"/>
+            <a:off x="6949440" y="2880360"/>
+            <a:ext cx="4206240" cy="457200"/>
           </a:xfrm>
           <a:prstGeom prst="rect">
             <a:avLst/>
@@ -5982,27 +6164,27 @@
           <a:lstStyle/>
           <a:p>
             <a:r>
-              <a:rPr sz="1300" b="1" i="0" spc="150">
+              <a:rPr sz="1400" b="0" i="0">
                 <a:solidFill>
                   <a:srgbClr val="153243"/>
                 </a:solidFill>
                 <a:latin typeface="Source Sans Pro"/>
               </a:rPr>
-              <a:t>OF BROKERS IN THE COUNTRY FOR NEW BUSINESS GROWTH</a:t>
-            </a:r>
-          </a:p>
-        </p:txBody>
-      </p:sp>
-      <p:sp>
-        <p:nvSpPr>
-          <p:cNvPr id="14" name="Stat card 1"/>
+              <a:t>people promoted in the last 18 months</a:t>
+            </a:r>
+          </a:p>
+        </p:txBody>
+      </p:sp>
+      <p:sp>
+        <p:nvSpPr>
+          <p:cNvPr id="19" name="Stat card 2"/>
           <p:cNvSpPr/>
           <p:nvPr/>
         </p:nvSpPr>
         <p:spPr>
           <a:xfrm>
-            <a:off x="5852160" y="1965960"/>
-            <a:ext cx="5468112" cy="1417320"/>
+            <a:off x="5852160" y="3886200"/>
+            <a:ext cx="5468112" cy="1645920"/>
           </a:xfrm>
           <a:prstGeom prst="roundRect">
             <a:avLst>
@@ -6041,13 +6223,13 @@
       </p:sp>
       <p:sp>
         <p:nvSpPr>
-          <p:cNvPr id="15" name="Stat icon 1 circle"/>
+          <p:cNvPr id="20" name="Stat icon 2 circle"/>
           <p:cNvSpPr/>
           <p:nvPr/>
         </p:nvSpPr>
         <p:spPr>
           <a:xfrm>
-            <a:off x="6149340" y="2382011"/>
+            <a:off x="6149340" y="4411980"/>
             <a:ext cx="594360" cy="594360"/>
           </a:xfrm>
           <a:prstGeom prst="ellipse">
@@ -6085,188 +6267,6 @@
       </p:sp>
       <p:pic>
         <p:nvPicPr>
-          <p:cNvPr id="16" name="Stat icon 1" descr="Stat icon 1"/>
-          <p:cNvPicPr>
-            <a:picLocks noChangeAspect="1"/>
-          </p:cNvPicPr>
-          <p:nvPr/>
-        </p:nvPicPr>
-        <p:blipFill>
-          <a:blip r:embed="rId3"/>
-          <a:stretch>
-            <a:fillRect/>
-          </a:stretch>
-        </p:blipFill>
-        <p:spPr>
-          <a:xfrm>
-            <a:off x="6291986" y="2524658"/>
-            <a:ext cx="309067" cy="309067"/>
-          </a:xfrm>
-          <a:prstGeom prst="rect">
-            <a:avLst/>
-          </a:prstGeom>
-        </p:spPr>
-      </p:pic>
-      <p:sp>
-        <p:nvSpPr>
-          <p:cNvPr id="17" name="Stat 1"/>
-          <p:cNvSpPr txBox="1"/>
-          <p:nvPr/>
-        </p:nvSpPr>
-        <p:spPr>
-          <a:xfrm>
-            <a:off x="6949440" y="2130552"/>
-            <a:ext cx="4206240" cy="640080"/>
-          </a:xfrm>
-          <a:prstGeom prst="rect">
-            <a:avLst/>
-          </a:prstGeom>
-          <a:noFill/>
-        </p:spPr>
-        <p:txBody>
-          <a:bodyPr wrap="square" lIns="0" rIns="0" tIns="0" bIns="0" anchor="ctr">
-            <a:spAutoFit/>
-          </a:bodyPr>
-          <a:lstStyle/>
-          <a:p>
-            <a:r>
-              <a:rPr sz="3200" b="1" i="0">
-                <a:solidFill>
-                  <a:srgbClr val="153243"/>
-                </a:solidFill>
-                <a:latin typeface="Playfair Display"/>
-              </a:rPr>
-              <a:t>24</a:t>
-            </a:r>
-          </a:p>
-        </p:txBody>
-      </p:sp>
-      <p:sp>
-        <p:nvSpPr>
-          <p:cNvPr id="18" name="Stat label 1"/>
-          <p:cNvSpPr txBox="1"/>
-          <p:nvPr/>
-        </p:nvSpPr>
-        <p:spPr>
-          <a:xfrm>
-            <a:off x="6949440" y="2770632"/>
-            <a:ext cx="4206240" cy="457200"/>
-          </a:xfrm>
-          <a:prstGeom prst="rect">
-            <a:avLst/>
-          </a:prstGeom>
-          <a:noFill/>
-        </p:spPr>
-        <p:txBody>
-          <a:bodyPr wrap="square" lIns="0" rIns="0" tIns="0" bIns="0" anchor="t">
-            <a:spAutoFit/>
-          </a:bodyPr>
-          <a:lstStyle/>
-          <a:p>
-            <a:r>
-              <a:rPr sz="1400" b="0" i="0">
-                <a:solidFill>
-                  <a:srgbClr val="153243"/>
-                </a:solidFill>
-                <a:latin typeface="Source Sans Pro"/>
-              </a:rPr>
-              <a:t>people promoted in the last 18 months</a:t>
-            </a:r>
-          </a:p>
-        </p:txBody>
-      </p:sp>
-      <p:sp>
-        <p:nvSpPr>
-          <p:cNvPr id="19" name="Stat card 2"/>
-          <p:cNvSpPr/>
-          <p:nvPr/>
-        </p:nvSpPr>
-        <p:spPr>
-          <a:xfrm>
-            <a:off x="5852160" y="3566160"/>
-            <a:ext cx="5468112" cy="1417320"/>
-          </a:xfrm>
-          <a:prstGeom prst="roundRect">
-            <a:avLst>
-              <a:gd name="adj" fmla="val 5000"/>
-            </a:avLst>
-          </a:prstGeom>
-          <a:solidFill>
-            <a:srgbClr val="EDECED"/>
-          </a:solidFill>
-          <a:ln>
-            <a:noFill/>
-          </a:ln>
-          <a:effectLst/>
-        </p:spPr>
-        <p:style>
-          <a:lnRef idx="1">
-            <a:schemeClr val="accent1"/>
-          </a:lnRef>
-          <a:fillRef idx="3">
-            <a:schemeClr val="accent1"/>
-          </a:fillRef>
-          <a:effectRef idx="2">
-            <a:schemeClr val="accent1"/>
-          </a:effectRef>
-          <a:fontRef idx="minor">
-            <a:schemeClr val="lt1"/>
-          </a:fontRef>
-        </p:style>
-        <p:txBody>
-          <a:bodyPr rtlCol="0" anchor="ctr"/>
-          <a:lstStyle/>
-          <a:p>
-            <a:pPr algn="ctr"/>
-          </a:p>
-        </p:txBody>
-      </p:sp>
-      <p:sp>
-        <p:nvSpPr>
-          <p:cNvPr id="20" name="Stat icon 2 circle"/>
-          <p:cNvSpPr/>
-          <p:nvPr/>
-        </p:nvSpPr>
-        <p:spPr>
-          <a:xfrm>
-            <a:off x="6149340" y="3982211"/>
-            <a:ext cx="594360" cy="594360"/>
-          </a:xfrm>
-          <a:prstGeom prst="ellipse">
-            <a:avLst/>
-          </a:prstGeom>
-          <a:solidFill>
-            <a:srgbClr val="8FB24E"/>
-          </a:solidFill>
-          <a:ln>
-            <a:noFill/>
-          </a:ln>
-          <a:effectLst/>
-        </p:spPr>
-        <p:style>
-          <a:lnRef idx="1">
-            <a:schemeClr val="accent1"/>
-          </a:lnRef>
-          <a:fillRef idx="3">
-            <a:schemeClr val="accent1"/>
-          </a:fillRef>
-          <a:effectRef idx="2">
-            <a:schemeClr val="accent1"/>
-          </a:effectRef>
-          <a:fontRef idx="minor">
-            <a:schemeClr val="lt1"/>
-          </a:fontRef>
-        </p:style>
-        <p:txBody>
-          <a:bodyPr rtlCol="0" anchor="ctr"/>
-          <a:lstStyle/>
-          <a:p>
-            <a:pPr algn="ctr"/>
-          </a:p>
-        </p:txBody>
-      </p:sp>
-      <p:pic>
-        <p:nvPicPr>
           <p:cNvPr id="21" name="Stat icon 2" descr="Stat icon 2"/>
           <p:cNvPicPr>
             <a:picLocks noChangeAspect="1"/>
@@ -6281,7 +6281,7 @@
         </p:blipFill>
         <p:spPr>
           <a:xfrm>
-            <a:off x="6291986" y="4124858"/>
+            <a:off x="6291986" y="4554626"/>
             <a:ext cx="309067" cy="309067"/>
           </a:xfrm>
           <a:prstGeom prst="rect">
@@ -6297,7 +6297,7 @@
         </p:nvSpPr>
         <p:spPr>
           <a:xfrm>
-            <a:off x="6949440" y="3730752"/>
+            <a:off x="6949440" y="4142232"/>
             <a:ext cx="4206240" cy="640080"/>
           </a:xfrm>
           <a:prstGeom prst="rect">
@@ -6331,7 +6331,7 @@
         </p:nvSpPr>
         <p:spPr>
           <a:xfrm>
-            <a:off x="6949440" y="4370832"/>
+            <a:off x="6949440" y="4800600"/>
             <a:ext cx="4206240" cy="457200"/>
           </a:xfrm>
           <a:prstGeom prst="rect">
@@ -6353,95 +6353,6 @@
                 <a:latin typeface="Source Sans Pro"/>
               </a:rPr>
               <a:t>new employees were referred by someone inside CCIG</a:t>
-            </a:r>
-          </a:p>
-        </p:txBody>
-      </p:sp>
-      <p:sp>
-        <p:nvSpPr>
-          <p:cNvPr id="24" name="Bottom line card"/>
-          <p:cNvSpPr/>
-          <p:nvPr/>
-        </p:nvSpPr>
-        <p:spPr>
-          <a:xfrm>
-            <a:off x="960120" y="5212080"/>
-            <a:ext cx="10360152" cy="731520"/>
-          </a:xfrm>
-          <a:prstGeom prst="roundRect">
-            <a:avLst>
-              <a:gd name="adj" fmla="val 8000"/>
-            </a:avLst>
-          </a:prstGeom>
-          <a:solidFill>
-            <a:srgbClr val="366E8E"/>
-          </a:solidFill>
-          <a:ln>
-            <a:noFill/>
-          </a:ln>
-          <a:effectLst/>
-        </p:spPr>
-        <p:style>
-          <a:lnRef idx="1">
-            <a:schemeClr val="accent1"/>
-          </a:lnRef>
-          <a:fillRef idx="3">
-            <a:schemeClr val="accent1"/>
-          </a:fillRef>
-          <a:effectRef idx="2">
-            <a:schemeClr val="accent1"/>
-          </a:effectRef>
-          <a:fontRef idx="minor">
-            <a:schemeClr val="lt1"/>
-          </a:fontRef>
-        </p:style>
-        <p:txBody>
-          <a:bodyPr rtlCol="0" anchor="ctr"/>
-          <a:lstStyle/>
-          <a:p>
-            <a:pPr algn="ctr"/>
-          </a:p>
-        </p:txBody>
-      </p:sp>
-      <p:sp>
-        <p:nvSpPr>
-          <p:cNvPr id="25" name="Bottom line text"/>
-          <p:cNvSpPr txBox="1"/>
-          <p:nvPr/>
-        </p:nvSpPr>
-        <p:spPr>
-          <a:xfrm>
-            <a:off x="1188720" y="5212080"/>
-            <a:ext cx="9902952" cy="731520"/>
-          </a:xfrm>
-          <a:prstGeom prst="rect">
-            <a:avLst/>
-          </a:prstGeom>
-          <a:noFill/>
-        </p:spPr>
-        <p:txBody>
-          <a:bodyPr wrap="square" lIns="0" rIns="0" tIns="0" bIns="0" anchor="ctr">
-            <a:spAutoFit/>
-          </a:bodyPr>
-          <a:lstStyle/>
-          <a:p>
-            <a:r>
-              <a:rPr sz="1200" b="1" i="0" spc="150">
-                <a:solidFill>
-                  <a:srgbClr val="FFC666"/>
-                </a:solidFill>
-                <a:latin typeface="Source Sans Pro"/>
-              </a:rPr>
-              <a:t>THE BOTTOM LINE   </a:t>
-            </a:r>
-            <a:r>
-              <a:rPr sz="1400" b="0" i="0">
-                <a:solidFill>
-                  <a:srgbClr val="FFFFFF"/>
-                </a:solidFill>
-                <a:latin typeface="Source Sans Pro"/>
-              </a:rPr>
-              <a:t>Growth creates opportunity to invest in our people, and it challenges our capacity, processes, and leadership. EOS gives us the structure to keep up.</a:t>
             </a:r>
           </a:p>
         </p:txBody>
@@ -6679,7 +6590,7 @@
         <p:spPr>
           <a:xfrm>
             <a:off x="960120" y="1920240"/>
-            <a:ext cx="5029200" cy="1417320"/>
+            <a:ext cx="5029200" cy="1737360"/>
           </a:xfrm>
           <a:prstGeom prst="roundRect">
             <a:avLst>
@@ -6724,7 +6635,7 @@
         </p:nvSpPr>
         <p:spPr>
           <a:xfrm>
-            <a:off x="1188719" y="2313432"/>
+            <a:off x="1188719" y="2468879"/>
             <a:ext cx="640080" cy="640080"/>
           </a:xfrm>
           <a:prstGeom prst="ellipse">
@@ -6776,7 +6687,7 @@
         </p:blipFill>
         <p:spPr>
           <a:xfrm>
-            <a:off x="1342339" y="2467051"/>
+            <a:off x="1342339" y="2622499"/>
             <a:ext cx="332841" cy="332841"/>
           </a:xfrm>
           <a:prstGeom prst="rect">
@@ -6793,7 +6704,7 @@
         <p:spPr>
           <a:xfrm>
             <a:off x="2011680" y="2084832"/>
-            <a:ext cx="3794760" cy="1143000"/>
+            <a:ext cx="3794760" cy="1417320"/>
           </a:xfrm>
           <a:prstGeom prst="rect">
             <a:avLst/>
@@ -6838,7 +6749,7 @@
         <p:spPr>
           <a:xfrm>
             <a:off x="6291072" y="1920240"/>
-            <a:ext cx="5029200" cy="1417320"/>
+            <a:ext cx="5029200" cy="1737360"/>
           </a:xfrm>
           <a:prstGeom prst="roundRect">
             <a:avLst>
@@ -6883,7 +6794,7 @@
         </p:nvSpPr>
         <p:spPr>
           <a:xfrm>
-            <a:off x="6519672" y="2313432"/>
+            <a:off x="6519672" y="2468879"/>
             <a:ext cx="640080" cy="640080"/>
           </a:xfrm>
           <a:prstGeom prst="ellipse">
@@ -6935,7 +6846,7 @@
         </p:blipFill>
         <p:spPr>
           <a:xfrm>
-            <a:off x="6673291" y="2467051"/>
+            <a:off x="6673291" y="2622499"/>
             <a:ext cx="332841" cy="332841"/>
           </a:xfrm>
           <a:prstGeom prst="rect">
@@ -6952,7 +6863,7 @@
         <p:spPr>
           <a:xfrm>
             <a:off x="7342631" y="2084832"/>
-            <a:ext cx="3794760" cy="1143000"/>
+            <a:ext cx="3794760" cy="1417320"/>
           </a:xfrm>
           <a:prstGeom prst="rect">
             <a:avLst/>
@@ -6996,8 +6907,8 @@
         </p:nvSpPr>
         <p:spPr>
           <a:xfrm>
-            <a:off x="960120" y="3474720"/>
-            <a:ext cx="5029200" cy="1417320"/>
+            <a:off x="960120" y="3794760"/>
+            <a:ext cx="5029200" cy="1737360"/>
           </a:xfrm>
           <a:prstGeom prst="roundRect">
             <a:avLst>
@@ -7042,7 +6953,7 @@
         </p:nvSpPr>
         <p:spPr>
           <a:xfrm>
-            <a:off x="1188719" y="3867912"/>
+            <a:off x="1188719" y="4343400"/>
             <a:ext cx="640080" cy="640080"/>
           </a:xfrm>
           <a:prstGeom prst="ellipse">
@@ -7094,7 +7005,7 @@
         </p:blipFill>
         <p:spPr>
           <a:xfrm>
-            <a:off x="1342339" y="4021531"/>
+            <a:off x="1342339" y="4497019"/>
             <a:ext cx="332841" cy="332841"/>
           </a:xfrm>
           <a:prstGeom prst="rect">
@@ -7110,8 +7021,8 @@
         </p:nvSpPr>
         <p:spPr>
           <a:xfrm>
-            <a:off x="2011680" y="3639312"/>
-            <a:ext cx="3794760" cy="1143000"/>
+            <a:off x="2011680" y="3959352"/>
+            <a:ext cx="3794760" cy="1417320"/>
           </a:xfrm>
           <a:prstGeom prst="rect">
             <a:avLst/>
@@ -7155,8 +7066,8 @@
         </p:nvSpPr>
         <p:spPr>
           <a:xfrm>
-            <a:off x="6291072" y="3474720"/>
-            <a:ext cx="5029200" cy="1417320"/>
+            <a:off x="6291072" y="3794760"/>
+            <a:ext cx="5029200" cy="1737360"/>
           </a:xfrm>
           <a:prstGeom prst="roundRect">
             <a:avLst>
@@ -7201,7 +7112,7 @@
         </p:nvSpPr>
         <p:spPr>
           <a:xfrm>
-            <a:off x="6519672" y="3867912"/>
+            <a:off x="6519672" y="4343400"/>
             <a:ext cx="640080" cy="640080"/>
           </a:xfrm>
           <a:prstGeom prst="ellipse">
@@ -7253,7 +7164,7 @@
         </p:blipFill>
         <p:spPr>
           <a:xfrm>
-            <a:off x="6673291" y="4021531"/>
+            <a:off x="6673291" y="4497019"/>
             <a:ext cx="332841" cy="332841"/>
           </a:xfrm>
           <a:prstGeom prst="rect">
@@ -7269,8 +7180,8 @@
         </p:nvSpPr>
         <p:spPr>
           <a:xfrm>
-            <a:off x="7342631" y="3639312"/>
-            <a:ext cx="3794760" cy="1143000"/>
+            <a:off x="7342631" y="3959352"/>
+            <a:ext cx="3794760" cy="1417320"/>
           </a:xfrm>
           <a:prstGeom prst="rect">
             <a:avLst/>
@@ -7302,95 +7213,6 @@
                 <a:latin typeface="Source Sans Pro"/>
               </a:rPr>
               <a:t>Keep the clients who trust us through responsiveness, follow-through, and raising concerns early.</a:t>
-            </a:r>
-          </a:p>
-        </p:txBody>
-      </p:sp>
-      <p:sp>
-        <p:nvSpPr>
-          <p:cNvPr id="25" name="Bottom line card"/>
-          <p:cNvSpPr/>
-          <p:nvPr/>
-        </p:nvSpPr>
-        <p:spPr>
-          <a:xfrm>
-            <a:off x="960120" y="5120640"/>
-            <a:ext cx="10360152" cy="640080"/>
-          </a:xfrm>
-          <a:prstGeom prst="roundRect">
-            <a:avLst>
-              <a:gd name="adj" fmla="val 8000"/>
-            </a:avLst>
-          </a:prstGeom>
-          <a:solidFill>
-            <a:srgbClr val="366E8E"/>
-          </a:solidFill>
-          <a:ln>
-            <a:noFill/>
-          </a:ln>
-          <a:effectLst/>
-        </p:spPr>
-        <p:style>
-          <a:lnRef idx="1">
-            <a:schemeClr val="accent1"/>
-          </a:lnRef>
-          <a:fillRef idx="3">
-            <a:schemeClr val="accent1"/>
-          </a:fillRef>
-          <a:effectRef idx="2">
-            <a:schemeClr val="accent1"/>
-          </a:effectRef>
-          <a:fontRef idx="minor">
-            <a:schemeClr val="lt1"/>
-          </a:fontRef>
-        </p:style>
-        <p:txBody>
-          <a:bodyPr rtlCol="0" anchor="ctr"/>
-          <a:lstStyle/>
-          <a:p>
-            <a:pPr algn="ctr"/>
-          </a:p>
-        </p:txBody>
-      </p:sp>
-      <p:sp>
-        <p:nvSpPr>
-          <p:cNvPr id="26" name="Bottom line text"/>
-          <p:cNvSpPr txBox="1"/>
-          <p:nvPr/>
-        </p:nvSpPr>
-        <p:spPr>
-          <a:xfrm>
-            <a:off x="1188720" y="5120640"/>
-            <a:ext cx="9902952" cy="640080"/>
-          </a:xfrm>
-          <a:prstGeom prst="rect">
-            <a:avLst/>
-          </a:prstGeom>
-          <a:noFill/>
-        </p:spPr>
-        <p:txBody>
-          <a:bodyPr wrap="square" lIns="0" rIns="0" tIns="0" bIns="0" anchor="ctr">
-            <a:spAutoFit/>
-          </a:bodyPr>
-          <a:lstStyle/>
-          <a:p>
-            <a:r>
-              <a:rPr sz="1200" b="1" i="0" spc="150">
-                <a:solidFill>
-                  <a:srgbClr val="FFC666"/>
-                </a:solidFill>
-                <a:latin typeface="Source Sans Pro"/>
-              </a:rPr>
-              <a:t>THE BOTTOM LINE   </a:t>
-            </a:r>
-            <a:r>
-              <a:rPr sz="1400" b="0" i="0">
-                <a:solidFill>
-                  <a:srgbClr val="FFFFFF"/>
-                </a:solidFill>
-                <a:latin typeface="Source Sans Pro"/>
-              </a:rPr>
-              <a:t>The value comes from solving the issue and making sure someone owns the next step.</a:t>
             </a:r>
           </a:p>
         </p:txBody>
@@ -7628,7 +7450,7 @@
         <p:spPr>
           <a:xfrm>
             <a:off x="960120" y="1920240"/>
-            <a:ext cx="5029200" cy="3337560"/>
+            <a:ext cx="5029200" cy="3611880"/>
           </a:xfrm>
           <a:prstGeom prst="roundRect">
             <a:avLst>
@@ -7741,7 +7563,7 @@
         </p:nvSpPr>
         <p:spPr>
           <a:xfrm>
-            <a:off x="1234440" y="2898648"/>
+            <a:off x="1234440" y="2944368"/>
             <a:ext cx="457200" cy="457200"/>
           </a:xfrm>
           <a:prstGeom prst="ellipse">
@@ -7793,7 +7615,7 @@
         </p:blipFill>
         <p:spPr>
           <a:xfrm>
-            <a:off x="1344168" y="3008376"/>
+            <a:off x="1344168" y="3054096"/>
             <a:ext cx="237744" cy="237744"/>
           </a:xfrm>
           <a:prstGeom prst="rect">
@@ -7809,7 +7631,7 @@
         </p:nvSpPr>
         <p:spPr>
           <a:xfrm>
-            <a:off x="1874519" y="2880360"/>
+            <a:off x="1874519" y="2926080"/>
             <a:ext cx="4023360" cy="530352"/>
           </a:xfrm>
           <a:prstGeom prst="rect">
@@ -7854,7 +7676,7 @@
         </p:nvSpPr>
         <p:spPr>
           <a:xfrm>
-            <a:off x="1234440" y="3483864"/>
+            <a:off x="1234440" y="3630168"/>
             <a:ext cx="457200" cy="457200"/>
           </a:xfrm>
           <a:prstGeom prst="ellipse">
@@ -7906,7 +7728,7 @@
         </p:blipFill>
         <p:spPr>
           <a:xfrm>
-            <a:off x="1344168" y="3593592"/>
+            <a:off x="1344168" y="3739896"/>
             <a:ext cx="237744" cy="237744"/>
           </a:xfrm>
           <a:prstGeom prst="rect">
@@ -7922,7 +7744,7 @@
         </p:nvSpPr>
         <p:spPr>
           <a:xfrm>
-            <a:off x="1874519" y="3465576"/>
+            <a:off x="1874519" y="3611880"/>
             <a:ext cx="4023360" cy="530352"/>
           </a:xfrm>
           <a:prstGeom prst="rect">
@@ -7967,7 +7789,7 @@
         </p:nvSpPr>
         <p:spPr>
           <a:xfrm>
-            <a:off x="1234440" y="4069079"/>
+            <a:off x="1234440" y="4315968"/>
             <a:ext cx="457200" cy="457200"/>
           </a:xfrm>
           <a:prstGeom prst="ellipse">
@@ -8019,7 +7841,7 @@
         </p:blipFill>
         <p:spPr>
           <a:xfrm>
-            <a:off x="1344168" y="4178807"/>
+            <a:off x="1344168" y="4425696"/>
             <a:ext cx="237744" cy="237744"/>
           </a:xfrm>
           <a:prstGeom prst="rect">
@@ -8035,7 +7857,7 @@
         </p:nvSpPr>
         <p:spPr>
           <a:xfrm>
-            <a:off x="1874519" y="4050791"/>
+            <a:off x="1874519" y="4297680"/>
             <a:ext cx="4023360" cy="530352"/>
           </a:xfrm>
           <a:prstGeom prst="rect">
@@ -8080,7 +7902,7 @@
         </p:nvSpPr>
         <p:spPr>
           <a:xfrm>
-            <a:off x="1234440" y="4654296"/>
+            <a:off x="1234440" y="5001768"/>
             <a:ext cx="457200" cy="457200"/>
           </a:xfrm>
           <a:prstGeom prst="ellipse">
@@ -8132,7 +7954,7 @@
         </p:blipFill>
         <p:spPr>
           <a:xfrm>
-            <a:off x="1344168" y="4764024"/>
+            <a:off x="1344168" y="5111496"/>
             <a:ext cx="237744" cy="237744"/>
           </a:xfrm>
           <a:prstGeom prst="rect">
@@ -8148,7 +7970,7 @@
         </p:nvSpPr>
         <p:spPr>
           <a:xfrm>
-            <a:off x="1874519" y="4636008"/>
+            <a:off x="1874519" y="4983480"/>
             <a:ext cx="4023360" cy="530352"/>
           </a:xfrm>
           <a:prstGeom prst="rect">
@@ -8194,7 +8016,7 @@
         <p:spPr>
           <a:xfrm>
             <a:off x="6291072" y="1920240"/>
-            <a:ext cx="5029200" cy="3337560"/>
+            <a:ext cx="5029200" cy="3611880"/>
           </a:xfrm>
           <a:prstGeom prst="roundRect">
             <a:avLst>
@@ -8307,7 +8129,7 @@
         </p:nvSpPr>
         <p:spPr>
           <a:xfrm>
-            <a:off x="6565392" y="2898648"/>
+            <a:off x="6565392" y="2944368"/>
             <a:ext cx="457200" cy="457200"/>
           </a:xfrm>
           <a:prstGeom prst="ellipse">
@@ -8359,7 +8181,7 @@
         </p:blipFill>
         <p:spPr>
           <a:xfrm>
-            <a:off x="6675120" y="3008376"/>
+            <a:off x="6675120" y="3054096"/>
             <a:ext cx="237744" cy="237744"/>
           </a:xfrm>
           <a:prstGeom prst="rect">
@@ -8375,7 +8197,7 @@
         </p:nvSpPr>
         <p:spPr>
           <a:xfrm>
-            <a:off x="7205472" y="2880360"/>
+            <a:off x="7205472" y="2926080"/>
             <a:ext cx="4023360" cy="530352"/>
           </a:xfrm>
           <a:prstGeom prst="rect">
@@ -8420,7 +8242,7 @@
         </p:nvSpPr>
         <p:spPr>
           <a:xfrm>
-            <a:off x="6565392" y="3630168"/>
+            <a:off x="6565392" y="3813048"/>
             <a:ext cx="457200" cy="457200"/>
           </a:xfrm>
           <a:prstGeom prst="ellipse">
@@ -8472,7 +8294,7 @@
         </p:blipFill>
         <p:spPr>
           <a:xfrm>
-            <a:off x="6675120" y="3739896"/>
+            <a:off x="6675120" y="3922776"/>
             <a:ext cx="237744" cy="237744"/>
           </a:xfrm>
           <a:prstGeom prst="rect">
@@ -8488,7 +8310,7 @@
         </p:nvSpPr>
         <p:spPr>
           <a:xfrm>
-            <a:off x="7205472" y="3611880"/>
+            <a:off x="7205472" y="3794760"/>
             <a:ext cx="4023360" cy="530352"/>
           </a:xfrm>
           <a:prstGeom prst="rect">
@@ -8533,7 +8355,7 @@
         </p:nvSpPr>
         <p:spPr>
           <a:xfrm>
-            <a:off x="6565392" y="4361688"/>
+            <a:off x="6565392" y="4681727"/>
             <a:ext cx="457200" cy="457200"/>
           </a:xfrm>
           <a:prstGeom prst="ellipse">
@@ -8585,7 +8407,7 @@
         </p:blipFill>
         <p:spPr>
           <a:xfrm>
-            <a:off x="6675120" y="4471416"/>
+            <a:off x="6675120" y="4791455"/>
             <a:ext cx="237744" cy="237744"/>
           </a:xfrm>
           <a:prstGeom prst="rect">
@@ -8601,7 +8423,7 @@
         </p:nvSpPr>
         <p:spPr>
           <a:xfrm>
-            <a:off x="7205472" y="4343400"/>
+            <a:off x="7205472" y="4663440"/>
             <a:ext cx="4023360" cy="530352"/>
           </a:xfrm>
           <a:prstGeom prst="rect">
@@ -8634,95 +8456,6 @@
                 <a:latin typeface="Source Sans Pro"/>
               </a:rPr>
               <a:t>Move the most important improvements forward</a:t>
-            </a:r>
-          </a:p>
-        </p:txBody>
-      </p:sp>
-      <p:sp>
-        <p:nvSpPr>
-          <p:cNvPr id="36" name="Bottom line card"/>
-          <p:cNvSpPr/>
-          <p:nvPr/>
-        </p:nvSpPr>
-        <p:spPr>
-          <a:xfrm>
-            <a:off x="960120" y="5440680"/>
-            <a:ext cx="10360152" cy="548640"/>
-          </a:xfrm>
-          <a:prstGeom prst="roundRect">
-            <a:avLst>
-              <a:gd name="adj" fmla="val 8000"/>
-            </a:avLst>
-          </a:prstGeom>
-          <a:solidFill>
-            <a:srgbClr val="366E8E"/>
-          </a:solidFill>
-          <a:ln>
-            <a:noFill/>
-          </a:ln>
-          <a:effectLst/>
-        </p:spPr>
-        <p:style>
-          <a:lnRef idx="1">
-            <a:schemeClr val="accent1"/>
-          </a:lnRef>
-          <a:fillRef idx="3">
-            <a:schemeClr val="accent1"/>
-          </a:fillRef>
-          <a:effectRef idx="2">
-            <a:schemeClr val="accent1"/>
-          </a:effectRef>
-          <a:fontRef idx="minor">
-            <a:schemeClr val="lt1"/>
-          </a:fontRef>
-        </p:style>
-        <p:txBody>
-          <a:bodyPr rtlCol="0" anchor="ctr"/>
-          <a:lstStyle/>
-          <a:p>
-            <a:pPr algn="ctr"/>
-          </a:p>
-        </p:txBody>
-      </p:sp>
-      <p:sp>
-        <p:nvSpPr>
-          <p:cNvPr id="37" name="Bottom line text"/>
-          <p:cNvSpPr txBox="1"/>
-          <p:nvPr/>
-        </p:nvSpPr>
-        <p:spPr>
-          <a:xfrm>
-            <a:off x="1188720" y="5440680"/>
-            <a:ext cx="9902952" cy="548640"/>
-          </a:xfrm>
-          <a:prstGeom prst="rect">
-            <a:avLst/>
-          </a:prstGeom>
-          <a:noFill/>
-        </p:spPr>
-        <p:txBody>
-          <a:bodyPr wrap="square" lIns="0" rIns="0" tIns="0" bIns="0" anchor="ctr">
-            <a:spAutoFit/>
-          </a:bodyPr>
-          <a:lstStyle/>
-          <a:p>
-            <a:r>
-              <a:rPr sz="1200" b="1" i="0" spc="150">
-                <a:solidFill>
-                  <a:srgbClr val="FFC666"/>
-                </a:solidFill>
-                <a:latin typeface="Source Sans Pro"/>
-              </a:rPr>
-              <a:t>THE BOTTOM LINE   </a:t>
-            </a:r>
-            <a:r>
-              <a:rPr sz="1400" b="0" i="0">
-                <a:solidFill>
-                  <a:srgbClr val="FFFFFF"/>
-                </a:solidFill>
-                <a:latin typeface="Source Sans Pro"/>
-              </a:rPr>
-              <a:t>Retention remains a challenge. Bring the same focus to keeping clients as to winning them.</a:t>
             </a:r>
           </a:p>
         </p:txBody>
@@ -8960,7 +8693,7 @@
         <p:spPr>
           <a:xfrm>
             <a:off x="960120" y="1920240"/>
-            <a:ext cx="3200400" cy="2468880"/>
+            <a:ext cx="3200400" cy="2743200"/>
           </a:xfrm>
           <a:prstGeom prst="roundRect">
             <a:avLst>
@@ -9107,7 +8840,7 @@
         </p:nvSpPr>
         <p:spPr>
           <a:xfrm>
-            <a:off x="1143000" y="2743200"/>
+            <a:off x="1143000" y="2834640"/>
             <a:ext cx="2834640" cy="621792"/>
           </a:xfrm>
           <a:prstGeom prst="roundRect">
@@ -9153,7 +8886,7 @@
         </p:nvSpPr>
         <p:spPr>
           <a:xfrm>
-            <a:off x="1280160" y="2743200"/>
+            <a:off x="1280160" y="2834640"/>
             <a:ext cx="2560320" cy="621792"/>
           </a:xfrm>
           <a:prstGeom prst="rect">
@@ -9198,7 +8931,7 @@
         </p:nvSpPr>
         <p:spPr>
           <a:xfrm>
-            <a:off x="1143000" y="3520440"/>
+            <a:off x="1143000" y="3703320"/>
             <a:ext cx="2834640" cy="685800"/>
           </a:xfrm>
           <a:prstGeom prst="roundRect">
@@ -9244,7 +8977,7 @@
         </p:nvSpPr>
         <p:spPr>
           <a:xfrm>
-            <a:off x="1280160" y="3520440"/>
+            <a:off x="1280160" y="3703320"/>
             <a:ext cx="2560320" cy="685800"/>
           </a:xfrm>
           <a:prstGeom prst="rect">
@@ -9290,7 +9023,7 @@
         <p:spPr>
           <a:xfrm>
             <a:off x="4539996" y="1920240"/>
-            <a:ext cx="3200400" cy="2468880"/>
+            <a:ext cx="3200400" cy="2743200"/>
           </a:xfrm>
           <a:prstGeom prst="roundRect">
             <a:avLst>
@@ -9437,7 +9170,7 @@
         </p:nvSpPr>
         <p:spPr>
           <a:xfrm>
-            <a:off x="4722876" y="2743200"/>
+            <a:off x="4722876" y="2834640"/>
             <a:ext cx="2834640" cy="621792"/>
           </a:xfrm>
           <a:prstGeom prst="roundRect">
@@ -9483,7 +9216,7 @@
         </p:nvSpPr>
         <p:spPr>
           <a:xfrm>
-            <a:off x="4860036" y="2743200"/>
+            <a:off x="4860036" y="2834640"/>
             <a:ext cx="2560320" cy="621792"/>
           </a:xfrm>
           <a:prstGeom prst="rect">
@@ -9528,7 +9261,7 @@
         </p:nvSpPr>
         <p:spPr>
           <a:xfrm>
-            <a:off x="4722876" y="3520440"/>
+            <a:off x="4722876" y="3703320"/>
             <a:ext cx="2834640" cy="685800"/>
           </a:xfrm>
           <a:prstGeom prst="roundRect">
@@ -9574,7 +9307,7 @@
         </p:nvSpPr>
         <p:spPr>
           <a:xfrm>
-            <a:off x="4860036" y="3520440"/>
+            <a:off x="4860036" y="3703320"/>
             <a:ext cx="2560320" cy="685800"/>
           </a:xfrm>
           <a:prstGeom prst="rect">
@@ -9620,7 +9353,7 @@
         <p:spPr>
           <a:xfrm>
             <a:off x="8119872" y="1920240"/>
-            <a:ext cx="3200400" cy="2468880"/>
+            <a:ext cx="3200400" cy="2743200"/>
           </a:xfrm>
           <a:prstGeom prst="roundRect">
             <a:avLst>
@@ -9767,7 +9500,7 @@
         </p:nvSpPr>
         <p:spPr>
           <a:xfrm>
-            <a:off x="8302752" y="2743200"/>
+            <a:off x="8302752" y="2834640"/>
             <a:ext cx="2834640" cy="621792"/>
           </a:xfrm>
           <a:prstGeom prst="roundRect">
@@ -9813,7 +9546,7 @@
         </p:nvSpPr>
         <p:spPr>
           <a:xfrm>
-            <a:off x="8439912" y="2743200"/>
+            <a:off x="8439912" y="2834640"/>
             <a:ext cx="2560320" cy="621792"/>
           </a:xfrm>
           <a:prstGeom prst="rect">
@@ -9858,7 +9591,7 @@
         </p:nvSpPr>
         <p:spPr>
           <a:xfrm>
-            <a:off x="8302752" y="3520440"/>
+            <a:off x="8302752" y="3703320"/>
             <a:ext cx="2834640" cy="685800"/>
           </a:xfrm>
           <a:prstGeom prst="roundRect">
@@ -9904,7 +9637,7 @@
         </p:nvSpPr>
         <p:spPr>
           <a:xfrm>
-            <a:off x="8439912" y="3520440"/>
+            <a:off x="8439912" y="3703320"/>
             <a:ext cx="2560320" cy="685800"/>
           </a:xfrm>
           <a:prstGeom prst="rect">
@@ -9949,7 +9682,7 @@
         </p:nvSpPr>
         <p:spPr>
           <a:xfrm>
-            <a:off x="960120" y="4526280"/>
+            <a:off x="960120" y="4846320"/>
             <a:ext cx="10360152" cy="777240"/>
           </a:xfrm>
           <a:prstGeom prst="roundRect">
@@ -9995,7 +9728,7 @@
         </p:nvSpPr>
         <p:spPr>
           <a:xfrm>
-            <a:off x="1280160" y="4640580"/>
+            <a:off x="1280160" y="4960620"/>
             <a:ext cx="548640" cy="548640"/>
           </a:xfrm>
           <a:prstGeom prst="ellipse">
@@ -10047,7 +9780,7 @@
         </p:blipFill>
         <p:spPr>
           <a:xfrm>
-            <a:off x="1411833" y="4772253"/>
+            <a:off x="1411833" y="5092293"/>
             <a:ext cx="285292" cy="285292"/>
           </a:xfrm>
           <a:prstGeom prst="rect">
@@ -10063,7 +9796,7 @@
         </p:nvSpPr>
         <p:spPr>
           <a:xfrm>
-            <a:off x="2057400" y="4526280"/>
+            <a:off x="2057400" y="4846320"/>
             <a:ext cx="9144000" cy="777240"/>
           </a:xfrm>
           <a:prstGeom prst="rect">
@@ -10094,95 +9827,6 @@
                 <a:latin typeface="Source Sans Pro"/>
               </a:rPr>
               <a:t>understand why clients leave, identify patterns, and turn what we learn into changes that stick.</a:t>
-            </a:r>
-          </a:p>
-        </p:txBody>
-      </p:sp>
-      <p:sp>
-        <p:nvSpPr>
-          <p:cNvPr id="37" name="Bottom line card"/>
-          <p:cNvSpPr/>
-          <p:nvPr/>
-        </p:nvSpPr>
-        <p:spPr>
-          <a:xfrm>
-            <a:off x="960120" y="5440680"/>
-            <a:ext cx="10360152" cy="548640"/>
-          </a:xfrm>
-          <a:prstGeom prst="roundRect">
-            <a:avLst>
-              <a:gd name="adj" fmla="val 8000"/>
-            </a:avLst>
-          </a:prstGeom>
-          <a:solidFill>
-            <a:srgbClr val="366E8E"/>
-          </a:solidFill>
-          <a:ln>
-            <a:noFill/>
-          </a:ln>
-          <a:effectLst/>
-        </p:spPr>
-        <p:style>
-          <a:lnRef idx="1">
-            <a:schemeClr val="accent1"/>
-          </a:lnRef>
-          <a:fillRef idx="3">
-            <a:schemeClr val="accent1"/>
-          </a:fillRef>
-          <a:effectRef idx="2">
-            <a:schemeClr val="accent1"/>
-          </a:effectRef>
-          <a:fontRef idx="minor">
-            <a:schemeClr val="lt1"/>
-          </a:fontRef>
-        </p:style>
-        <p:txBody>
-          <a:bodyPr rtlCol="0" anchor="ctr"/>
-          <a:lstStyle/>
-          <a:p>
-            <a:pPr algn="ctr"/>
-          </a:p>
-        </p:txBody>
-      </p:sp>
-      <p:sp>
-        <p:nvSpPr>
-          <p:cNvPr id="38" name="Bottom line text"/>
-          <p:cNvSpPr txBox="1"/>
-          <p:nvPr/>
-        </p:nvSpPr>
-        <p:spPr>
-          <a:xfrm>
-            <a:off x="1188720" y="5440680"/>
-            <a:ext cx="9902952" cy="548640"/>
-          </a:xfrm>
-          <a:prstGeom prst="rect">
-            <a:avLst/>
-          </a:prstGeom>
-          <a:noFill/>
-        </p:spPr>
-        <p:txBody>
-          <a:bodyPr wrap="square" lIns="0" rIns="0" tIns="0" bIns="0" anchor="ctr">
-            <a:spAutoFit/>
-          </a:bodyPr>
-          <a:lstStyle/>
-          <a:p>
-            <a:r>
-              <a:rPr sz="1200" b="1" i="0" spc="150">
-                <a:solidFill>
-                  <a:srgbClr val="FFC666"/>
-                </a:solidFill>
-                <a:latin typeface="Source Sans Pro"/>
-              </a:rPr>
-              <a:t>THE BOTTOM LINE   </a:t>
-            </a:r>
-            <a:r>
-              <a:rPr sz="1400" b="0" i="0">
-                <a:solidFill>
-                  <a:srgbClr val="FFFFFF"/>
-                </a:solidFill>
-                <a:latin typeface="Source Sans Pro"/>
-              </a:rPr>
-              <a:t>That work is especially challenging when teams already have full schedules.</a:t>
             </a:r>
           </a:p>
         </p:txBody>

</xml_diff>

<commit_message>
Add P&C rate environment and organic growth chart slides
Co-Authored-By: Claude Sonnet 5.5 <noreply@anthropic.com>
Claude-Session: https://claude.ai/code/session_013DXsjPawU7xQxqcoPwwbM8
</commit_message>
<xml_diff>
--- a/Market Update/CCIG_Market_Update_Slides_CCIG-Brand.pptx
+++ b/Market Update/CCIG_Market_Update_Slides_CCIG-Brand.pptx
@@ -11,6 +11,8 @@
   <p:sldIdLst>
     <p:sldId id="333" r:id="rId9"/>
     <p:sldId id="336" r:id="rId21"/>
+    <p:sldId id="342" r:id="rId27"/>
+    <p:sldId id="341" r:id="rId26"/>
     <p:sldId id="340" r:id="rId25"/>
     <p:sldId id="339" r:id="rId24"/>
     <p:sldId id="338" r:id="rId23"/>
@@ -339,6 +341,2106 @@
 </c:chartSpace>
 </file>
 
+<file path=ppt/charts/chart2.xml><?xml version="1.0" encoding="utf-8"?>
+<c:chartSpace xmlns:c="http://schemas.openxmlformats.org/drawingml/2006/chart" xmlns:a="http://schemas.openxmlformats.org/drawingml/2006/main" xmlns:r="http://schemas.openxmlformats.org/officeDocument/2006/relationships">
+  <c:date1904 val="0"/>
+  <c:chart>
+    <c:autoTitleDeleted val="1"/>
+    <c:plotArea>
+      <c:lineChart>
+        <c:grouping val="standard"/>
+        <c:varyColors val="0"/>
+        <c:ser>
+          <c:idx val="0"/>
+          <c:order val="0"/>
+          <c:tx>
+            <c:strRef>
+              <c:f>Sheet1!$B$1</c:f>
+              <c:strCache>
+                <c:ptCount val="1"/>
+                <c:pt idx="0">
+                  <c:v>CIAB P&amp;C rate changes</c:v>
+                </c:pt>
+              </c:strCache>
+            </c:strRef>
+          </c:tx>
+          <c:spPr>
+            <a:ln w="28575">
+              <a:solidFill>
+                <a:srgbClr val="FFC666"/>
+              </a:solidFill>
+            </a:ln>
+          </c:spPr>
+          <c:marker>
+            <c:symbol val="circle"/>
+            <c:size val="6"/>
+            <c:spPr>
+              <a:solidFill>
+                <a:srgbClr val="FFC666"/>
+              </a:solidFill>
+              <a:ln>
+                <a:solidFill>
+                  <a:srgbClr val="FFC666"/>
+                </a:solidFill>
+              </a:ln>
+            </c:spPr>
+          </c:marker>
+          <c:dLbls>
+            <c:dLbl>
+              <c:idx val="0"/>
+              <c:spPr/>
+              <c:txPr>
+                <a:bodyPr/>
+                <a:lstStyle/>
+                <a:p>
+                  <a:pPr>
+                    <a:defRPr sz="1000" b="0">
+                      <a:solidFill>
+                        <a:srgbClr val="FFC666"/>
+                      </a:solidFill>
+                      <a:latin typeface="Source Sans Pro"/>
+                    </a:defRPr>
+                  </a:pPr>
+                </a:p>
+              </c:txPr>
+              <c:dLblPos val="t"/>
+              <c:showLegendKey val="0"/>
+              <c:showVal val="1"/>
+              <c:showCatName val="0"/>
+              <c:showSerName val="0"/>
+              <c:showPercent val="0"/>
+              <c:showBubbleSize val="0"/>
+            </c:dLbl>
+            <c:dLbl>
+              <c:idx val="1"/>
+              <c:spPr/>
+              <c:txPr>
+                <a:bodyPr/>
+                <a:lstStyle/>
+                <a:p>
+                  <a:pPr>
+                    <a:defRPr sz="1000" b="0">
+                      <a:solidFill>
+                        <a:srgbClr val="FFC666"/>
+                      </a:solidFill>
+                      <a:latin typeface="Source Sans Pro"/>
+                    </a:defRPr>
+                  </a:pPr>
+                </a:p>
+              </c:txPr>
+              <c:dLblPos val="t"/>
+              <c:showLegendKey val="0"/>
+              <c:showVal val="1"/>
+              <c:showCatName val="0"/>
+              <c:showSerName val="0"/>
+              <c:showPercent val="0"/>
+              <c:showBubbleSize val="0"/>
+            </c:dLbl>
+            <c:dLbl>
+              <c:idx val="2"/>
+              <c:spPr/>
+              <c:txPr>
+                <a:bodyPr/>
+                <a:lstStyle/>
+                <a:p>
+                  <a:pPr>
+                    <a:defRPr sz="1000" b="0">
+                      <a:solidFill>
+                        <a:srgbClr val="FFC666"/>
+                      </a:solidFill>
+                      <a:latin typeface="Source Sans Pro"/>
+                    </a:defRPr>
+                  </a:pPr>
+                </a:p>
+              </c:txPr>
+              <c:dLblPos val="t"/>
+              <c:showLegendKey val="0"/>
+              <c:showVal val="1"/>
+              <c:showCatName val="0"/>
+              <c:showSerName val="0"/>
+              <c:showPercent val="0"/>
+              <c:showBubbleSize val="0"/>
+            </c:dLbl>
+            <c:dLbl>
+              <c:idx val="3"/>
+              <c:spPr/>
+              <c:txPr>
+                <a:bodyPr/>
+                <a:lstStyle/>
+                <a:p>
+                  <a:pPr>
+                    <a:defRPr sz="1000" b="0">
+                      <a:solidFill>
+                        <a:srgbClr val="FFC666"/>
+                      </a:solidFill>
+                      <a:latin typeface="Source Sans Pro"/>
+                    </a:defRPr>
+                  </a:pPr>
+                </a:p>
+              </c:txPr>
+              <c:dLblPos val="t"/>
+              <c:showLegendKey val="0"/>
+              <c:showVal val="1"/>
+              <c:showCatName val="0"/>
+              <c:showSerName val="0"/>
+              <c:showPercent val="0"/>
+              <c:showBubbleSize val="0"/>
+            </c:dLbl>
+            <c:dLbl>
+              <c:idx val="4"/>
+              <c:spPr/>
+              <c:txPr>
+                <a:bodyPr/>
+                <a:lstStyle/>
+                <a:p>
+                  <a:pPr>
+                    <a:defRPr sz="1000" b="0">
+                      <a:solidFill>
+                        <a:srgbClr val="FFC666"/>
+                      </a:solidFill>
+                      <a:latin typeface="Source Sans Pro"/>
+                    </a:defRPr>
+                  </a:pPr>
+                </a:p>
+              </c:txPr>
+              <c:dLblPos val="t"/>
+              <c:showLegendKey val="0"/>
+              <c:showVal val="1"/>
+              <c:showCatName val="0"/>
+              <c:showSerName val="0"/>
+              <c:showPercent val="0"/>
+              <c:showBubbleSize val="0"/>
+            </c:dLbl>
+            <c:dLbl>
+              <c:idx val="5"/>
+              <c:spPr/>
+              <c:txPr>
+                <a:bodyPr/>
+                <a:lstStyle/>
+                <a:p>
+                  <a:pPr>
+                    <a:defRPr sz="1000" b="0">
+                      <a:solidFill>
+                        <a:srgbClr val="FFC666"/>
+                      </a:solidFill>
+                      <a:latin typeface="Source Sans Pro"/>
+                    </a:defRPr>
+                  </a:pPr>
+                </a:p>
+              </c:txPr>
+              <c:dLblPos val="t"/>
+              <c:showLegendKey val="0"/>
+              <c:showVal val="1"/>
+              <c:showCatName val="0"/>
+              <c:showSerName val="0"/>
+              <c:showPercent val="0"/>
+              <c:showBubbleSize val="0"/>
+            </c:dLbl>
+            <c:dLbl>
+              <c:idx val="6"/>
+              <c:spPr/>
+              <c:txPr>
+                <a:bodyPr/>
+                <a:lstStyle/>
+                <a:p>
+                  <a:pPr>
+                    <a:defRPr sz="1000" b="0">
+                      <a:solidFill>
+                        <a:srgbClr val="FFC666"/>
+                      </a:solidFill>
+                      <a:latin typeface="Source Sans Pro"/>
+                    </a:defRPr>
+                  </a:pPr>
+                </a:p>
+              </c:txPr>
+              <c:dLblPos val="t"/>
+              <c:showLegendKey val="0"/>
+              <c:showVal val="1"/>
+              <c:showCatName val="0"/>
+              <c:showSerName val="0"/>
+              <c:showPercent val="0"/>
+              <c:showBubbleSize val="0"/>
+            </c:dLbl>
+            <c:dLbl>
+              <c:idx val="7"/>
+              <c:spPr/>
+              <c:txPr>
+                <a:bodyPr/>
+                <a:lstStyle/>
+                <a:p>
+                  <a:pPr>
+                    <a:defRPr sz="1000" b="0">
+                      <a:solidFill>
+                        <a:srgbClr val="FFC666"/>
+                      </a:solidFill>
+                      <a:latin typeface="Source Sans Pro"/>
+                    </a:defRPr>
+                  </a:pPr>
+                </a:p>
+              </c:txPr>
+              <c:dLblPos val="t"/>
+              <c:showLegendKey val="0"/>
+              <c:showVal val="1"/>
+              <c:showCatName val="0"/>
+              <c:showSerName val="0"/>
+              <c:showPercent val="0"/>
+              <c:showBubbleSize val="0"/>
+            </c:dLbl>
+            <c:dLbl>
+              <c:idx val="8"/>
+              <c:spPr/>
+              <c:txPr>
+                <a:bodyPr/>
+                <a:lstStyle/>
+                <a:p>
+                  <a:pPr>
+                    <a:defRPr sz="1000" b="0">
+                      <a:solidFill>
+                        <a:srgbClr val="FFC666"/>
+                      </a:solidFill>
+                      <a:latin typeface="Source Sans Pro"/>
+                    </a:defRPr>
+                  </a:pPr>
+                </a:p>
+              </c:txPr>
+              <c:dLblPos val="t"/>
+              <c:showLegendKey val="0"/>
+              <c:showVal val="1"/>
+              <c:showCatName val="0"/>
+              <c:showSerName val="0"/>
+              <c:showPercent val="0"/>
+              <c:showBubbleSize val="0"/>
+            </c:dLbl>
+            <c:dLbl>
+              <c:idx val="9"/>
+              <c:spPr/>
+              <c:txPr>
+                <a:bodyPr/>
+                <a:lstStyle/>
+                <a:p>
+                  <a:pPr>
+                    <a:defRPr sz="1000" b="0">
+                      <a:solidFill>
+                        <a:srgbClr val="FFC666"/>
+                      </a:solidFill>
+                      <a:latin typeface="Source Sans Pro"/>
+                    </a:defRPr>
+                  </a:pPr>
+                </a:p>
+              </c:txPr>
+              <c:dLblPos val="t"/>
+              <c:showLegendKey val="0"/>
+              <c:showVal val="1"/>
+              <c:showCatName val="0"/>
+              <c:showSerName val="0"/>
+              <c:showPercent val="0"/>
+              <c:showBubbleSize val="0"/>
+            </c:dLbl>
+            <c:dLbl>
+              <c:idx val="10"/>
+              <c:spPr/>
+              <c:txPr>
+                <a:bodyPr/>
+                <a:lstStyle/>
+                <a:p>
+                  <a:pPr>
+                    <a:defRPr sz="1000" b="0">
+                      <a:solidFill>
+                        <a:srgbClr val="FFC666"/>
+                      </a:solidFill>
+                      <a:latin typeface="Source Sans Pro"/>
+                    </a:defRPr>
+                  </a:pPr>
+                </a:p>
+              </c:txPr>
+              <c:dLblPos val="t"/>
+              <c:showLegendKey val="0"/>
+              <c:showVal val="1"/>
+              <c:showCatName val="0"/>
+              <c:showSerName val="0"/>
+              <c:showPercent val="0"/>
+              <c:showBubbleSize val="0"/>
+            </c:dLbl>
+            <c:dLbl>
+              <c:idx val="11"/>
+              <c:spPr/>
+              <c:txPr>
+                <a:bodyPr/>
+                <a:lstStyle/>
+                <a:p>
+                  <a:pPr>
+                    <a:defRPr sz="1000" b="0">
+                      <a:solidFill>
+                        <a:srgbClr val="FFC666"/>
+                      </a:solidFill>
+                      <a:latin typeface="Source Sans Pro"/>
+                    </a:defRPr>
+                  </a:pPr>
+                </a:p>
+              </c:txPr>
+              <c:dLblPos val="t"/>
+              <c:showLegendKey val="0"/>
+              <c:showVal val="1"/>
+              <c:showCatName val="0"/>
+              <c:showSerName val="0"/>
+              <c:showPercent val="0"/>
+              <c:showBubbleSize val="0"/>
+            </c:dLbl>
+            <c:dLbl>
+              <c:idx val="12"/>
+              <c:spPr/>
+              <c:txPr>
+                <a:bodyPr/>
+                <a:lstStyle/>
+                <a:p>
+                  <a:pPr>
+                    <a:defRPr sz="1000" b="0">
+                      <a:solidFill>
+                        <a:srgbClr val="FFC666"/>
+                      </a:solidFill>
+                      <a:latin typeface="Source Sans Pro"/>
+                    </a:defRPr>
+                  </a:pPr>
+                </a:p>
+              </c:txPr>
+              <c:dLblPos val="t"/>
+              <c:showLegendKey val="0"/>
+              <c:showVal val="1"/>
+              <c:showCatName val="0"/>
+              <c:showSerName val="0"/>
+              <c:showPercent val="0"/>
+              <c:showBubbleSize val="0"/>
+            </c:dLbl>
+            <c:dLbl>
+              <c:idx val="13"/>
+              <c:spPr/>
+              <c:txPr>
+                <a:bodyPr/>
+                <a:lstStyle/>
+                <a:p>
+                  <a:pPr>
+                    <a:defRPr sz="1000" b="0">
+                      <a:solidFill>
+                        <a:srgbClr val="FFC666"/>
+                      </a:solidFill>
+                      <a:latin typeface="Source Sans Pro"/>
+                    </a:defRPr>
+                  </a:pPr>
+                </a:p>
+              </c:txPr>
+              <c:dLblPos val="t"/>
+              <c:showLegendKey val="0"/>
+              <c:showVal val="1"/>
+              <c:showCatName val="0"/>
+              <c:showSerName val="0"/>
+              <c:showPercent val="0"/>
+              <c:showBubbleSize val="0"/>
+            </c:dLbl>
+            <c:dLbl>
+              <c:idx val="14"/>
+              <c:spPr/>
+              <c:txPr>
+                <a:bodyPr/>
+                <a:lstStyle/>
+                <a:p>
+                  <a:pPr>
+                    <a:defRPr sz="1000" b="0">
+                      <a:solidFill>
+                        <a:srgbClr val="FFC666"/>
+                      </a:solidFill>
+                      <a:latin typeface="Source Sans Pro"/>
+                    </a:defRPr>
+                  </a:pPr>
+                </a:p>
+              </c:txPr>
+              <c:dLblPos val="t"/>
+              <c:showLegendKey val="0"/>
+              <c:showVal val="1"/>
+              <c:showCatName val="0"/>
+              <c:showSerName val="0"/>
+              <c:showPercent val="0"/>
+              <c:showBubbleSize val="0"/>
+            </c:dLbl>
+            <c:dLbl>
+              <c:idx val="15"/>
+              <c:spPr/>
+              <c:txPr>
+                <a:bodyPr/>
+                <a:lstStyle/>
+                <a:p>
+                  <a:pPr>
+                    <a:defRPr sz="1000" b="0">
+                      <a:solidFill>
+                        <a:srgbClr val="FFC666"/>
+                      </a:solidFill>
+                      <a:latin typeface="Source Sans Pro"/>
+                    </a:defRPr>
+                  </a:pPr>
+                </a:p>
+              </c:txPr>
+              <c:dLblPos val="t"/>
+              <c:showLegendKey val="0"/>
+              <c:showVal val="1"/>
+              <c:showCatName val="0"/>
+              <c:showSerName val="0"/>
+              <c:showPercent val="0"/>
+              <c:showBubbleSize val="0"/>
+            </c:dLbl>
+            <c:dLbl>
+              <c:idx val="16"/>
+              <c:spPr/>
+              <c:txPr>
+                <a:bodyPr/>
+                <a:lstStyle/>
+                <a:p>
+                  <a:pPr>
+                    <a:defRPr sz="1000" b="0">
+                      <a:solidFill>
+                        <a:srgbClr val="FFC666"/>
+                      </a:solidFill>
+                      <a:latin typeface="Source Sans Pro"/>
+                    </a:defRPr>
+                  </a:pPr>
+                </a:p>
+              </c:txPr>
+              <c:dLblPos val="t"/>
+              <c:showLegendKey val="0"/>
+              <c:showVal val="1"/>
+              <c:showCatName val="0"/>
+              <c:showSerName val="0"/>
+              <c:showPercent val="0"/>
+              <c:showBubbleSize val="0"/>
+            </c:dLbl>
+            <c:numFmt formatCode="0.0&quot;%&quot;;(0.0&quot;%&quot;);&quot;-&quot;" sourceLinked="0"/>
+            <c:txPr>
+              <a:bodyPr/>
+              <a:lstStyle/>
+              <a:p>
+                <a:pPr>
+                  <a:defRPr sz="1000">
+                    <a:solidFill>
+                      <a:srgbClr val="FFC666"/>
+                    </a:solidFill>
+                    <a:latin typeface="Source Sans Pro"/>
+                  </a:defRPr>
+                </a:pPr>
+              </a:p>
+            </c:txPr>
+            <c:dLblPos val="t"/>
+            <c:showLegendKey val="0"/>
+            <c:showVal val="1"/>
+            <c:showCatName val="0"/>
+            <c:showSerName val="0"/>
+            <c:showPercent val="0"/>
+            <c:showBubbleSize val="0"/>
+            <c:showLeaderLines val="1"/>
+          </c:dLbls>
+          <c:cat>
+            <c:strRef>
+              <c:f>Sheet1!$A$2:$A$18</c:f>
+              <c:strCache>
+                <c:ptCount val="17"/>
+                <c:pt idx="0">
+                  <c:v>Q2 22</c:v>
+                </c:pt>
+                <c:pt idx="1">
+                  <c:v>Q3 22</c:v>
+                </c:pt>
+                <c:pt idx="2">
+                  <c:v>Q4 22</c:v>
+                </c:pt>
+                <c:pt idx="3">
+                  <c:v>Q1 23</c:v>
+                </c:pt>
+                <c:pt idx="4">
+                  <c:v>Q2 23</c:v>
+                </c:pt>
+                <c:pt idx="5">
+                  <c:v>Q3 23</c:v>
+                </c:pt>
+                <c:pt idx="6">
+                  <c:v>Q4 23</c:v>
+                </c:pt>
+                <c:pt idx="7">
+                  <c:v>Q1 24</c:v>
+                </c:pt>
+                <c:pt idx="8">
+                  <c:v>Q2 24</c:v>
+                </c:pt>
+                <c:pt idx="9">
+                  <c:v>Q3 24</c:v>
+                </c:pt>
+                <c:pt idx="10">
+                  <c:v>Q4 24</c:v>
+                </c:pt>
+                <c:pt idx="11">
+                  <c:v>Q1 25</c:v>
+                </c:pt>
+                <c:pt idx="12">
+                  <c:v>Q2 25</c:v>
+                </c:pt>
+                <c:pt idx="13">
+                  <c:v>Q3 25</c:v>
+                </c:pt>
+                <c:pt idx="14">
+                  <c:v>Q4 25</c:v>
+                </c:pt>
+                <c:pt idx="15">
+                  <c:v>Q1 26</c:v>
+                </c:pt>
+                <c:pt idx="16">
+                  <c:v>Q2 26</c:v>
+                </c:pt>
+              </c:strCache>
+            </c:strRef>
+          </c:cat>
+          <c:val>
+            <c:numRef>
+              <c:f>Sheet1!$B$2:$B$18</c:f>
+              <c:numCache>
+                <c:formatCode>General</c:formatCode>
+                <c:ptCount val="17"/>
+                <c:pt idx="0">
+                  <c:v>7.1</c:v>
+                </c:pt>
+                <c:pt idx="1">
+                  <c:v>8.1</c:v>
+                </c:pt>
+                <c:pt idx="2">
+                  <c:v>8.0</c:v>
+                </c:pt>
+                <c:pt idx="3">
+                  <c:v>8.8</c:v>
+                </c:pt>
+                <c:pt idx="4">
+                  <c:v>8.9</c:v>
+                </c:pt>
+                <c:pt idx="5">
+                  <c:v>8.1</c:v>
+                </c:pt>
+                <c:pt idx="6">
+                  <c:v>7.0</c:v>
+                </c:pt>
+                <c:pt idx="7">
+                  <c:v>7.7</c:v>
+                </c:pt>
+                <c:pt idx="8">
+                  <c:v>5.2</c:v>
+                </c:pt>
+                <c:pt idx="9">
+                  <c:v>5.1</c:v>
+                </c:pt>
+                <c:pt idx="10">
+                  <c:v>5.4</c:v>
+                </c:pt>
+                <c:pt idx="11">
+                  <c:v>4.2</c:v>
+                </c:pt>
+                <c:pt idx="12">
+                  <c:v>3.7</c:v>
+                </c:pt>
+                <c:pt idx="13">
+                  <c:v>1.6</c:v>
+                </c:pt>
+                <c:pt idx="14">
+                  <c:v>0.2</c:v>
+                </c:pt>
+                <c:pt idx="15">
+                  <c:v>-1.2</c:v>
+                </c:pt>
+                <c:pt idx="16">
+                  <c:v>-2.0</c:v>
+                </c:pt>
+              </c:numCache>
+            </c:numRef>
+          </c:val>
+          <c:smooth val="0"/>
+        </c:ser>
+        <c:ser>
+          <c:idx val="1"/>
+          <c:order val="1"/>
+          <c:tx>
+            <c:strRef>
+              <c:f>Sheet1!$C$1</c:f>
+              <c:strCache>
+                <c:ptCount val="1"/>
+                <c:pt idx="0">
+                  <c:v>Marsh US composite insurance rate changes</c:v>
+                </c:pt>
+              </c:strCache>
+            </c:strRef>
+          </c:tx>
+          <c:spPr>
+            <a:ln w="28575">
+              <a:solidFill>
+                <a:srgbClr val="BFC7CB"/>
+              </a:solidFill>
+            </a:ln>
+          </c:spPr>
+          <c:marker>
+            <c:symbol val="circle"/>
+            <c:size val="6"/>
+            <c:spPr>
+              <a:solidFill>
+                <a:srgbClr val="BFC7CB"/>
+              </a:solidFill>
+              <a:ln>
+                <a:solidFill>
+                  <a:srgbClr val="BFC7CB"/>
+                </a:solidFill>
+              </a:ln>
+            </c:spPr>
+          </c:marker>
+          <c:dLbls>
+            <c:dLbl>
+              <c:idx val="0"/>
+              <c:spPr/>
+              <c:txPr>
+                <a:bodyPr/>
+                <a:lstStyle/>
+                <a:p>
+                  <a:pPr>
+                    <a:defRPr sz="1000" b="0">
+                      <a:solidFill>
+                        <a:srgbClr val="BFC7CB"/>
+                      </a:solidFill>
+                      <a:latin typeface="Source Sans Pro"/>
+                    </a:defRPr>
+                  </a:pPr>
+                </a:p>
+              </c:txPr>
+              <c:dLblPos val="r"/>
+              <c:showLegendKey val="0"/>
+              <c:showVal val="1"/>
+              <c:showCatName val="0"/>
+              <c:showSerName val="0"/>
+              <c:showPercent val="0"/>
+              <c:showBubbleSize val="0"/>
+            </c:dLbl>
+            <c:dLbl>
+              <c:idx val="1"/>
+              <c:spPr/>
+              <c:txPr>
+                <a:bodyPr/>
+                <a:lstStyle/>
+                <a:p>
+                  <a:pPr>
+                    <a:defRPr sz="1000" b="0">
+                      <a:solidFill>
+                        <a:srgbClr val="BFC7CB"/>
+                      </a:solidFill>
+                      <a:latin typeface="Source Sans Pro"/>
+                    </a:defRPr>
+                  </a:pPr>
+                </a:p>
+              </c:txPr>
+              <c:dLblPos val="b"/>
+              <c:showLegendKey val="0"/>
+              <c:showVal val="1"/>
+              <c:showCatName val="0"/>
+              <c:showSerName val="0"/>
+              <c:showPercent val="0"/>
+              <c:showBubbleSize val="0"/>
+            </c:dLbl>
+            <c:dLbl>
+              <c:idx val="2"/>
+              <c:spPr/>
+              <c:txPr>
+                <a:bodyPr/>
+                <a:lstStyle/>
+                <a:p>
+                  <a:pPr>
+                    <a:defRPr sz="1000" b="0">
+                      <a:solidFill>
+                        <a:srgbClr val="BFC7CB"/>
+                      </a:solidFill>
+                      <a:latin typeface="Source Sans Pro"/>
+                    </a:defRPr>
+                  </a:pPr>
+                </a:p>
+              </c:txPr>
+              <c:dLblPos val="b"/>
+              <c:showLegendKey val="0"/>
+              <c:showVal val="1"/>
+              <c:showCatName val="0"/>
+              <c:showSerName val="0"/>
+              <c:showPercent val="0"/>
+              <c:showBubbleSize val="0"/>
+            </c:dLbl>
+            <c:dLbl>
+              <c:idx val="3"/>
+              <c:spPr/>
+              <c:txPr>
+                <a:bodyPr/>
+                <a:lstStyle/>
+                <a:p>
+                  <a:pPr>
+                    <a:defRPr sz="1000" b="0">
+                      <a:solidFill>
+                        <a:srgbClr val="BFC7CB"/>
+                      </a:solidFill>
+                      <a:latin typeface="Source Sans Pro"/>
+                    </a:defRPr>
+                  </a:pPr>
+                </a:p>
+              </c:txPr>
+              <c:dLblPos val="b"/>
+              <c:showLegendKey val="0"/>
+              <c:showVal val="1"/>
+              <c:showCatName val="0"/>
+              <c:showSerName val="0"/>
+              <c:showPercent val="0"/>
+              <c:showBubbleSize val="0"/>
+            </c:dLbl>
+            <c:dLbl>
+              <c:idx val="4"/>
+              <c:spPr/>
+              <c:txPr>
+                <a:bodyPr/>
+                <a:lstStyle/>
+                <a:p>
+                  <a:pPr>
+                    <a:defRPr sz="1000" b="0">
+                      <a:solidFill>
+                        <a:srgbClr val="BFC7CB"/>
+                      </a:solidFill>
+                      <a:latin typeface="Source Sans Pro"/>
+                    </a:defRPr>
+                  </a:pPr>
+                </a:p>
+              </c:txPr>
+              <c:dLblPos val="b"/>
+              <c:showLegendKey val="0"/>
+              <c:showVal val="1"/>
+              <c:showCatName val="0"/>
+              <c:showSerName val="0"/>
+              <c:showPercent val="0"/>
+              <c:showBubbleSize val="0"/>
+            </c:dLbl>
+            <c:dLbl>
+              <c:idx val="5"/>
+              <c:spPr/>
+              <c:txPr>
+                <a:bodyPr/>
+                <a:lstStyle/>
+                <a:p>
+                  <a:pPr>
+                    <a:defRPr sz="1000" b="0">
+                      <a:solidFill>
+                        <a:srgbClr val="BFC7CB"/>
+                      </a:solidFill>
+                      <a:latin typeface="Source Sans Pro"/>
+                    </a:defRPr>
+                  </a:pPr>
+                </a:p>
+              </c:txPr>
+              <c:dLblPos val="b"/>
+              <c:showLegendKey val="0"/>
+              <c:showVal val="1"/>
+              <c:showCatName val="0"/>
+              <c:showSerName val="0"/>
+              <c:showPercent val="0"/>
+              <c:showBubbleSize val="0"/>
+            </c:dLbl>
+            <c:dLbl>
+              <c:idx val="6"/>
+              <c:spPr/>
+              <c:txPr>
+                <a:bodyPr/>
+                <a:lstStyle/>
+                <a:p>
+                  <a:pPr>
+                    <a:defRPr sz="1000" b="0">
+                      <a:solidFill>
+                        <a:srgbClr val="BFC7CB"/>
+                      </a:solidFill>
+                      <a:latin typeface="Source Sans Pro"/>
+                    </a:defRPr>
+                  </a:pPr>
+                </a:p>
+              </c:txPr>
+              <c:dLblPos val="b"/>
+              <c:showLegendKey val="0"/>
+              <c:showVal val="1"/>
+              <c:showCatName val="0"/>
+              <c:showSerName val="0"/>
+              <c:showPercent val="0"/>
+              <c:showBubbleSize val="0"/>
+            </c:dLbl>
+            <c:dLbl>
+              <c:idx val="7"/>
+              <c:spPr/>
+              <c:txPr>
+                <a:bodyPr/>
+                <a:lstStyle/>
+                <a:p>
+                  <a:pPr>
+                    <a:defRPr sz="1000" b="0">
+                      <a:solidFill>
+                        <a:srgbClr val="BFC7CB"/>
+                      </a:solidFill>
+                      <a:latin typeface="Source Sans Pro"/>
+                    </a:defRPr>
+                  </a:pPr>
+                </a:p>
+              </c:txPr>
+              <c:dLblPos val="b"/>
+              <c:showLegendKey val="0"/>
+              <c:showVal val="1"/>
+              <c:showCatName val="0"/>
+              <c:showSerName val="0"/>
+              <c:showPercent val="0"/>
+              <c:showBubbleSize val="0"/>
+            </c:dLbl>
+            <c:dLbl>
+              <c:idx val="8"/>
+              <c:spPr/>
+              <c:txPr>
+                <a:bodyPr/>
+                <a:lstStyle/>
+                <a:p>
+                  <a:pPr>
+                    <a:defRPr sz="1000" b="0">
+                      <a:solidFill>
+                        <a:srgbClr val="BFC7CB"/>
+                      </a:solidFill>
+                      <a:latin typeface="Source Sans Pro"/>
+                    </a:defRPr>
+                  </a:pPr>
+                </a:p>
+              </c:txPr>
+              <c:dLblPos val="b"/>
+              <c:showLegendKey val="0"/>
+              <c:showVal val="1"/>
+              <c:showCatName val="0"/>
+              <c:showSerName val="0"/>
+              <c:showPercent val="0"/>
+              <c:showBubbleSize val="0"/>
+            </c:dLbl>
+            <c:dLbl>
+              <c:idx val="9"/>
+              <c:spPr/>
+              <c:txPr>
+                <a:bodyPr/>
+                <a:lstStyle/>
+                <a:p>
+                  <a:pPr>
+                    <a:defRPr sz="1000" b="0">
+                      <a:solidFill>
+                        <a:srgbClr val="BFC7CB"/>
+                      </a:solidFill>
+                      <a:latin typeface="Source Sans Pro"/>
+                    </a:defRPr>
+                  </a:pPr>
+                </a:p>
+              </c:txPr>
+              <c:dLblPos val="t"/>
+              <c:showLegendKey val="0"/>
+              <c:showVal val="1"/>
+              <c:showCatName val="0"/>
+              <c:showSerName val="0"/>
+              <c:showPercent val="0"/>
+              <c:showBubbleSize val="0"/>
+            </c:dLbl>
+            <c:dLbl>
+              <c:idx val="10"/>
+              <c:spPr/>
+              <c:txPr>
+                <a:bodyPr/>
+                <a:lstStyle/>
+                <a:p>
+                  <a:pPr>
+                    <a:defRPr sz="1000" b="0">
+                      <a:solidFill>
+                        <a:srgbClr val="BFC7CB"/>
+                      </a:solidFill>
+                      <a:latin typeface="Source Sans Pro"/>
+                    </a:defRPr>
+                  </a:pPr>
+                </a:p>
+              </c:txPr>
+              <c:dLblPos val="b"/>
+              <c:showLegendKey val="0"/>
+              <c:showVal val="1"/>
+              <c:showCatName val="0"/>
+              <c:showSerName val="0"/>
+              <c:showPercent val="0"/>
+              <c:showBubbleSize val="0"/>
+            </c:dLbl>
+            <c:dLbl>
+              <c:idx val="11"/>
+              <c:spPr/>
+              <c:txPr>
+                <a:bodyPr/>
+                <a:lstStyle/>
+                <a:p>
+                  <a:pPr>
+                    <a:defRPr sz="1000" b="0">
+                      <a:solidFill>
+                        <a:srgbClr val="BFC7CB"/>
+                      </a:solidFill>
+                      <a:latin typeface="Source Sans Pro"/>
+                    </a:defRPr>
+                  </a:pPr>
+                </a:p>
+              </c:txPr>
+              <c:dLblPos val="b"/>
+              <c:showLegendKey val="0"/>
+              <c:showVal val="1"/>
+              <c:showCatName val="0"/>
+              <c:showSerName val="0"/>
+              <c:showPercent val="0"/>
+              <c:showBubbleSize val="0"/>
+            </c:dLbl>
+            <c:dLbl>
+              <c:idx val="12"/>
+              <c:spPr/>
+              <c:txPr>
+                <a:bodyPr/>
+                <a:lstStyle/>
+                <a:p>
+                  <a:pPr>
+                    <a:defRPr sz="1000" b="0">
+                      <a:solidFill>
+                        <a:srgbClr val="BFC7CB"/>
+                      </a:solidFill>
+                      <a:latin typeface="Source Sans Pro"/>
+                    </a:defRPr>
+                  </a:pPr>
+                </a:p>
+              </c:txPr>
+              <c:dLblPos val="b"/>
+              <c:showLegendKey val="0"/>
+              <c:showVal val="1"/>
+              <c:showCatName val="0"/>
+              <c:showSerName val="0"/>
+              <c:showPercent val="0"/>
+              <c:showBubbleSize val="0"/>
+            </c:dLbl>
+            <c:dLbl>
+              <c:idx val="13"/>
+              <c:spPr/>
+              <c:txPr>
+                <a:bodyPr/>
+                <a:lstStyle/>
+                <a:p>
+                  <a:pPr>
+                    <a:defRPr sz="1000" b="0">
+                      <a:solidFill>
+                        <a:srgbClr val="BFC7CB"/>
+                      </a:solidFill>
+                      <a:latin typeface="Source Sans Pro"/>
+                    </a:defRPr>
+                  </a:pPr>
+                </a:p>
+              </c:txPr>
+              <c:dLblPos val="b"/>
+              <c:showLegendKey val="0"/>
+              <c:showVal val="1"/>
+              <c:showCatName val="0"/>
+              <c:showSerName val="0"/>
+              <c:showPercent val="0"/>
+              <c:showBubbleSize val="0"/>
+            </c:dLbl>
+            <c:dLbl>
+              <c:idx val="14"/>
+              <c:spPr/>
+              <c:txPr>
+                <a:bodyPr/>
+                <a:lstStyle/>
+                <a:p>
+                  <a:pPr>
+                    <a:defRPr sz="1000" b="0">
+                      <a:solidFill>
+                        <a:srgbClr val="BFC7CB"/>
+                      </a:solidFill>
+                      <a:latin typeface="Source Sans Pro"/>
+                    </a:defRPr>
+                  </a:pPr>
+                </a:p>
+              </c:txPr>
+              <c:dLblPos val="b"/>
+              <c:showLegendKey val="0"/>
+              <c:showVal val="1"/>
+              <c:showCatName val="0"/>
+              <c:showSerName val="0"/>
+              <c:showPercent val="0"/>
+              <c:showBubbleSize val="0"/>
+            </c:dLbl>
+            <c:dLbl>
+              <c:idx val="15"/>
+              <c:spPr/>
+              <c:txPr>
+                <a:bodyPr/>
+                <a:lstStyle/>
+                <a:p>
+                  <a:pPr>
+                    <a:defRPr sz="1000" b="0">
+                      <a:solidFill>
+                        <a:srgbClr val="BFC7CB"/>
+                      </a:solidFill>
+                      <a:latin typeface="Source Sans Pro"/>
+                    </a:defRPr>
+                  </a:pPr>
+                </a:p>
+              </c:txPr>
+              <c:dLblPos val="b"/>
+              <c:showLegendKey val="0"/>
+              <c:showVal val="1"/>
+              <c:showCatName val="0"/>
+              <c:showSerName val="0"/>
+              <c:showPercent val="0"/>
+              <c:showBubbleSize val="0"/>
+            </c:dLbl>
+            <c:dLbl>
+              <c:idx val="16"/>
+              <c:spPr/>
+              <c:txPr>
+                <a:bodyPr/>
+                <a:lstStyle/>
+                <a:p>
+                  <a:pPr>
+                    <a:defRPr sz="1000" b="0">
+                      <a:solidFill>
+                        <a:srgbClr val="BFC7CB"/>
+                      </a:solidFill>
+                      <a:latin typeface="Source Sans Pro"/>
+                    </a:defRPr>
+                  </a:pPr>
+                </a:p>
+              </c:txPr>
+              <c:dLblPos val="b"/>
+              <c:showLegendKey val="0"/>
+              <c:showVal val="1"/>
+              <c:showCatName val="0"/>
+              <c:showSerName val="0"/>
+              <c:showPercent val="0"/>
+              <c:showBubbleSize val="0"/>
+            </c:dLbl>
+            <c:numFmt formatCode="0.0&quot;%&quot;;(0.0&quot;%&quot;);&quot;-&quot;" sourceLinked="0"/>
+            <c:txPr>
+              <a:bodyPr/>
+              <a:lstStyle/>
+              <a:p>
+                <a:pPr>
+                  <a:defRPr sz="1000">
+                    <a:solidFill>
+                      <a:srgbClr val="BFC7CB"/>
+                    </a:solidFill>
+                    <a:latin typeface="Source Sans Pro"/>
+                  </a:defRPr>
+                </a:pPr>
+              </a:p>
+            </c:txPr>
+            <c:dLblPos val="b"/>
+            <c:showLegendKey val="0"/>
+            <c:showVal val="1"/>
+            <c:showCatName val="0"/>
+            <c:showSerName val="0"/>
+            <c:showPercent val="0"/>
+            <c:showBubbleSize val="0"/>
+            <c:showLeaderLines val="1"/>
+          </c:dLbls>
+          <c:cat>
+            <c:strRef>
+              <c:f>Sheet1!$A$2:$A$18</c:f>
+              <c:strCache>
+                <c:ptCount val="17"/>
+                <c:pt idx="0">
+                  <c:v>Q2 22</c:v>
+                </c:pt>
+                <c:pt idx="1">
+                  <c:v>Q3 22</c:v>
+                </c:pt>
+                <c:pt idx="2">
+                  <c:v>Q4 22</c:v>
+                </c:pt>
+                <c:pt idx="3">
+                  <c:v>Q1 23</c:v>
+                </c:pt>
+                <c:pt idx="4">
+                  <c:v>Q2 23</c:v>
+                </c:pt>
+                <c:pt idx="5">
+                  <c:v>Q3 23</c:v>
+                </c:pt>
+                <c:pt idx="6">
+                  <c:v>Q4 23</c:v>
+                </c:pt>
+                <c:pt idx="7">
+                  <c:v>Q1 24</c:v>
+                </c:pt>
+                <c:pt idx="8">
+                  <c:v>Q2 24</c:v>
+                </c:pt>
+                <c:pt idx="9">
+                  <c:v>Q3 24</c:v>
+                </c:pt>
+                <c:pt idx="10">
+                  <c:v>Q4 24</c:v>
+                </c:pt>
+                <c:pt idx="11">
+                  <c:v>Q1 25</c:v>
+                </c:pt>
+                <c:pt idx="12">
+                  <c:v>Q2 25</c:v>
+                </c:pt>
+                <c:pt idx="13">
+                  <c:v>Q3 25</c:v>
+                </c:pt>
+                <c:pt idx="14">
+                  <c:v>Q4 25</c:v>
+                </c:pt>
+                <c:pt idx="15">
+                  <c:v>Q1 26</c:v>
+                </c:pt>
+                <c:pt idx="16">
+                  <c:v>Q2 26</c:v>
+                </c:pt>
+              </c:strCache>
+            </c:strRef>
+          </c:cat>
+          <c:val>
+            <c:numRef>
+              <c:f>Sheet1!$C$2:$C$18</c:f>
+              <c:numCache>
+                <c:formatCode>General</c:formatCode>
+                <c:ptCount val="17"/>
+                <c:pt idx="0">
+                  <c:v>10.0</c:v>
+                </c:pt>
+                <c:pt idx="1">
+                  <c:v>5.0</c:v>
+                </c:pt>
+                <c:pt idx="2">
+                  <c:v>3.0</c:v>
+                </c:pt>
+                <c:pt idx="3">
+                  <c:v>4.0</c:v>
+                </c:pt>
+                <c:pt idx="4">
+                  <c:v>4.0</c:v>
+                </c:pt>
+                <c:pt idx="5">
+                  <c:v>4.0</c:v>
+                </c:pt>
+                <c:pt idx="6">
+                  <c:v>3.0</c:v>
+                </c:pt>
+                <c:pt idx="7">
+                  <c:v>3.0</c:v>
+                </c:pt>
+                <c:pt idx="8">
+                  <c:v>1.0</c:v>
+                </c:pt>
+                <c:pt idx="9">
+                  <c:v>3.0</c:v>
+                </c:pt>
+                <c:pt idx="10">
+                  <c:v>0.0</c:v>
+                </c:pt>
+                <c:pt idx="11">
+                  <c:v>-1.0</c:v>
+                </c:pt>
+                <c:pt idx="12">
+                  <c:v>0.0</c:v>
+                </c:pt>
+                <c:pt idx="13">
+                  <c:v>-1.0</c:v>
+                </c:pt>
+                <c:pt idx="14">
+                  <c:v>0.0</c:v>
+                </c:pt>
+                <c:pt idx="15">
+                  <c:v>-1.0</c:v>
+                </c:pt>
+                <c:pt idx="16">
+                  <c:v>-2.0</c:v>
+                </c:pt>
+              </c:numCache>
+            </c:numRef>
+          </c:val>
+          <c:smooth val="0"/>
+        </c:ser>
+        <c:marker val="1"/>
+        <c:smooth val="0"/>
+        <c:axId val="2118791784"/>
+        <c:axId val="2140495176"/>
+      </c:lineChart>
+      <c:catAx>
+        <c:axId val="2118791784"/>
+        <c:scaling>
+          <c:orientation val="minMax"/>
+        </c:scaling>
+        <c:delete val="0"/>
+        <c:axPos val="b"/>
+        <c:majorTickMark val="none"/>
+        <c:minorTickMark val="none"/>
+        <c:tickLblPos val="low"/>
+        <c:spPr>
+          <a:ln>
+            <a:solidFill>
+              <a:srgbClr val="BFC7CB"/>
+            </a:solidFill>
+          </a:ln>
+        </c:spPr>
+        <c:txPr>
+          <a:bodyPr/>
+          <a:lstStyle/>
+          <a:p>
+            <a:pPr>
+              <a:defRPr sz="1100">
+                <a:solidFill>
+                  <a:srgbClr val="FFFFFF"/>
+                </a:solidFill>
+              </a:defRPr>
+            </a:pPr>
+          </a:p>
+        </c:txPr>
+        <c:crossAx val="2140495176"/>
+        <c:crosses val="autoZero"/>
+        <c:auto val="1"/>
+        <c:lblAlgn val="ctr"/>
+        <c:lblOffset val="100"/>
+        <c:noMultiLvlLbl val="0"/>
+      </c:catAx>
+      <c:valAx>
+        <c:axId val="2140495176"/>
+        <c:scaling>
+          <c:max val="12.0"/>
+          <c:min val="-4.0"/>
+        </c:scaling>
+        <c:delete val="0"/>
+        <c:axPos val="l"/>
+        <c:majorGridlines>
+          <c:spPr>
+            <a:ln>
+              <a:solidFill>
+                <a:srgbClr val="2B4A5C"/>
+              </a:solidFill>
+            </a:ln>
+          </c:spPr>
+        </c:majorGridlines>
+        <c:numFmt formatCode="0&quot;%&quot;" sourceLinked="0"/>
+        <c:majorTickMark val="out"/>
+        <c:minorTickMark val="none"/>
+        <c:tickLblPos val="nextTo"/>
+        <c:spPr>
+          <a:ln>
+            <a:noFill/>
+          </a:ln>
+        </c:spPr>
+        <c:txPr>
+          <a:bodyPr/>
+          <a:lstStyle/>
+          <a:p>
+            <a:pPr>
+              <a:defRPr sz="1100">
+                <a:solidFill>
+                  <a:srgbClr val="BFC7CB"/>
+                </a:solidFill>
+              </a:defRPr>
+            </a:pPr>
+          </a:p>
+        </c:txPr>
+        <c:crossAx val="2118791784"/>
+        <c:crosses val="autoZero"/>
+        <c:majorUnit val="4.0"/>
+      </c:valAx>
+    </c:plotArea>
+    <c:legend>
+      <c:legendPos val="t"/>
+      <c:layout/>
+      <c:overlay val="0"/>
+      <c:txPr>
+        <a:bodyPr/>
+        <a:lstStyle/>
+        <a:p>
+          <a:pPr>
+            <a:defRPr sz="1200">
+              <a:solidFill>
+                <a:srgbClr val="FFFFFF"/>
+              </a:solidFill>
+            </a:defRPr>
+          </a:pPr>
+        </a:p>
+      </c:txPr>
+    </c:legend>
+    <c:plotVisOnly val="1"/>
+    <c:dispBlanksAs val="gap"/>
+    <c:showDLblsOverMax val="0"/>
+  </c:chart>
+  <c:txPr>
+    <a:bodyPr/>
+    <a:lstStyle/>
+    <a:p>
+      <a:pPr>
+        <a:defRPr sz="1100">
+          <a:solidFill>
+            <a:srgbClr val="FFFFFF"/>
+          </a:solidFill>
+          <a:latin typeface="Source Sans Pro"/>
+        </a:defRPr>
+      </a:pPr>
+      <a:endParaRPr lang="en-US"/>
+    </a:p>
+  </c:txPr>
+  <c:externalData r:id="rId1">
+    <c:autoUpdate val="0"/>
+  </c:externalData>
+</c:chartSpace>
+</file>
+
+<file path=ppt/charts/chart3.xml><?xml version="1.0" encoding="utf-8"?>
+<c:chartSpace xmlns:c="http://schemas.openxmlformats.org/drawingml/2006/chart" xmlns:a="http://schemas.openxmlformats.org/drawingml/2006/main" xmlns:r="http://schemas.openxmlformats.org/officeDocument/2006/relationships">
+  <c:date1904 val="0"/>
+  <c:chart>
+    <c:autoTitleDeleted val="1"/>
+    <c:plotArea>
+      <c:lineChart>
+        <c:grouping val="standard"/>
+        <c:varyColors val="0"/>
+        <c:ser>
+          <c:idx val="0"/>
+          <c:order val="0"/>
+          <c:tx>
+            <c:strRef>
+              <c:f>Sheet1!$B$1</c:f>
+              <c:strCache>
+                <c:ptCount val="1"/>
+                <c:pt idx="0">
+                  <c:v>Commercial lines</c:v>
+                </c:pt>
+              </c:strCache>
+            </c:strRef>
+          </c:tx>
+          <c:spPr>
+            <a:ln w="25400">
+              <a:solidFill>
+                <a:srgbClr val="FFC666"/>
+              </a:solidFill>
+            </a:ln>
+          </c:spPr>
+          <c:marker>
+            <c:symbol val="circle"/>
+            <c:size val="6"/>
+            <c:spPr>
+              <a:solidFill>
+                <a:srgbClr val="FFC666"/>
+              </a:solidFill>
+              <a:ln>
+                <a:solidFill>
+                  <a:srgbClr val="FFC666"/>
+                </a:solidFill>
+              </a:ln>
+            </c:spPr>
+          </c:marker>
+          <c:dLbls>
+            <c:dLbl>
+              <c:idx val="18"/>
+              <c:tx>
+                <c:rich>
+                  <a:bodyPr/>
+                  <a:lstStyle/>
+                  <a:p>
+                    <a:r>
+                      <a:rPr sz="1300" b="1">
+                        <a:solidFill>
+                          <a:srgbClr val="FFC666"/>
+                        </a:solidFill>
+                        <a:latin typeface="Source Sans Pro"/>
+                      </a:rPr>
+                      <a:t>4.5%</a:t>
+                    </a:r>
+                  </a:p>
+                </c:rich>
+              </c:tx>
+              <c:dLblPos val="b"/>
+              <c:showLegendKey val="0"/>
+              <c:showVal val="1"/>
+              <c:showCatName val="0"/>
+              <c:showSerName val="0"/>
+              <c:showPercent val="0"/>
+              <c:showBubbleSize val="0"/>
+            </c:dLbl>
+            <c:showLegendKey val="0"/>
+            <c:showVal val="0"/>
+            <c:showCatName val="0"/>
+            <c:showSerName val="0"/>
+            <c:showPercent val="0"/>
+            <c:showBubbleSize val="0"/>
+            <c:showLeaderLines val="1"/>
+          </c:dLbls>
+          <c:cat>
+            <c:strRef>
+              <c:f>Sheet1!$A$2:$A$20</c:f>
+              <c:strCache>
+                <c:ptCount val="19"/>
+                <c:pt idx="0">
+                  <c:v>2008</c:v>
+                </c:pt>
+                <c:pt idx="1">
+                  <c:v>2009</c:v>
+                </c:pt>
+                <c:pt idx="2">
+                  <c:v>2010</c:v>
+                </c:pt>
+                <c:pt idx="3">
+                  <c:v>2011</c:v>
+                </c:pt>
+                <c:pt idx="4">
+                  <c:v>2012</c:v>
+                </c:pt>
+                <c:pt idx="5">
+                  <c:v>2013</c:v>
+                </c:pt>
+                <c:pt idx="6">
+                  <c:v>2014</c:v>
+                </c:pt>
+                <c:pt idx="7">
+                  <c:v>2015</c:v>
+                </c:pt>
+                <c:pt idx="8">
+                  <c:v>2016</c:v>
+                </c:pt>
+                <c:pt idx="9">
+                  <c:v>2017</c:v>
+                </c:pt>
+                <c:pt idx="10">
+                  <c:v>2018</c:v>
+                </c:pt>
+                <c:pt idx="11">
+                  <c:v>2019</c:v>
+                </c:pt>
+                <c:pt idx="12">
+                  <c:v>2020</c:v>
+                </c:pt>
+                <c:pt idx="13">
+                  <c:v>2021</c:v>
+                </c:pt>
+                <c:pt idx="14">
+                  <c:v>2022</c:v>
+                </c:pt>
+                <c:pt idx="15">
+                  <c:v>2023</c:v>
+                </c:pt>
+                <c:pt idx="16">
+                  <c:v>2024</c:v>
+                </c:pt>
+                <c:pt idx="17">
+                  <c:v>2025</c:v>
+                </c:pt>
+                <c:pt idx="18">
+                  <c:v>Q2 2026</c:v>
+                </c:pt>
+              </c:strCache>
+            </c:strRef>
+          </c:cat>
+          <c:val>
+            <c:numRef>
+              <c:f>Sheet1!$B$2:$B$20</c:f>
+              <c:numCache>
+                <c:formatCode>General</c:formatCode>
+                <c:ptCount val="19"/>
+                <c:pt idx="0">
+                  <c:v>-1.3</c:v>
+                </c:pt>
+                <c:pt idx="1">
+                  <c:v>-3.3</c:v>
+                </c:pt>
+                <c:pt idx="2">
+                  <c:v>0.0</c:v>
+                </c:pt>
+                <c:pt idx="3">
+                  <c:v>3.3</c:v>
+                </c:pt>
+                <c:pt idx="4">
+                  <c:v>7.6</c:v>
+                </c:pt>
+                <c:pt idx="5">
+                  <c:v>8.2</c:v>
+                </c:pt>
+                <c:pt idx="6">
+                  <c:v>7.0</c:v>
+                </c:pt>
+                <c:pt idx="7">
+                  <c:v>5.3</c:v>
+                </c:pt>
+                <c:pt idx="8">
+                  <c:v>3.3</c:v>
+                </c:pt>
+                <c:pt idx="9">
+                  <c:v>4.1</c:v>
+                </c:pt>
+                <c:pt idx="10">
+                  <c:v>6.5</c:v>
+                </c:pt>
+                <c:pt idx="11">
+                  <c:v>7.2</c:v>
+                </c:pt>
+                <c:pt idx="12">
+                  <c:v>4.9</c:v>
+                </c:pt>
+                <c:pt idx="13">
+                  <c:v>11.4</c:v>
+                </c:pt>
+                <c:pt idx="14">
+                  <c:v>12.6</c:v>
+                </c:pt>
+                <c:pt idx="15">
+                  <c:v>10.9</c:v>
+                </c:pt>
+                <c:pt idx="16">
+                  <c:v>8.2</c:v>
+                </c:pt>
+                <c:pt idx="17">
+                  <c:v>6.2</c:v>
+                </c:pt>
+                <c:pt idx="18">
+                  <c:v>4.5</c:v>
+                </c:pt>
+              </c:numCache>
+            </c:numRef>
+          </c:val>
+          <c:smooth val="0"/>
+        </c:ser>
+        <c:ser>
+          <c:idx val="1"/>
+          <c:order val="1"/>
+          <c:tx>
+            <c:strRef>
+              <c:f>Sheet1!$C$1</c:f>
+              <c:strCache>
+                <c:ptCount val="1"/>
+                <c:pt idx="0">
+                  <c:v>Personal lines</c:v>
+                </c:pt>
+              </c:strCache>
+            </c:strRef>
+          </c:tx>
+          <c:spPr>
+            <a:ln w="25400">
+              <a:solidFill>
+                <a:srgbClr val="BFC7CB"/>
+              </a:solidFill>
+            </a:ln>
+          </c:spPr>
+          <c:marker>
+            <c:symbol val="circle"/>
+            <c:size val="6"/>
+            <c:spPr>
+              <a:solidFill>
+                <a:srgbClr val="BFC7CB"/>
+              </a:solidFill>
+              <a:ln>
+                <a:solidFill>
+                  <a:srgbClr val="BFC7CB"/>
+                </a:solidFill>
+              </a:ln>
+            </c:spPr>
+          </c:marker>
+          <c:dLbls>
+            <c:dLbl>
+              <c:idx val="18"/>
+              <c:tx>
+                <c:rich>
+                  <a:bodyPr/>
+                  <a:lstStyle/>
+                  <a:p>
+                    <a:r>
+                      <a:rPr sz="1300" b="1">
+                        <a:solidFill>
+                          <a:srgbClr val="BFC7CB"/>
+                        </a:solidFill>
+                        <a:latin typeface="Source Sans Pro"/>
+                      </a:rPr>
+                      <a:t>1.2%</a:t>
+                    </a:r>
+                  </a:p>
+                </c:rich>
+              </c:tx>
+              <c:dLblPos val="b"/>
+              <c:showLegendKey val="0"/>
+              <c:showVal val="1"/>
+              <c:showCatName val="0"/>
+              <c:showSerName val="0"/>
+              <c:showPercent val="0"/>
+              <c:showBubbleSize val="0"/>
+            </c:dLbl>
+            <c:showLegendKey val="0"/>
+            <c:showVal val="0"/>
+            <c:showCatName val="0"/>
+            <c:showSerName val="0"/>
+            <c:showPercent val="0"/>
+            <c:showBubbleSize val="0"/>
+            <c:showLeaderLines val="1"/>
+          </c:dLbls>
+          <c:cat>
+            <c:strRef>
+              <c:f>Sheet1!$A$2:$A$20</c:f>
+              <c:strCache>
+                <c:ptCount val="19"/>
+                <c:pt idx="0">
+                  <c:v>2008</c:v>
+                </c:pt>
+                <c:pt idx="1">
+                  <c:v>2009</c:v>
+                </c:pt>
+                <c:pt idx="2">
+                  <c:v>2010</c:v>
+                </c:pt>
+                <c:pt idx="3">
+                  <c:v>2011</c:v>
+                </c:pt>
+                <c:pt idx="4">
+                  <c:v>2012</c:v>
+                </c:pt>
+                <c:pt idx="5">
+                  <c:v>2013</c:v>
+                </c:pt>
+                <c:pt idx="6">
+                  <c:v>2014</c:v>
+                </c:pt>
+                <c:pt idx="7">
+                  <c:v>2015</c:v>
+                </c:pt>
+                <c:pt idx="8">
+                  <c:v>2016</c:v>
+                </c:pt>
+                <c:pt idx="9">
+                  <c:v>2017</c:v>
+                </c:pt>
+                <c:pt idx="10">
+                  <c:v>2018</c:v>
+                </c:pt>
+                <c:pt idx="11">
+                  <c:v>2019</c:v>
+                </c:pt>
+                <c:pt idx="12">
+                  <c:v>2020</c:v>
+                </c:pt>
+                <c:pt idx="13">
+                  <c:v>2021</c:v>
+                </c:pt>
+                <c:pt idx="14">
+                  <c:v>2022</c:v>
+                </c:pt>
+                <c:pt idx="15">
+                  <c:v>2023</c:v>
+                </c:pt>
+                <c:pt idx="16">
+                  <c:v>2024</c:v>
+                </c:pt>
+                <c:pt idx="17">
+                  <c:v>2025</c:v>
+                </c:pt>
+                <c:pt idx="18">
+                  <c:v>Q2 2026</c:v>
+                </c:pt>
+              </c:strCache>
+            </c:strRef>
+          </c:cat>
+          <c:val>
+            <c:numRef>
+              <c:f>Sheet1!$C$2:$C$20</c:f>
+              <c:numCache>
+                <c:formatCode>General</c:formatCode>
+                <c:ptCount val="19"/>
+                <c:pt idx="0">
+                  <c:v>0.6</c:v>
+                </c:pt>
+                <c:pt idx="1">
+                  <c:v>-0.9</c:v>
+                </c:pt>
+                <c:pt idx="2">
+                  <c:v>1.6</c:v>
+                </c:pt>
+                <c:pt idx="3">
+                  <c:v>1.3</c:v>
+                </c:pt>
+                <c:pt idx="4">
+                  <c:v>2.1</c:v>
+                </c:pt>
+                <c:pt idx="5">
+                  <c:v>2.9</c:v>
+                </c:pt>
+                <c:pt idx="6">
+                  <c:v>2.7</c:v>
+                </c:pt>
+                <c:pt idx="7">
+                  <c:v>0.9</c:v>
+                </c:pt>
+                <c:pt idx="8">
+                  <c:v>2.1</c:v>
+                </c:pt>
+                <c:pt idx="9">
+                  <c:v>3.0</c:v>
+                </c:pt>
+                <c:pt idx="10">
+                  <c:v>3.9</c:v>
+                </c:pt>
+                <c:pt idx="11">
+                  <c:v>3.1</c:v>
+                </c:pt>
+                <c:pt idx="12">
+                  <c:v>3.2</c:v>
+                </c:pt>
+                <c:pt idx="13">
+                  <c:v>3.3</c:v>
+                </c:pt>
+                <c:pt idx="14">
+                  <c:v>7.5</c:v>
+                </c:pt>
+                <c:pt idx="15">
+                  <c:v>10.3</c:v>
+                </c:pt>
+                <c:pt idx="16">
+                  <c:v>9.2</c:v>
+                </c:pt>
+                <c:pt idx="17">
+                  <c:v>5.7</c:v>
+                </c:pt>
+                <c:pt idx="18">
+                  <c:v>1.2</c:v>
+                </c:pt>
+              </c:numCache>
+            </c:numRef>
+          </c:val>
+          <c:smooth val="0"/>
+        </c:ser>
+        <c:ser>
+          <c:idx val="2"/>
+          <c:order val="2"/>
+          <c:tx>
+            <c:strRef>
+              <c:f>Sheet1!$D$1</c:f>
+              <c:strCache>
+                <c:ptCount val="1"/>
+                <c:pt idx="0">
+                  <c:v>Employee benefits</c:v>
+                </c:pt>
+              </c:strCache>
+            </c:strRef>
+          </c:tx>
+          <c:spPr>
+            <a:ln w="50800">
+              <a:solidFill>
+                <a:srgbClr val="8FB24E"/>
+              </a:solidFill>
+            </a:ln>
+          </c:spPr>
+          <c:marker>
+            <c:symbol val="circle"/>
+            <c:size val="7"/>
+            <c:spPr>
+              <a:solidFill>
+                <a:srgbClr val="8FB24E"/>
+              </a:solidFill>
+              <a:ln>
+                <a:solidFill>
+                  <a:srgbClr val="8FB24E"/>
+                </a:solidFill>
+              </a:ln>
+            </c:spPr>
+          </c:marker>
+          <c:dLbls>
+            <c:dLbl>
+              <c:idx val="18"/>
+              <c:tx>
+                <c:rich>
+                  <a:bodyPr/>
+                  <a:lstStyle/>
+                  <a:p>
+                    <a:r>
+                      <a:rPr sz="1300" b="1">
+                        <a:solidFill>
+                          <a:srgbClr val="8FB24E"/>
+                        </a:solidFill>
+                        <a:latin typeface="Source Sans Pro"/>
+                      </a:rPr>
+                      <a:t>6.2%</a:t>
+                    </a:r>
+                  </a:p>
+                </c:rich>
+              </c:tx>
+              <c:dLblPos val="t"/>
+              <c:showLegendKey val="0"/>
+              <c:showVal val="1"/>
+              <c:showCatName val="0"/>
+              <c:showSerName val="0"/>
+              <c:showPercent val="0"/>
+              <c:showBubbleSize val="0"/>
+            </c:dLbl>
+            <c:showLegendKey val="0"/>
+            <c:showVal val="0"/>
+            <c:showCatName val="0"/>
+            <c:showSerName val="0"/>
+            <c:showPercent val="0"/>
+            <c:showBubbleSize val="0"/>
+            <c:showLeaderLines val="1"/>
+          </c:dLbls>
+          <c:cat>
+            <c:strRef>
+              <c:f>Sheet1!$A$2:$A$20</c:f>
+              <c:strCache>
+                <c:ptCount val="19"/>
+                <c:pt idx="0">
+                  <c:v>2008</c:v>
+                </c:pt>
+                <c:pt idx="1">
+                  <c:v>2009</c:v>
+                </c:pt>
+                <c:pt idx="2">
+                  <c:v>2010</c:v>
+                </c:pt>
+                <c:pt idx="3">
+                  <c:v>2011</c:v>
+                </c:pt>
+                <c:pt idx="4">
+                  <c:v>2012</c:v>
+                </c:pt>
+                <c:pt idx="5">
+                  <c:v>2013</c:v>
+                </c:pt>
+                <c:pt idx="6">
+                  <c:v>2014</c:v>
+                </c:pt>
+                <c:pt idx="7">
+                  <c:v>2015</c:v>
+                </c:pt>
+                <c:pt idx="8">
+                  <c:v>2016</c:v>
+                </c:pt>
+                <c:pt idx="9">
+                  <c:v>2017</c:v>
+                </c:pt>
+                <c:pt idx="10">
+                  <c:v>2018</c:v>
+                </c:pt>
+                <c:pt idx="11">
+                  <c:v>2019</c:v>
+                </c:pt>
+                <c:pt idx="12">
+                  <c:v>2020</c:v>
+                </c:pt>
+                <c:pt idx="13">
+                  <c:v>2021</c:v>
+                </c:pt>
+                <c:pt idx="14">
+                  <c:v>2022</c:v>
+                </c:pt>
+                <c:pt idx="15">
+                  <c:v>2023</c:v>
+                </c:pt>
+                <c:pt idx="16">
+                  <c:v>2024</c:v>
+                </c:pt>
+                <c:pt idx="17">
+                  <c:v>2025</c:v>
+                </c:pt>
+                <c:pt idx="18">
+                  <c:v>Q2 2026</c:v>
+                </c:pt>
+              </c:strCache>
+            </c:strRef>
+          </c:cat>
+          <c:val>
+            <c:numRef>
+              <c:f>Sheet1!$D$2:$D$20</c:f>
+              <c:numCache>
+                <c:formatCode>General</c:formatCode>
+                <c:ptCount val="19"/>
+                <c:pt idx="0">
+                  <c:v>10.6</c:v>
+                </c:pt>
+                <c:pt idx="1">
+                  <c:v>4.5</c:v>
+                </c:pt>
+                <c:pt idx="2">
+                  <c:v>4.4</c:v>
+                </c:pt>
+                <c:pt idx="3">
+                  <c:v>7.1</c:v>
+                </c:pt>
+                <c:pt idx="4">
+                  <c:v>4.8</c:v>
+                </c:pt>
+                <c:pt idx="5">
+                  <c:v>5.0</c:v>
+                </c:pt>
+                <c:pt idx="6">
+                  <c:v>5.7</c:v>
+                </c:pt>
+                <c:pt idx="7">
+                  <c:v>5.5</c:v>
+                </c:pt>
+                <c:pt idx="8">
+                  <c:v>6.8</c:v>
+                </c:pt>
+                <c:pt idx="9">
+                  <c:v>5.2</c:v>
+                </c:pt>
+                <c:pt idx="10">
+                  <c:v>7.3</c:v>
+                </c:pt>
+                <c:pt idx="11">
+                  <c:v>5.4</c:v>
+                </c:pt>
+                <c:pt idx="12">
+                  <c:v>3.3</c:v>
+                </c:pt>
+                <c:pt idx="13">
+                  <c:v>4.0</c:v>
+                </c:pt>
+                <c:pt idx="14">
+                  <c:v>6.0</c:v>
+                </c:pt>
+                <c:pt idx="15">
+                  <c:v>6.5</c:v>
+                </c:pt>
+                <c:pt idx="16">
+                  <c:v>7.6</c:v>
+                </c:pt>
+                <c:pt idx="17">
+                  <c:v>5.8</c:v>
+                </c:pt>
+                <c:pt idx="18">
+                  <c:v>6.2</c:v>
+                </c:pt>
+              </c:numCache>
+            </c:numRef>
+          </c:val>
+          <c:smooth val="0"/>
+        </c:ser>
+        <c:marker val="1"/>
+        <c:smooth val="0"/>
+        <c:axId val="2118791784"/>
+        <c:axId val="2140495176"/>
+      </c:lineChart>
+      <c:catAx>
+        <c:axId val="2118791784"/>
+        <c:scaling>
+          <c:orientation val="minMax"/>
+        </c:scaling>
+        <c:delete val="0"/>
+        <c:axPos val="b"/>
+        <c:majorTickMark val="none"/>
+        <c:minorTickMark val="none"/>
+        <c:tickLblPos val="low"/>
+        <c:spPr>
+          <a:ln>
+            <a:solidFill>
+              <a:srgbClr val="BFC7CB"/>
+            </a:solidFill>
+          </a:ln>
+        </c:spPr>
+        <c:txPr>
+          <a:bodyPr/>
+          <a:lstStyle/>
+          <a:p>
+            <a:pPr>
+              <a:defRPr sz="1100">
+                <a:solidFill>
+                  <a:srgbClr val="FFFFFF"/>
+                </a:solidFill>
+              </a:defRPr>
+            </a:pPr>
+          </a:p>
+        </c:txPr>
+        <c:crossAx val="2140495176"/>
+        <c:crosses val="autoZero"/>
+        <c:auto val="1"/>
+        <c:lblAlgn val="ctr"/>
+        <c:lblOffset val="100"/>
+        <c:noMultiLvlLbl val="0"/>
+      </c:catAx>
+      <c:valAx>
+        <c:axId val="2140495176"/>
+        <c:scaling>
+          <c:max val="15.0"/>
+          <c:min val="-5.0"/>
+        </c:scaling>
+        <c:delete val="0"/>
+        <c:axPos val="l"/>
+        <c:majorGridlines>
+          <c:spPr>
+            <a:ln>
+              <a:solidFill>
+                <a:srgbClr val="2B4A5C"/>
+              </a:solidFill>
+            </a:ln>
+          </c:spPr>
+        </c:majorGridlines>
+        <c:numFmt formatCode="0&quot;%&quot;" sourceLinked="0"/>
+        <c:majorTickMark val="out"/>
+        <c:minorTickMark val="none"/>
+        <c:tickLblPos val="nextTo"/>
+        <c:spPr>
+          <a:ln>
+            <a:noFill/>
+          </a:ln>
+        </c:spPr>
+        <c:txPr>
+          <a:bodyPr/>
+          <a:lstStyle/>
+          <a:p>
+            <a:pPr>
+              <a:defRPr sz="1100">
+                <a:solidFill>
+                  <a:srgbClr val="BFC7CB"/>
+                </a:solidFill>
+              </a:defRPr>
+            </a:pPr>
+          </a:p>
+        </c:txPr>
+        <c:crossAx val="2118791784"/>
+        <c:crosses val="autoZero"/>
+        <c:majorUnit val="5.0"/>
+      </c:valAx>
+    </c:plotArea>
+    <c:legend>
+      <c:legendPos val="t"/>
+      <c:layout/>
+      <c:overlay val="0"/>
+      <c:txPr>
+        <a:bodyPr/>
+        <a:lstStyle/>
+        <a:p>
+          <a:pPr>
+            <a:defRPr sz="1200">
+              <a:solidFill>
+                <a:srgbClr val="FFFFFF"/>
+              </a:solidFill>
+            </a:defRPr>
+          </a:pPr>
+        </a:p>
+      </c:txPr>
+    </c:legend>
+    <c:plotVisOnly val="1"/>
+    <c:dispBlanksAs val="gap"/>
+    <c:showDLblsOverMax val="0"/>
+  </c:chart>
+  <c:txPr>
+    <a:bodyPr/>
+    <a:lstStyle/>
+    <a:p>
+      <a:pPr>
+        <a:defRPr sz="1100">
+          <a:solidFill>
+            <a:srgbClr val="FFFFFF"/>
+          </a:solidFill>
+          <a:latin typeface="Source Sans Pro"/>
+        </a:defRPr>
+      </a:pPr>
+      <a:endParaRPr lang="en-US"/>
+    </a:p>
+  </c:txPr>
+  <c:externalData r:id="rId1">
+    <c:autoUpdate val="0"/>
+  </c:externalData>
+</c:chartSpace>
+</file>
+
 <file path=ppt/notesMasters/notesMaster1.xml><?xml version="1.0" encoding="utf-8"?>
 <p:notesMaster xmlns:a="http://schemas.openxmlformats.org/drawingml/2006/main" xmlns:r="http://schemas.openxmlformats.org/officeDocument/2006/relationships" xmlns:p="http://schemas.openxmlformats.org/presentationml/2006/main">
   <p:cSld>
@@ -1084,6 +3186,146 @@
           <a:p>
             <a:r>
               <a:t>What was harder than expected? Building the capacity and structure to keep pace with exceptional growth while continuing to serve our existing clients well. Hiring is one step; getting someone trained, supported, and confident takes more work. Creating a process is one step; getting it consistently used takes more work. Finding a promising technology is one step; making it useful in someone's day takes more work. That work is especially challenging when teams already have full schedules. Retention is another area where we need to keep improving: understand why clients leave, identify patterns, and turn what we learn into changes that stick.</a:t>
+            </a:r>
+          </a:p>
+        </p:txBody>
+      </p:sp>
+      <p:sp>
+        <p:nvSpPr>
+          <p:cNvPr id="4" name="Slide Number Placeholder 3"/>
+          <p:cNvSpPr>
+            <a:spLocks noGrp="1"/>
+          </p:cNvSpPr>
+          <p:nvPr>
+            <p:ph type="sldNum" idx="5" sz="quarter"/>
+          </p:nvPr>
+        </p:nvSpPr>
+        <p:spPr/>
+      </p:sp>
+    </p:spTree>
+  </p:cSld>
+  <p:clrMapOvr>
+    <a:masterClrMapping/>
+  </p:clrMapOvr>
+</p:notes>
+</file>
+
+<file path=ppt/notesSlides/notesSlide7.xml><?xml version="1.0" encoding="utf-8"?>
+<p:notes xmlns:a="http://schemas.openxmlformats.org/drawingml/2006/main" xmlns:p="http://schemas.openxmlformats.org/presentationml/2006/main" xmlns:r="http://schemas.openxmlformats.org/officeDocument/2006/relationships">
+  <p:cSld>
+    <p:spTree>
+      <p:nvGrpSpPr>
+        <p:cNvPr id="1" name=""/>
+        <p:cNvGrpSpPr/>
+        <p:nvPr/>
+      </p:nvGrpSpPr>
+      <p:grpSpPr>
+        <a:xfrm>
+          <a:off x="0" y="0"/>
+          <a:ext cx="0" cy="0"/>
+          <a:chOff x="0" y="0"/>
+          <a:chExt cx="0" cy="0"/>
+        </a:xfrm>
+      </p:grpSpPr>
+      <p:sp>
+        <p:nvSpPr>
+          <p:cNvPr id="2" name="Slide Image Placeholder 1"/>
+          <p:cNvSpPr>
+            <a:spLocks noGrp="1"/>
+          </p:cNvSpPr>
+          <p:nvPr>
+            <p:ph type="sldImg" idx="2"/>
+          </p:nvPr>
+        </p:nvSpPr>
+        <p:spPr/>
+      </p:sp>
+      <p:sp>
+        <p:nvSpPr>
+          <p:cNvPr id="3" name="Notes Placeholder 2"/>
+          <p:cNvSpPr>
+            <a:spLocks noGrp="1"/>
+          </p:cNvSpPr>
+          <p:nvPr>
+            <p:ph type="body" idx="3" sz="quarter"/>
+          </p:nvPr>
+        </p:nvSpPr>
+        <p:spPr/>
+        <p:txBody>
+          <a:bodyPr/>
+          <a:lstStyle/>
+          <a:p>
+            <a:r>
+              <a:t>CIAB P&amp;C rate changes peaked at 8.9% in Q2 2023 and have declined every period since Q1 24 to (2.0%) in Q2 2026. The Marsh US composite moved from 10.0% in Q2 22 to (2.0%) in Q2 26. Source: CIAB, Marsh Global Insurance Market Index.</a:t>
+            </a:r>
+          </a:p>
+        </p:txBody>
+      </p:sp>
+      <p:sp>
+        <p:nvSpPr>
+          <p:cNvPr id="4" name="Slide Number Placeholder 3"/>
+          <p:cNvSpPr>
+            <a:spLocks noGrp="1"/>
+          </p:cNvSpPr>
+          <p:nvPr>
+            <p:ph type="sldNum" idx="5" sz="quarter"/>
+          </p:nvPr>
+        </p:nvSpPr>
+        <p:spPr/>
+      </p:sp>
+    </p:spTree>
+  </p:cSld>
+  <p:clrMapOvr>
+    <a:masterClrMapping/>
+  </p:clrMapOvr>
+</p:notes>
+</file>
+
+<file path=ppt/notesSlides/notesSlide8.xml><?xml version="1.0" encoding="utf-8"?>
+<p:notes xmlns:a="http://schemas.openxmlformats.org/drawingml/2006/main" xmlns:p="http://schemas.openxmlformats.org/presentationml/2006/main" xmlns:r="http://schemas.openxmlformats.org/officeDocument/2006/relationships">
+  <p:cSld>
+    <p:spTree>
+      <p:nvGrpSpPr>
+        <p:cNvPr id="1" name=""/>
+        <p:cNvGrpSpPr/>
+        <p:nvPr/>
+      </p:nvGrpSpPr>
+      <p:grpSpPr>
+        <a:xfrm>
+          <a:off x="0" y="0"/>
+          <a:ext cx="0" cy="0"/>
+          <a:chOff x="0" y="0"/>
+          <a:chExt cx="0" cy="0"/>
+        </a:xfrm>
+      </p:grpSpPr>
+      <p:sp>
+        <p:nvSpPr>
+          <p:cNvPr id="2" name="Slide Image Placeholder 1"/>
+          <p:cNvSpPr>
+            <a:spLocks noGrp="1"/>
+          </p:cNvSpPr>
+          <p:nvPr>
+            <p:ph type="sldImg" idx="2"/>
+          </p:nvPr>
+        </p:nvSpPr>
+        <p:spPr/>
+      </p:sp>
+      <p:sp>
+        <p:nvSpPr>
+          <p:cNvPr id="3" name="Notes Placeholder 2"/>
+          <p:cNvSpPr>
+            <a:spLocks noGrp="1"/>
+          </p:cNvSpPr>
+          <p:nvPr>
+            <p:ph type="body" idx="3" sz="quarter"/>
+          </p:nvPr>
+        </p:nvSpPr>
+        <p:spPr/>
+        <p:txBody>
+          <a:bodyPr/>
+          <a:lstStyle/>
+          <a:p>
+            <a:r>
+              <a:t>Organic growth by line of business. In Q2 2026 Employee Benefits is growing fastest at 6.2%, followed by commercial lines at 4.5% and personal lines at 1.2%. Only the Q2 2026 end points are labeled in the source chart; earlier years are read from the chart and approximate. Source: Reagan GPS results, Q4 except where indicated.</a:t>
             </a:r>
           </a:p>
         </p:txBody>
@@ -9827,6 +12069,558 @@
                 <a:latin typeface="Source Sans Pro"/>
               </a:rPr>
               <a:t>understand why clients leave, identify patterns, and turn what we learn into changes that stick.</a:t>
+            </a:r>
+          </a:p>
+        </p:txBody>
+      </p:sp>
+    </p:spTree>
+    <p:extLst>
+      <p:ext uri="{BB962C8B-B14F-4D97-AF65-F5344CB8AC3E}">
+        <p14:creationId xmlns:p14="http://schemas.microsoft.com/office/powerpoint/2010/main" val="3739547963"/>
+      </p:ext>
+    </p:extLst>
+  </p:cSld>
+  <p:clrMapOvr>
+    <a:masterClrMapping/>
+  </p:clrMapOvr>
+  <mc:AlternateContent xmlns:mc="http://schemas.openxmlformats.org/markup-compatibility/2006" xmlns:p159="http://schemas.microsoft.com/office/powerpoint/2015/09/main">
+    <mc:Choice Requires="p159">
+      <p:transition xmlns:p14="http://schemas.microsoft.com/office/powerpoint/2010/main" spd="slow" p14:dur="2000">
+        <p159:morph option="byObject"/>
+      </p:transition>
+    </mc:Choice>
+    <mc:Fallback xmlns="">
+      <p:transition spd="slow">
+        <p:fade/>
+      </p:transition>
+    </mc:Fallback>
+  </mc:AlternateContent>
+</p:sld>
+</file>
+
+<file path=ppt/slides/slide7.xml><?xml version="1.0" encoding="utf-8"?>
+<p:sld xmlns:a="http://schemas.openxmlformats.org/drawingml/2006/main" xmlns:r="http://schemas.openxmlformats.org/officeDocument/2006/relationships" xmlns:p="http://schemas.openxmlformats.org/presentationml/2006/main">
+  <p:cSld>
+    <p:spTree>
+      <p:nvGrpSpPr>
+        <p:cNvPr id="1" name="">
+          <a:extLst>
+            <a:ext uri="{FF2B5EF4-FFF2-40B4-BE49-F238E27FC236}">
+              <a16:creationId xmlns:a16="http://schemas.microsoft.com/office/drawing/2014/main" id="{3CC0E2FD-837D-9753-CF85-B96BB0ED339A}"/>
+            </a:ext>
+          </a:extLst>
+        </p:cNvPr>
+        <p:cNvGrpSpPr/>
+        <p:nvPr/>
+      </p:nvGrpSpPr>
+      <p:grpSpPr>
+        <a:xfrm>
+          <a:off x="0" y="0"/>
+          <a:ext cx="0" cy="0"/>
+          <a:chOff x="0" y="0"/>
+          <a:chExt cx="0" cy="0"/>
+        </a:xfrm>
+      </p:grpSpPr>
+      <p:sp>
+        <p:nvSpPr>
+          <p:cNvPr id="4" name="TextBox 3">
+            <a:extLst>
+              <a:ext uri="{FF2B5EF4-FFF2-40B4-BE49-F238E27FC236}">
+                <a16:creationId xmlns:a16="http://schemas.microsoft.com/office/drawing/2014/main" id="{D52C6772-D662-5D65-1798-38644B18B7E5}"/>
+              </a:ext>
+            </a:extLst>
+          </p:cNvPr>
+          <p:cNvSpPr txBox="1"/>
+          <p:nvPr/>
+        </p:nvSpPr>
+        <p:spPr>
+          <a:xfrm>
+            <a:off x="875347" y="368336"/>
+            <a:ext cx="10447973" cy="584775"/>
+          </a:xfrm>
+          <a:prstGeom prst="rect">
+            <a:avLst/>
+          </a:prstGeom>
+          <a:noFill/>
+        </p:spPr>
+        <p:txBody>
+          <a:bodyPr wrap="square" rtlCol="0">
+            <a:spAutoFit/>
+          </a:bodyPr>
+          <a:lstStyle/>
+          <a:p>
+            <a:pPr marL="0" marR="0" lvl="0" indent="0" algn="l" defTabSz="914400" rtl="0" eaLnBrk="1" fontAlgn="auto" latinLnBrk="0" hangingPunct="1">
+              <a:lnSpc>
+                <a:spcPct val="100000"/>
+              </a:lnSpc>
+              <a:spcBef>
+                <a:spcPts val="0"/>
+              </a:spcBef>
+              <a:spcAft>
+                <a:spcPts val="0"/>
+              </a:spcAft>
+              <a:buClrTx/>
+              <a:buSzTx/>
+              <a:buFontTx/>
+              <a:buNone/>
+              <a:tabLst/>
+              <a:defRPr/>
+            </a:pPr>
+            <a:r>
+              <a:rPr kumimoji="0" lang="en-US" sz="3200" b="1" i="1" u="none" strike="noStrike" kern="1200" cap="none" spc="0" normalizeH="0" baseline="0" noProof="0" dirty="0">
+                <a:ln>
+                  <a:noFill/>
+                </a:ln>
+                <a:solidFill>
+                  <a:srgbClr val="EDECED"/>
+                </a:solidFill>
+                <a:effectLst/>
+                <a:uLnTx/>
+                <a:uFillTx/>
+                <a:latin typeface="Playfair Display" panose="00000500000000000000" pitchFamily="2" charset="0"/>
+                <a:ea typeface="+mn-ea"/>
+                <a:cs typeface="+mn-cs"/>
+              </a:rPr>
+              <a:t>The P&amp;C rate environment has shifted</a:t>
+            </a:r>
+          </a:p>
+        </p:txBody>
+      </p:sp>
+      <p:cxnSp>
+        <p:nvCxnSpPr>
+          <p:cNvPr id="6" name="Straight Connector 5">
+            <a:extLst>
+              <a:ext uri="{FF2B5EF4-FFF2-40B4-BE49-F238E27FC236}">
+                <a16:creationId xmlns:a16="http://schemas.microsoft.com/office/drawing/2014/main" id="{5E9116D3-F450-4A0A-4B24-450372B6DA92}"/>
+              </a:ext>
+            </a:extLst>
+          </p:cNvPr>
+          <p:cNvCxnSpPr>
+            <a:cxnSpLocks/>
+          </p:cNvCxnSpPr>
+          <p:nvPr/>
+        </p:nvCxnSpPr>
+        <p:spPr>
+          <a:xfrm>
+            <a:off x="963168" y="1060704"/>
+            <a:ext cx="10360152" cy="0"/>
+          </a:xfrm>
+          <a:prstGeom prst="line">
+            <a:avLst/>
+          </a:prstGeom>
+          <a:ln>
+            <a:solidFill>
+              <a:schemeClr val="accent3"/>
+            </a:solidFill>
+          </a:ln>
+        </p:spPr>
+        <p:style>
+          <a:lnRef idx="2">
+            <a:schemeClr val="accent3"/>
+          </a:lnRef>
+          <a:fillRef idx="0">
+            <a:schemeClr val="accent3"/>
+          </a:fillRef>
+          <a:effectRef idx="1">
+            <a:schemeClr val="accent3"/>
+          </a:effectRef>
+          <a:fontRef idx="minor">
+            <a:schemeClr val="tx1"/>
+          </a:fontRef>
+        </p:style>
+      </p:cxnSp>
+      <p:sp>
+        <p:nvSpPr>
+          <p:cNvPr id="7" name="Eyebrow"/>
+          <p:cNvSpPr txBox="1"/>
+          <p:nvPr/>
+        </p:nvSpPr>
+        <p:spPr>
+          <a:xfrm>
+            <a:off x="960120" y="1188720"/>
+            <a:ext cx="10360152" cy="228600"/>
+          </a:xfrm>
+          <a:prstGeom prst="rect">
+            <a:avLst/>
+          </a:prstGeom>
+          <a:noFill/>
+        </p:spPr>
+        <p:txBody>
+          <a:bodyPr wrap="square" lIns="0" rIns="0" tIns="0" bIns="0" anchor="t">
+            <a:spAutoFit/>
+          </a:bodyPr>
+          <a:lstStyle/>
+          <a:p>
+            <a:r>
+              <a:rPr sz="1200" b="1" i="0" spc="200">
+                <a:solidFill>
+                  <a:srgbClr val="8FB24E"/>
+                </a:solidFill>
+                <a:latin typeface="Source Sans Pro"/>
+              </a:rPr>
+              <a:t>MARKET RATES</a:t>
+            </a:r>
+          </a:p>
+        </p:txBody>
+      </p:sp>
+      <p:sp>
+        <p:nvSpPr>
+          <p:cNvPr id="8" name="Subtitle"/>
+          <p:cNvSpPr txBox="1"/>
+          <p:nvPr/>
+        </p:nvSpPr>
+        <p:spPr>
+          <a:xfrm>
+            <a:off x="960120" y="1444752"/>
+            <a:ext cx="10360152" cy="320040"/>
+          </a:xfrm>
+          <a:prstGeom prst="rect">
+            <a:avLst/>
+          </a:prstGeom>
+          <a:noFill/>
+        </p:spPr>
+        <p:txBody>
+          <a:bodyPr wrap="square" lIns="0" rIns="0" tIns="0" bIns="0" anchor="t">
+            <a:spAutoFit/>
+          </a:bodyPr>
+          <a:lstStyle/>
+          <a:p>
+            <a:r>
+              <a:rPr sz="1600" b="0" i="0">
+                <a:solidFill>
+                  <a:srgbClr val="FFFFFF"/>
+                </a:solidFill>
+                <a:latin typeface="Source Sans Pro"/>
+              </a:rPr>
+              <a:t>Both indices have moved from high single digits to negative territory.</a:t>
+            </a:r>
+          </a:p>
+        </p:txBody>
+      </p:sp>
+      <p:graphicFrame>
+        <p:nvGraphicFramePr>
+          <p:cNvPr id="9" name="Rate change chart"/>
+          <p:cNvGraphicFramePr>
+            <a:graphicFrameLocks noGrp="1"/>
+          </p:cNvGraphicFramePr>
+          <p:nvPr/>
+        </p:nvGraphicFramePr>
+        <p:xfrm>
+          <a:off x="960120" y="1874519"/>
+          <a:ext cx="10360152" cy="4023360"/>
+        </p:xfrm>
+        <a:graphic>
+          <a:graphicData uri="http://schemas.openxmlformats.org/drawingml/2006/chart">
+            <c:chart xmlns:c="http://schemas.openxmlformats.org/drawingml/2006/chart" r:id="rId2"/>
+          </a:graphicData>
+        </a:graphic>
+      </p:graphicFrame>
+      <p:sp>
+        <p:nvSpPr>
+          <p:cNvPr id="10" name="Source"/>
+          <p:cNvSpPr txBox="1"/>
+          <p:nvPr/>
+        </p:nvSpPr>
+        <p:spPr>
+          <a:xfrm>
+            <a:off x="960120" y="5943600"/>
+            <a:ext cx="10360152" cy="274320"/>
+          </a:xfrm>
+          <a:prstGeom prst="rect">
+            <a:avLst/>
+          </a:prstGeom>
+          <a:noFill/>
+        </p:spPr>
+        <p:txBody>
+          <a:bodyPr wrap="square" lIns="0" rIns="0" tIns="0" bIns="0" anchor="t">
+            <a:spAutoFit/>
+          </a:bodyPr>
+          <a:lstStyle/>
+          <a:p>
+            <a:r>
+              <a:rPr sz="1000" b="0" i="1">
+                <a:solidFill>
+                  <a:srgbClr val="BFC7CB"/>
+                </a:solidFill>
+                <a:latin typeface="Source Sans Pro"/>
+              </a:rPr>
+              <a:t>Source: CIAB, Marsh Global Insurance Market Index</a:t>
+            </a:r>
+          </a:p>
+        </p:txBody>
+      </p:sp>
+    </p:spTree>
+    <p:extLst>
+      <p:ext uri="{BB962C8B-B14F-4D97-AF65-F5344CB8AC3E}">
+        <p14:creationId xmlns:p14="http://schemas.microsoft.com/office/powerpoint/2010/main" val="3739547963"/>
+      </p:ext>
+    </p:extLst>
+  </p:cSld>
+  <p:clrMapOvr>
+    <a:masterClrMapping/>
+  </p:clrMapOvr>
+  <mc:AlternateContent xmlns:mc="http://schemas.openxmlformats.org/markup-compatibility/2006" xmlns:p159="http://schemas.microsoft.com/office/powerpoint/2015/09/main">
+    <mc:Choice Requires="p159">
+      <p:transition xmlns:p14="http://schemas.microsoft.com/office/powerpoint/2010/main" spd="slow" p14:dur="2000">
+        <p159:morph option="byObject"/>
+      </p:transition>
+    </mc:Choice>
+    <mc:Fallback xmlns="">
+      <p:transition spd="slow">
+        <p:fade/>
+      </p:transition>
+    </mc:Fallback>
+  </mc:AlternateContent>
+</p:sld>
+</file>
+
+<file path=ppt/slides/slide8.xml><?xml version="1.0" encoding="utf-8"?>
+<p:sld xmlns:a="http://schemas.openxmlformats.org/drawingml/2006/main" xmlns:r="http://schemas.openxmlformats.org/officeDocument/2006/relationships" xmlns:p="http://schemas.openxmlformats.org/presentationml/2006/main">
+  <p:cSld>
+    <p:spTree>
+      <p:nvGrpSpPr>
+        <p:cNvPr id="1" name="">
+          <a:extLst>
+            <a:ext uri="{FF2B5EF4-FFF2-40B4-BE49-F238E27FC236}">
+              <a16:creationId xmlns:a16="http://schemas.microsoft.com/office/drawing/2014/main" id="{3CC0E2FD-837D-9753-CF85-B96BB0ED339A}"/>
+            </a:ext>
+          </a:extLst>
+        </p:cNvPr>
+        <p:cNvGrpSpPr/>
+        <p:nvPr/>
+      </p:nvGrpSpPr>
+      <p:grpSpPr>
+        <a:xfrm>
+          <a:off x="0" y="0"/>
+          <a:ext cx="0" cy="0"/>
+          <a:chOff x="0" y="0"/>
+          <a:chExt cx="0" cy="0"/>
+        </a:xfrm>
+      </p:grpSpPr>
+      <p:sp>
+        <p:nvSpPr>
+          <p:cNvPr id="4" name="TextBox 3">
+            <a:extLst>
+              <a:ext uri="{FF2B5EF4-FFF2-40B4-BE49-F238E27FC236}">
+                <a16:creationId xmlns:a16="http://schemas.microsoft.com/office/drawing/2014/main" id="{D52C6772-D662-5D65-1798-38644B18B7E5}"/>
+              </a:ext>
+            </a:extLst>
+          </p:cNvPr>
+          <p:cNvSpPr txBox="1"/>
+          <p:nvPr/>
+        </p:nvSpPr>
+        <p:spPr>
+          <a:xfrm>
+            <a:off x="875347" y="368336"/>
+            <a:ext cx="10447973" cy="584775"/>
+          </a:xfrm>
+          <a:prstGeom prst="rect">
+            <a:avLst/>
+          </a:prstGeom>
+          <a:noFill/>
+        </p:spPr>
+        <p:txBody>
+          <a:bodyPr wrap="square" rtlCol="0">
+            <a:spAutoFit/>
+          </a:bodyPr>
+          <a:lstStyle/>
+          <a:p>
+            <a:pPr marL="0" marR="0" lvl="0" indent="0" algn="l" defTabSz="914400" rtl="0" eaLnBrk="1" fontAlgn="auto" latinLnBrk="0" hangingPunct="1">
+              <a:lnSpc>
+                <a:spcPct val="100000"/>
+              </a:lnSpc>
+              <a:spcBef>
+                <a:spcPts val="0"/>
+              </a:spcBef>
+              <a:spcAft>
+                <a:spcPts val="0"/>
+              </a:spcAft>
+              <a:buClrTx/>
+              <a:buSzTx/>
+              <a:buFontTx/>
+              <a:buNone/>
+              <a:tabLst/>
+              <a:defRPr/>
+            </a:pPr>
+            <a:r>
+              <a:rPr kumimoji="0" lang="en-US" sz="3200" b="1" i="1" u="none" strike="noStrike" kern="1200" cap="none" spc="0" normalizeH="0" baseline="0" noProof="0" dirty="0">
+                <a:ln>
+                  <a:noFill/>
+                </a:ln>
+                <a:solidFill>
+                  <a:srgbClr val="EDECED"/>
+                </a:solidFill>
+                <a:effectLst/>
+                <a:uLnTx/>
+                <a:uFillTx/>
+                <a:latin typeface="Playfair Display" panose="00000500000000000000" pitchFamily="2" charset="0"/>
+                <a:ea typeface="+mn-ea"/>
+                <a:cs typeface="+mn-cs"/>
+              </a:rPr>
+              <a:t>Group benefits now growing fastest</a:t>
+            </a:r>
+          </a:p>
+        </p:txBody>
+      </p:sp>
+      <p:cxnSp>
+        <p:nvCxnSpPr>
+          <p:cNvPr id="6" name="Straight Connector 5">
+            <a:extLst>
+              <a:ext uri="{FF2B5EF4-FFF2-40B4-BE49-F238E27FC236}">
+                <a16:creationId xmlns:a16="http://schemas.microsoft.com/office/drawing/2014/main" id="{5E9116D3-F450-4A0A-4B24-450372B6DA92}"/>
+              </a:ext>
+            </a:extLst>
+          </p:cNvPr>
+          <p:cNvCxnSpPr>
+            <a:cxnSpLocks/>
+          </p:cNvCxnSpPr>
+          <p:nvPr/>
+        </p:nvCxnSpPr>
+        <p:spPr>
+          <a:xfrm>
+            <a:off x="963168" y="1060704"/>
+            <a:ext cx="10360152" cy="0"/>
+          </a:xfrm>
+          <a:prstGeom prst="line">
+            <a:avLst/>
+          </a:prstGeom>
+          <a:ln>
+            <a:solidFill>
+              <a:schemeClr val="accent3"/>
+            </a:solidFill>
+          </a:ln>
+        </p:spPr>
+        <p:style>
+          <a:lnRef idx="2">
+            <a:schemeClr val="accent3"/>
+          </a:lnRef>
+          <a:fillRef idx="0">
+            <a:schemeClr val="accent3"/>
+          </a:fillRef>
+          <a:effectRef idx="1">
+            <a:schemeClr val="accent3"/>
+          </a:effectRef>
+          <a:fontRef idx="minor">
+            <a:schemeClr val="tx1"/>
+          </a:fontRef>
+        </p:style>
+      </p:cxnSp>
+      <p:sp>
+        <p:nvSpPr>
+          <p:cNvPr id="7" name="Eyebrow"/>
+          <p:cNvSpPr txBox="1"/>
+          <p:nvPr/>
+        </p:nvSpPr>
+        <p:spPr>
+          <a:xfrm>
+            <a:off x="960120" y="1188720"/>
+            <a:ext cx="10360152" cy="228600"/>
+          </a:xfrm>
+          <a:prstGeom prst="rect">
+            <a:avLst/>
+          </a:prstGeom>
+          <a:noFill/>
+        </p:spPr>
+        <p:txBody>
+          <a:bodyPr wrap="square" lIns="0" rIns="0" tIns="0" bIns="0" anchor="t">
+            <a:spAutoFit/>
+          </a:bodyPr>
+          <a:lstStyle/>
+          <a:p>
+            <a:r>
+              <a:rPr sz="1200" b="1" i="0" spc="200">
+                <a:solidFill>
+                  <a:srgbClr val="8FB24E"/>
+                </a:solidFill>
+                <a:latin typeface="Source Sans Pro"/>
+              </a:rPr>
+              <a:t>ORGANIC GROWTH BY LINE OF BUSINESS</a:t>
+            </a:r>
+          </a:p>
+        </p:txBody>
+      </p:sp>
+      <p:sp>
+        <p:nvSpPr>
+          <p:cNvPr id="8" name="Subtitle"/>
+          <p:cNvSpPr txBox="1"/>
+          <p:nvPr/>
+        </p:nvSpPr>
+        <p:spPr>
+          <a:xfrm>
+            <a:off x="960120" y="1444752"/>
+            <a:ext cx="10360152" cy="320040"/>
+          </a:xfrm>
+          <a:prstGeom prst="rect">
+            <a:avLst/>
+          </a:prstGeom>
+          <a:noFill/>
+        </p:spPr>
+        <p:txBody>
+          <a:bodyPr wrap="square" lIns="0" rIns="0" tIns="0" bIns="0" anchor="t">
+            <a:spAutoFit/>
+          </a:bodyPr>
+          <a:lstStyle/>
+          <a:p>
+            <a:r>
+              <a:rPr sz="1600" b="0" i="0">
+                <a:solidFill>
+                  <a:srgbClr val="FFFFFF"/>
+                </a:solidFill>
+                <a:latin typeface="Source Sans Pro"/>
+              </a:rPr>
+              <a:t>Employee Benefits leads at 6.2% in Q2 2026, ahead of commercial (4.5%) and personal lines (1.2%).</a:t>
+            </a:r>
+          </a:p>
+        </p:txBody>
+      </p:sp>
+      <p:graphicFrame>
+        <p:nvGraphicFramePr>
+          <p:cNvPr id="9" name="Organic growth chart"/>
+          <p:cNvGraphicFramePr>
+            <a:graphicFrameLocks noGrp="1"/>
+          </p:cNvGraphicFramePr>
+          <p:nvPr/>
+        </p:nvGraphicFramePr>
+        <p:xfrm>
+          <a:off x="960120" y="1874519"/>
+          <a:ext cx="10360152" cy="4023360"/>
+        </p:xfrm>
+        <a:graphic>
+          <a:graphicData uri="http://schemas.openxmlformats.org/drawingml/2006/chart">
+            <c:chart xmlns:c="http://schemas.openxmlformats.org/drawingml/2006/chart" r:id="rId2"/>
+          </a:graphicData>
+        </a:graphic>
+      </p:graphicFrame>
+      <p:sp>
+        <p:nvSpPr>
+          <p:cNvPr id="10" name="Source"/>
+          <p:cNvSpPr txBox="1"/>
+          <p:nvPr/>
+        </p:nvSpPr>
+        <p:spPr>
+          <a:xfrm>
+            <a:off x="960120" y="5943600"/>
+            <a:ext cx="10360152" cy="274320"/>
+          </a:xfrm>
+          <a:prstGeom prst="rect">
+            <a:avLst/>
+          </a:prstGeom>
+          <a:noFill/>
+        </p:spPr>
+        <p:txBody>
+          <a:bodyPr wrap="square" lIns="0" rIns="0" tIns="0" bIns="0" anchor="t">
+            <a:spAutoFit/>
+          </a:bodyPr>
+          <a:lstStyle/>
+          <a:p>
+            <a:r>
+              <a:rPr sz="1000" b="0" i="1">
+                <a:solidFill>
+                  <a:srgbClr val="BFC7CB"/>
+                </a:solidFill>
+                <a:latin typeface="Source Sans Pro"/>
+              </a:rPr>
+              <a:t>Source: Reagan GPS results, Q4 except where indicated. Values before Q2 2026 are read from the source chart and approximate.</a:t>
             </a:r>
           </a:p>
         </p:txBody>

</xml_diff>